<commit_message>
Deck: drop 'for Apromore' from title subtitle
Co-Authored-By: Claude Opus 5.5 <noreply@anthropic.com>
</commit_message>
<xml_diff>
--- a/deck/salesforce-process-intelligence.pptx
+++ b/deck/salesforce-process-intelligence.pptx
@@ -114,26 +114,26 @@
   <p:extLst>
     <p:ext uri="{521415D9-36F7-43E2-AB2F-B90AF26B5E84}">
       <p14:sectionLst xmlns:p14="http://schemas.microsoft.com/office/powerpoint/2010/main">
-        <p14:section name="Opening" id="{265c1982-e116-42ff-b7c0-7eb38206bb40}">
+        <p14:section name="Opening" id="{a4b3c557-0be0-875a-af16-44097121777e}">
           <p14:sldIdLst>
             <p14:sldId id="256"/>
             <p14:sldId id="257"/>
           </p14:sldIdLst>
         </p14:section>
-        <p14:section name="Evidence" id="{b9487968-4089-d078-fd6e-081c9d20f1ee}">
+        <p14:section name="Evidence" id="{1869a031-5bf5-68c7-8c0c-75d62cb4f232}">
           <p14:sldIdLst>
             <p14:sldId id="258"/>
             <p14:sldId id="259"/>
             <p14:sldId id="260"/>
           </p14:sldIdLst>
         </p14:section>
-        <p14:section name="Value" id="{44fde5f1-9f9c-12e1-7191-e2eeed9c23e3}">
+        <p14:section name="Value" id="{c0af868d-a5ac-7acf-f0d4-c9d3b96d5243}">
           <p14:sldIdLst>
             <p14:sldId id="261"/>
             <p14:sldId id="262"/>
           </p14:sldIdLst>
         </p14:section>
-        <p14:section name="Close" id="{a03e89e3-c33c-0394-1be4-17f4daac1a2e}">
+        <p14:section name="Close" id="{98258e1b-94e0-b7f2-5b6c-9004f71b6963}">
           <p14:sldIdLst>
             <p14:sldId id="263"/>
           </p14:sldIdLst>
@@ -2862,7 +2862,7 @@
                   <a:schemeClr val="accent3"/>
                 </a:solidFill>
               </a:rPr>
-              <a:t>Lead-to-close process intelligence: a working demo built for Apromore</a:t>
+              <a:t>Lead-to-close process intelligence: a working demo build</a:t>
             </a:r>
             <a:endParaRPr lang="en-US" sz="2000" dirty="0"/>
           </a:p>

</xml_diff>

<commit_message>
Deck: retitle pipeline slide without Apromore
Co-Authored-By: Claude Opus 5.5 <noreply@anthropic.com>
</commit_message>
<xml_diff>
--- a/deck/salesforce-process-intelligence.pptx
+++ b/deck/salesforce-process-intelligence.pptx
@@ -117,24 +117,24 @@
   <p:extLst>
     <p:ext uri="{521415D9-36F7-43E2-AB2F-B90AF26B5E84}">
       <p14:sectionLst xmlns:p14="http://schemas.microsoft.com/office/powerpoint/2010/main">
-        <p14:section name="Opening" id="{17795403-9396-725d-c414-501f866fd073}">
+        <p14:section name="Opening" id="{e805174c-0229-0f1b-e826-91d80d34e528}">
           <p14:sldIdLst>
             <p14:sldId id="256"/>
             <p14:sldId id="257"/>
           </p14:sldIdLst>
         </p14:section>
-        <p14:section name="Evidence" id="{85fbde82-9cec-8f78-a242-6c9daccd6540}">
+        <p14:section name="Evidence" id="{9ef25b4b-9ee7-d7b3-ef9a-49cf16364c4c}">
           <p14:sldIdLst>
             <p14:sldId id="258"/>
             <p14:sldId id="259"/>
           </p14:sldIdLst>
         </p14:section>
-        <p14:section name="Value" id="{4e8a13c5-3957-4d6a-c99e-4405ca997d95}">
+        <p14:section name="Value" id="{c6365106-2ab8-5c23-76b4-2b329aa871da}">
           <p14:sldIdLst>
             <p14:sldId id="260"/>
           </p14:sldIdLst>
         </p14:section>
-        <p14:section name="Tech setup" id="{3dbcbcab-7b09-ad4a-5235-2ed2a77eab95}">
+        <p14:section name="Tech setup" id="{e50cd908-5653-644e-7159-4db781577120}">
           <p14:sldIdLst>
             <p14:sldId id="261"/>
             <p14:sldId id="262"/>
@@ -143,7 +143,7 @@
             <p14:sldId id="265"/>
           </p14:sldIdLst>
         </p14:section>
-        <p14:section name="Close" id="{e0829fee-14ba-deb4-2c72-d7f9c20bbb32}">
+        <p14:section name="Close" id="{98250bfe-6674-2e8d-5467-4f149f44f630}">
           <p14:sldIdLst>
             <p14:sldId id="266"/>
           </p14:sldIdLst>
@@ -7713,7 +7713,7 @@
                   <a:schemeClr val="tx2"/>
                 </a:solidFill>
               </a:rPr>
-              <a:t>Salesforce to Apromore in four steps</a:t>
+              <a:t>From Salesforce to an event log in four steps</a:t>
             </a:r>
             <a:endParaRPr lang="en-US" sz="3000" dirty="0"/>
           </a:p>

</xml_diff>

<commit_message>
Deck: retitle pipeline slide to Process Intelligence
Co-Authored-By: Claude Opus 5.5 <noreply@anthropic.com>
</commit_message>
<xml_diff>
--- a/deck/salesforce-process-intelligence.pptx
+++ b/deck/salesforce-process-intelligence.pptx
@@ -117,24 +117,24 @@
   <p:extLst>
     <p:ext uri="{521415D9-36F7-43E2-AB2F-B90AF26B5E84}">
       <p14:sectionLst xmlns:p14="http://schemas.microsoft.com/office/powerpoint/2010/main">
-        <p14:section name="Opening" id="{e805174c-0229-0f1b-e826-91d80d34e528}">
+        <p14:section name="Opening" id="{a7c3dd03-6d0e-8dd6-8c09-7ed018a74820}">
           <p14:sldIdLst>
             <p14:sldId id="256"/>
             <p14:sldId id="257"/>
           </p14:sldIdLst>
         </p14:section>
-        <p14:section name="Evidence" id="{9ef25b4b-9ee7-d7b3-ef9a-49cf16364c4c}">
+        <p14:section name="Evidence" id="{276d2888-9cc2-7be6-21f5-2af5d535dc77}">
           <p14:sldIdLst>
             <p14:sldId id="258"/>
             <p14:sldId id="259"/>
           </p14:sldIdLst>
         </p14:section>
-        <p14:section name="Value" id="{c6365106-2ab8-5c23-76b4-2b329aa871da}">
+        <p14:section name="Value" id="{4edf3d9e-2f83-3f93-eb13-3fdb082ff20c}">
           <p14:sldIdLst>
             <p14:sldId id="260"/>
           </p14:sldIdLst>
         </p14:section>
-        <p14:section name="Tech setup" id="{e50cd908-5653-644e-7159-4db781577120}">
+        <p14:section name="Tech setup" id="{ae01f3ea-67c4-6dfe-349f-8da434d6687f}">
           <p14:sldIdLst>
             <p14:sldId id="261"/>
             <p14:sldId id="262"/>
@@ -143,7 +143,7 @@
             <p14:sldId id="265"/>
           </p14:sldIdLst>
         </p14:section>
-        <p14:section name="Close" id="{98250bfe-6674-2e8d-5467-4f149f44f630}">
+        <p14:section name="Close" id="{4091b444-0ca7-1f79-d4d2-2cee50fe67b4}">
           <p14:sldIdLst>
             <p14:sldId id="266"/>
           </p14:sldIdLst>
@@ -7713,7 +7713,7 @@
                   <a:schemeClr val="tx2"/>
                 </a:solidFill>
               </a:rPr>
-              <a:t>From Salesforce to an event log in four steps</a:t>
+              <a:t>From Salesforce to Process Intelligence in four steps</a:t>
             </a:r>
             <a:endParaRPr lang="en-US" sz="3000" dirty="0"/>
           </a:p>

</xml_diff>

<commit_message>
Deck: add evidence screenshots from the Salesforce org
Accounts and opportunities lists, one deal's stage history showing the
re-quote loop, and the Connected Apps OAuth Usage fix.

Co-Authored-By: Claude Opus 5.5 <noreply@anthropic.com>
</commit_message>
<xml_diff>
--- a/deck/salesforce-process-intelligence.pptx
+++ b/deck/salesforce-process-intelligence.pptx
@@ -16,9 +16,11 @@
     <p:sldId id="264" r:id="rId10"/>
     <p:sldId id="265" r:id="rId11"/>
     <p:sldId id="266" r:id="rId12"/>
+    <p:sldId id="267" r:id="rId13"/>
+    <p:sldId id="268" r:id="rId14"/>
   </p:sldIdLst>
   <p:notesMasterIdLst>
-    <p:notesMasterId r:id="rId13"/>
+    <p:notesMasterId r:id="rId15"/>
   </p:notesMasterIdLst>
   <p:sldSz cx="12192000" cy="6858000"/>
   <p:notesSz cx="6858000" cy="12192000"/>
@@ -117,35 +119,37 @@
   <p:extLst>
     <p:ext uri="{521415D9-36F7-43E2-AB2F-B90AF26B5E84}">
       <p14:sectionLst xmlns:p14="http://schemas.microsoft.com/office/powerpoint/2010/main">
-        <p14:section name="Opening" id="{6c6590f9-e8a5-5243-748b-3cf507d1915d}">
+        <p14:section name="Opening" id="{9606f73f-5352-0c8a-1b6f-cbb2013955f7}">
           <p14:sldIdLst>
             <p14:sldId id="256"/>
             <p14:sldId id="257"/>
           </p14:sldIdLst>
         </p14:section>
-        <p14:section name="Evidence" id="{198eac98-c4a5-d914-07c7-d118c680445a}">
+        <p14:section name="Evidence" id="{8cf8c4fc-a79b-9a67-e68f-69c85841a29d}">
           <p14:sldIdLst>
             <p14:sldId id="258"/>
             <p14:sldId id="259"/>
           </p14:sldIdLst>
         </p14:section>
-        <p14:section name="Value" id="{ce1b0900-b3d0-c401-65e7-95ebc29c5c24}">
+        <p14:section name="Value" id="{0be3f633-c937-c010-eacf-ec605e49bbc5}">
           <p14:sldIdLst>
             <p14:sldId id="260"/>
             <p14:sldId id="261"/>
           </p14:sldIdLst>
         </p14:section>
-        <p14:section name="Close" id="{a089c8f5-d164-c9be-a68b-f82a152f2c23}">
+        <p14:section name="Close" id="{719c482f-b896-b042-f53d-40a1b96093d9}">
           <p14:sldIdLst>
             <p14:sldId id="262"/>
           </p14:sldIdLst>
         </p14:section>
-        <p14:section name="Tech setup" id="{e10e8d4c-9f91-41b2-bf2e-dfd7241242a9}">
+        <p14:section name="Tech setup" id="{fee289be-66a8-9486-f37d-5bb09447e84f}">
           <p14:sldIdLst>
             <p14:sldId id="263"/>
             <p14:sldId id="264"/>
             <p14:sldId id="265"/>
             <p14:sldId id="266"/>
+            <p14:sldId id="267"/>
+            <p14:sldId id="268"/>
           </p14:sldIdLst>
         </p14:section>
       </p14:sectionLst>
@@ -1597,6 +1601,182 @@
             <a:fld id="{F7021451-1387-4CA6-816F-3879F97B5CBC}" type="slidenum">
               <a:rPr lang="en-US"/>
               <a:t>11</a:t>
+            </a:fld>
+            <a:endParaRPr lang="en-US"/>
+          </a:p>
+        </p:txBody>
+      </p:sp>
+    </p:spTree>
+    <p:extLst>
+      <p:ext uri="{BB962C8B-B14F-4D97-AF65-F5344CB8AC3E}">
+        <p14:creationId xmlns:p14="http://schemas.microsoft.com/office/powerpoint/2010/main" val="1024086991"/>
+      </p:ext>
+    </p:extLst>
+  </p:cSld>
+  <p:clrMapOvr>
+    <a:masterClrMapping/>
+  </p:clrMapOvr>
+</p:notes>
+</file>
+
+<file path=ppt/notesSlides/notesSlide12.xml><?xml version="1.0" encoding="utf-8"?>
+<p:notes xmlns:a="http://schemas.openxmlformats.org/drawingml/2006/main" xmlns:r="http://schemas.openxmlformats.org/officeDocument/2006/relationships" xmlns:p="http://schemas.openxmlformats.org/presentationml/2006/main">
+  <p:cSld>
+    <p:spTree>
+      <p:nvGrpSpPr>
+        <p:cNvPr id="1" name=""/>
+        <p:cNvGrpSpPr/>
+        <p:nvPr/>
+      </p:nvGrpSpPr>
+      <p:grpSpPr>
+        <a:xfrm>
+          <a:off x="0" y="0"/>
+          <a:ext cx="0" cy="0"/>
+          <a:chOff x="0" y="0"/>
+          <a:chExt cx="0" cy="0"/>
+        </a:xfrm>
+      </p:grpSpPr>
+      <p:sp>
+        <p:nvSpPr>
+          <p:cNvPr id="2" name="Slide Image Placeholder 1"/>
+          <p:cNvSpPr>
+            <a:spLocks noGrp="1" noRot="1" noChangeAspect="1"/>
+          </p:cNvSpPr>
+          <p:nvPr>
+            <p:ph type="sldImg"/>
+          </p:nvPr>
+        </p:nvSpPr>
+        <p:spPr/>
+      </p:sp>
+      <p:sp>
+        <p:nvSpPr>
+          <p:cNvPr id="3" name="Notes Placeholder 2"/>
+          <p:cNvSpPr>
+            <a:spLocks noGrp="1"/>
+          </p:cNvSpPr>
+          <p:nvPr>
+            <p:ph type="body" idx="1"/>
+          </p:nvPr>
+        </p:nvSpPr>
+        <p:spPr/>
+        <p:txBody>
+          <a:bodyPr/>
+          <a:lstStyle/>
+          <a:p>
+            <a:r>
+              <a:rPr lang="en-US" dirty="0"/>
+              <a:t>Screenshots from the trial org. Every record is tagged [Demo] and can be removed with seed.py --cleanup.</a:t>
+            </a:r>
+            <a:endParaRPr lang="en-US" dirty="0"/>
+          </a:p>
+        </p:txBody>
+      </p:sp>
+      <p:sp>
+        <p:nvSpPr>
+          <p:cNvPr id="4" name="Slide Number Placeholder 3"/>
+          <p:cNvSpPr>
+            <a:spLocks noGrp="1"/>
+          </p:cNvSpPr>
+          <p:nvPr>
+            <p:ph type="sldNum" sz="quarter" idx="10"/>
+          </p:nvPr>
+        </p:nvSpPr>
+        <p:spPr/>
+        <p:txBody>
+          <a:bodyPr/>
+          <a:lstStyle/>
+          <a:p>
+            <a:fld id="{F7021451-1387-4CA6-816F-3879F97B5CBC}" type="slidenum">
+              <a:rPr lang="en-US"/>
+              <a:t>12</a:t>
+            </a:fld>
+            <a:endParaRPr lang="en-US"/>
+          </a:p>
+        </p:txBody>
+      </p:sp>
+    </p:spTree>
+    <p:extLst>
+      <p:ext uri="{BB962C8B-B14F-4D97-AF65-F5344CB8AC3E}">
+        <p14:creationId xmlns:p14="http://schemas.microsoft.com/office/powerpoint/2010/main" val="1024086991"/>
+      </p:ext>
+    </p:extLst>
+  </p:cSld>
+  <p:clrMapOvr>
+    <a:masterClrMapping/>
+  </p:clrMapOvr>
+</p:notes>
+</file>
+
+<file path=ppt/notesSlides/notesSlide13.xml><?xml version="1.0" encoding="utf-8"?>
+<p:notes xmlns:a="http://schemas.openxmlformats.org/drawingml/2006/main" xmlns:r="http://schemas.openxmlformats.org/officeDocument/2006/relationships" xmlns:p="http://schemas.openxmlformats.org/presentationml/2006/main">
+  <p:cSld>
+    <p:spTree>
+      <p:nvGrpSpPr>
+        <p:cNvPr id="1" name=""/>
+        <p:cNvGrpSpPr/>
+        <p:nvPr/>
+      </p:nvGrpSpPr>
+      <p:grpSpPr>
+        <a:xfrm>
+          <a:off x="0" y="0"/>
+          <a:ext cx="0" cy="0"/>
+          <a:chOff x="0" y="0"/>
+          <a:chExt cx="0" cy="0"/>
+        </a:xfrm>
+      </p:grpSpPr>
+      <p:sp>
+        <p:nvSpPr>
+          <p:cNvPr id="2" name="Slide Image Placeholder 1"/>
+          <p:cNvSpPr>
+            <a:spLocks noGrp="1" noRot="1" noChangeAspect="1"/>
+          </p:cNvSpPr>
+          <p:nvPr>
+            <p:ph type="sldImg"/>
+          </p:nvPr>
+        </p:nvSpPr>
+        <p:spPr/>
+      </p:sp>
+      <p:sp>
+        <p:nvSpPr>
+          <p:cNvPr id="3" name="Notes Placeholder 2"/>
+          <p:cNvSpPr>
+            <a:spLocks noGrp="1"/>
+          </p:cNvSpPr>
+          <p:nvPr>
+            <p:ph type="body" idx="1"/>
+          </p:nvPr>
+        </p:nvSpPr>
+        <p:spPr/>
+        <p:txBody>
+          <a:bodyPr/>
+          <a:lstStyle/>
+          <a:p>
+            <a:r>
+              <a:rPr lang="en-US" dirty="0"/>
+              <a:t>The stage history is the raw material for the event log: each row becomes an event. The setup screen is the one-click fix for new orgs that block uninstalled connected apps.</a:t>
+            </a:r>
+            <a:endParaRPr lang="en-US" dirty="0"/>
+          </a:p>
+        </p:txBody>
+      </p:sp>
+      <p:sp>
+        <p:nvSpPr>
+          <p:cNvPr id="4" name="Slide Number Placeholder 3"/>
+          <p:cNvSpPr>
+            <a:spLocks noGrp="1"/>
+          </p:cNvSpPr>
+          <p:nvPr>
+            <p:ph type="sldNum" sz="quarter" idx="10"/>
+          </p:nvPr>
+        </p:nvSpPr>
+        <p:spPr/>
+        <p:txBody>
+          <a:bodyPr/>
+          <a:lstStyle/>
+          <a:p>
+            <a:fld id="{F7021451-1387-4CA6-816F-3879F97B5CBC}" type="slidenum">
+              <a:rPr lang="en-US"/>
+              <a:t>13</a:t>
             </a:fld>
             <a:endParaRPr lang="en-US"/>
           </a:p>
@@ -5574,6 +5754,562 @@
 </p:sld>
 </file>
 
+<file path=ppt/slides/slide12.xml><?xml version="1.0" encoding="utf-8"?>
+<p:sld xmlns:a="http://schemas.openxmlformats.org/drawingml/2006/main" xmlns:r="http://schemas.openxmlformats.org/officeDocument/2006/relationships" xmlns:p="http://schemas.openxmlformats.org/presentationml/2006/main">
+  <p:cSld name="Slide 12">
+    <p:spTree>
+      <p:nvGrpSpPr>
+        <p:cNvPr id="1" name=""/>
+        <p:cNvGrpSpPr/>
+        <p:nvPr/>
+      </p:nvGrpSpPr>
+      <p:grpSpPr>
+        <a:xfrm>
+          <a:off x="0" y="0"/>
+          <a:ext cx="0" cy="0"/>
+          <a:chOff x="0" y="0"/>
+          <a:chExt cx="0" cy="0"/>
+        </a:xfrm>
+      </p:grpSpPr>
+      <p:sp>
+        <p:nvSpPr>
+          <p:cNvPr id="2" name="Text 0"/>
+          <p:cNvSpPr/>
+          <p:nvPr>
+            <p:ph idx="100" type="title" hasCustomPrompt="1"/>
+          </p:nvPr>
+        </p:nvSpPr>
+        <p:spPr>
+          <a:xfrm>
+            <a:off x="548640" y="320040"/>
+            <a:ext cx="11064240" cy="822960"/>
+          </a:xfrm>
+          <a:prstGeom prst="rect">
+            <a:avLst/>
+          </a:prstGeom>
+          <a:noFill/>
+          <a:ln/>
+        </p:spPr>
+        <p:txBody>
+          <a:bodyPr wrap="square" lIns="0" tIns="0" rIns="0" bIns="0" rtlCol="0" anchor="ctr"/>
+          <a:lstStyle/>
+          <a:p>
+            <a:pPr algn="l" indent="0" marL="0">
+              <a:buNone/>
+            </a:pPr>
+            <a:r>
+              <a:rPr lang="en-US" sz="3000" b="1" dirty="0">
+                <a:solidFill>
+                  <a:schemeClr val="tx2"/>
+                </a:solidFill>
+              </a:rPr>
+              <a:t>Evidence: the seeded deals live in Salesforce</a:t>
+            </a:r>
+            <a:endParaRPr lang="en-US" sz="3000" dirty="0"/>
+          </a:p>
+        </p:txBody>
+      </p:sp>
+      <p:sp>
+        <p:nvSpPr>
+          <p:cNvPr id="3" name="Accounts list frame"/>
+          <p:cNvSpPr/>
+          <p:nvPr/>
+        </p:nvSpPr>
+        <p:spPr>
+          <a:xfrm>
+            <a:off x="512064" y="1335024"/>
+            <a:ext cx="5786737" cy="3410712"/>
+          </a:xfrm>
+          <a:prstGeom prst="rect">
+            <a:avLst/>
+          </a:prstGeom>
+          <a:solidFill>
+            <a:schemeClr val="bg1"/>
+          </a:solidFill>
+          <a:ln w="12700">
+            <a:solidFill>
+              <a:schemeClr val="accent3"/>
+            </a:solidFill>
+            <a:prstDash val="solid"/>
+          </a:ln>
+        </p:spPr>
+      </p:sp>
+      <p:pic>
+        <p:nvPicPr>
+          <p:cNvPr id="4" name="Accounts list" descr="40 [Demo] accounts created through the Composite API, each with an industry and country.">    </p:cNvPr>
+          <p:cNvPicPr>
+            <a:picLocks noChangeAspect="1"/>
+          </p:cNvPicPr>
+          <p:nvPr/>
+        </p:nvPicPr>
+        <p:blipFill>
+          <a:blip r:embed="rId1"/>
+          <a:stretch>
+            <a:fillRect/>
+          </a:stretch>
+        </p:blipFill>
+        <p:spPr>
+          <a:xfrm>
+            <a:off x="548640" y="1371600"/>
+            <a:ext cx="5713585" cy="3337560"/>
+          </a:xfrm>
+          <a:prstGeom prst="rect">
+            <a:avLst/>
+          </a:prstGeom>
+        </p:spPr>
+      </p:pic>
+      <p:sp>
+        <p:nvSpPr>
+          <p:cNvPr id="5" name="Accounts list caption"/>
+          <p:cNvSpPr txBox="1"/>
+          <p:nvPr/>
+        </p:nvSpPr>
+        <p:spPr>
+          <a:xfrm>
+            <a:off x="548640" y="4892040"/>
+            <a:ext cx="5713585" cy="685800"/>
+          </a:xfrm>
+          <a:prstGeom prst="rect">
+            <a:avLst/>
+          </a:prstGeom>
+          <a:noFill/>
+          <a:ln/>
+        </p:spPr>
+        <p:txBody>
+          <a:bodyPr wrap="square" lIns="0" tIns="0" rIns="0" bIns="0" rtlCol="0" anchor="t"/>
+          <a:lstStyle/>
+          <a:p>
+            <a:pPr indent="0" marL="0">
+              <a:buNone/>
+            </a:pPr>
+            <a:r>
+              <a:rPr lang="en-US" sz="1400" dirty="0">
+                <a:solidFill>
+                  <a:schemeClr val="tx2"/>
+                </a:solidFill>
+              </a:rPr>
+              <a:t>40 [Demo] accounts created through the Composite API, each with an industry and country.</a:t>
+            </a:r>
+            <a:endParaRPr lang="en-US" sz="1400" dirty="0"/>
+          </a:p>
+        </p:txBody>
+      </p:sp>
+      <p:sp>
+        <p:nvSpPr>
+          <p:cNvPr id="6" name="Opportunities list frame"/>
+          <p:cNvSpPr/>
+          <p:nvPr/>
+        </p:nvSpPr>
+        <p:spPr>
+          <a:xfrm>
+            <a:off x="6499969" y="1335024"/>
+            <a:ext cx="5036066" cy="3410712"/>
+          </a:xfrm>
+          <a:prstGeom prst="rect">
+            <a:avLst/>
+          </a:prstGeom>
+          <a:solidFill>
+            <a:schemeClr val="bg1"/>
+          </a:solidFill>
+          <a:ln w="12700">
+            <a:solidFill>
+              <a:schemeClr val="accent3"/>
+            </a:solidFill>
+            <a:prstDash val="solid"/>
+          </a:ln>
+        </p:spPr>
+      </p:sp>
+      <p:pic>
+        <p:nvPicPr>
+          <p:cNvPr id="7" name="Opportunities list" descr="40 opportunities walked through the org's own sales stages.">    </p:cNvPr>
+          <p:cNvPicPr>
+            <a:picLocks noChangeAspect="1"/>
+          </p:cNvPicPr>
+          <p:nvPr/>
+        </p:nvPicPr>
+        <p:blipFill>
+          <a:blip r:embed="rId2"/>
+          <a:stretch>
+            <a:fillRect/>
+          </a:stretch>
+        </p:blipFill>
+        <p:spPr>
+          <a:xfrm>
+            <a:off x="6536545" y="1371600"/>
+            <a:ext cx="4962914" cy="3337560"/>
+          </a:xfrm>
+          <a:prstGeom prst="rect">
+            <a:avLst/>
+          </a:prstGeom>
+        </p:spPr>
+      </p:pic>
+      <p:sp>
+        <p:nvSpPr>
+          <p:cNvPr id="8" name="Opportunities list caption"/>
+          <p:cNvSpPr txBox="1"/>
+          <p:nvPr/>
+        </p:nvSpPr>
+        <p:spPr>
+          <a:xfrm>
+            <a:off x="6536545" y="4892040"/>
+            <a:ext cx="4962914" cy="685800"/>
+          </a:xfrm>
+          <a:prstGeom prst="rect">
+            <a:avLst/>
+          </a:prstGeom>
+          <a:noFill/>
+          <a:ln/>
+        </p:spPr>
+        <p:txBody>
+          <a:bodyPr wrap="square" lIns="0" tIns="0" rIns="0" bIns="0" rtlCol="0" anchor="t"/>
+          <a:lstStyle/>
+          <a:p>
+            <a:pPr indent="0" marL="0">
+              <a:buNone/>
+            </a:pPr>
+            <a:r>
+              <a:rPr lang="en-US" sz="1400" dirty="0">
+                <a:solidFill>
+                  <a:schemeClr val="tx2"/>
+                </a:solidFill>
+              </a:rPr>
+              <a:t>40 opportunities walked through the org's own sales stages.</a:t>
+            </a:r>
+            <a:endParaRPr lang="en-US" sz="1400" dirty="0"/>
+          </a:p>
+        </p:txBody>
+      </p:sp>
+      <p:sp>
+        <p:nvSpPr>
+          <p:cNvPr id="25" name="Slide Number Placeholder 0"/>
+          <p:cNvSpPr>
+            <a:spLocks noGrp="1"/>
+          </p:cNvSpPr>
+          <p:nvPr>
+            <p:ph type="sldNum" sz="quarter" idx="4294967295"/>
+          </p:nvPr>
+        </p:nvSpPr>
+        <p:spPr>
+          <a:xfrm>
+            <a:off x="11155680" y="6400800"/>
+            <a:ext cx="457200" cy="274320"/>
+          </a:xfrm>
+          <a:prstGeom prst="rect">
+            <a:avLst/>
+          </a:prstGeom>
+          <a:extLst>
+            <a:ext uri="{C572A759-6A51-4108-AA02-DFA0A04FC94B}">
+              <ma14:wrappingTextBoxFlag xmlns:ma14="http://schemas.microsoft.com/office/mac/drawingml/2011/main" val="0"/>
+            </a:ext>
+          </a:extLst>
+        </p:spPr>
+        <p:txBody>
+          <a:bodyPr/>
+          <a:lstStyle>
+            <a:lvl1pPr>
+              <a:defRPr sz="1000">
+                <a:solidFill>
+                  <a:schemeClr val="accent6"/>
+                </a:solidFill>
+              </a:defRPr>
+            </a:lvl1pPr>
+          </a:lstStyle>
+          <a:p>
+            <a:pPr algn="r"/>
+            <a:fld id="{F7021451-1387-4CA6-816F-3879F97B5CBC}" type="slidenum">
+              <a:rPr b="0" lang="en-US"/>
+              <a:t>12</a:t>
+            </a:fld>
+            <a:endParaRPr lang="en-US"/>
+          </a:p>
+        </p:txBody>
+      </p:sp>
+    </p:spTree>
+  </p:cSld>
+  <p:clrMapOvr>
+    <a:masterClrMapping/>
+  </p:clrMapOvr>
+</p:sld>
+</file>
+
+<file path=ppt/slides/slide13.xml><?xml version="1.0" encoding="utf-8"?>
+<p:sld xmlns:a="http://schemas.openxmlformats.org/drawingml/2006/main" xmlns:r="http://schemas.openxmlformats.org/officeDocument/2006/relationships" xmlns:p="http://schemas.openxmlformats.org/presentationml/2006/main">
+  <p:cSld name="Slide 13">
+    <p:spTree>
+      <p:nvGrpSpPr>
+        <p:cNvPr id="1" name=""/>
+        <p:cNvGrpSpPr/>
+        <p:nvPr/>
+      </p:nvGrpSpPr>
+      <p:grpSpPr>
+        <a:xfrm>
+          <a:off x="0" y="0"/>
+          <a:ext cx="0" cy="0"/>
+          <a:chOff x="0" y="0"/>
+          <a:chExt cx="0" cy="0"/>
+        </a:xfrm>
+      </p:grpSpPr>
+      <p:sp>
+        <p:nvSpPr>
+          <p:cNvPr id="2" name="Text 0"/>
+          <p:cNvSpPr/>
+          <p:nvPr>
+            <p:ph idx="100" type="title" hasCustomPrompt="1"/>
+          </p:nvPr>
+        </p:nvSpPr>
+        <p:spPr>
+          <a:xfrm>
+            <a:off x="548640" y="320040"/>
+            <a:ext cx="11064240" cy="822960"/>
+          </a:xfrm>
+          <a:prstGeom prst="rect">
+            <a:avLst/>
+          </a:prstGeom>
+          <a:noFill/>
+          <a:ln/>
+        </p:spPr>
+        <p:txBody>
+          <a:bodyPr wrap="square" lIns="0" tIns="0" rIns="0" bIns="0" rtlCol="0" anchor="ctr"/>
+          <a:lstStyle/>
+          <a:p>
+            <a:pPr algn="l" indent="0" marL="0">
+              <a:buNone/>
+            </a:pPr>
+            <a:r>
+              <a:rPr lang="en-US" sz="3000" b="1" dirty="0">
+                <a:solidFill>
+                  <a:schemeClr val="tx2"/>
+                </a:solidFill>
+              </a:rPr>
+              <a:t>Evidence: what the extract reads</a:t>
+            </a:r>
+            <a:endParaRPr lang="en-US" sz="3000" dirty="0"/>
+          </a:p>
+        </p:txBody>
+      </p:sp>
+      <p:sp>
+        <p:nvSpPr>
+          <p:cNvPr id="3" name="Stage history frame"/>
+          <p:cNvSpPr/>
+          <p:nvPr/>
+        </p:nvSpPr>
+        <p:spPr>
+          <a:xfrm>
+            <a:off x="512064" y="1335024"/>
+            <a:ext cx="5898118" cy="3182112"/>
+          </a:xfrm>
+          <a:prstGeom prst="rect">
+            <a:avLst/>
+          </a:prstGeom>
+          <a:solidFill>
+            <a:schemeClr val="bg1"/>
+          </a:solidFill>
+          <a:ln w="12700">
+            <a:solidFill>
+              <a:schemeClr val="accent3"/>
+            </a:solidFill>
+            <a:prstDash val="solid"/>
+          </a:ln>
+        </p:spPr>
+      </p:sp>
+      <p:pic>
+        <p:nvPicPr>
+          <p:cNvPr id="4" name="Stage history" descr="OpportunityHistory for one deal: Propose → Negotiate twice before Closed Won. This is the re-quote loop the dashboard measures.">    </p:cNvPr>
+          <p:cNvPicPr>
+            <a:picLocks noChangeAspect="1"/>
+          </p:cNvPicPr>
+          <p:nvPr/>
+        </p:nvPicPr>
+        <p:blipFill>
+          <a:blip r:embed="rId1"/>
+          <a:stretch>
+            <a:fillRect/>
+          </a:stretch>
+        </p:blipFill>
+        <p:spPr>
+          <a:xfrm>
+            <a:off x="548640" y="1371600"/>
+            <a:ext cx="5824966" cy="3108960"/>
+          </a:xfrm>
+          <a:prstGeom prst="rect">
+            <a:avLst/>
+          </a:prstGeom>
+        </p:spPr>
+      </p:pic>
+      <p:sp>
+        <p:nvSpPr>
+          <p:cNvPr id="5" name="Stage history caption"/>
+          <p:cNvSpPr txBox="1"/>
+          <p:nvPr/>
+        </p:nvSpPr>
+        <p:spPr>
+          <a:xfrm>
+            <a:off x="548640" y="4663440"/>
+            <a:ext cx="5824966" cy="685800"/>
+          </a:xfrm>
+          <a:prstGeom prst="rect">
+            <a:avLst/>
+          </a:prstGeom>
+          <a:noFill/>
+          <a:ln/>
+        </p:spPr>
+        <p:txBody>
+          <a:bodyPr wrap="square" lIns="0" tIns="0" rIns="0" bIns="0" rtlCol="0" anchor="t"/>
+          <a:lstStyle/>
+          <a:p>
+            <a:pPr indent="0" marL="0">
+              <a:buNone/>
+            </a:pPr>
+            <a:r>
+              <a:rPr lang="en-US" sz="1400" dirty="0">
+                <a:solidFill>
+                  <a:schemeClr val="tx2"/>
+                </a:solidFill>
+              </a:rPr>
+              <a:t>OpportunityHistory for one deal: Propose → Negotiate twice before Closed Won. This is the re-quote loop the dashboard measures.</a:t>
+            </a:r>
+            <a:endParaRPr lang="en-US" sz="1400" dirty="0"/>
+          </a:p>
+        </p:txBody>
+      </p:sp>
+      <p:sp>
+        <p:nvSpPr>
+          <p:cNvPr id="6" name="Connected apps frame"/>
+          <p:cNvSpPr/>
+          <p:nvPr/>
+        </p:nvSpPr>
+        <p:spPr>
+          <a:xfrm>
+            <a:off x="6611350" y="1335024"/>
+            <a:ext cx="4722713" cy="3182112"/>
+          </a:xfrm>
+          <a:prstGeom prst="rect">
+            <a:avLst/>
+          </a:prstGeom>
+          <a:solidFill>
+            <a:schemeClr val="bg1"/>
+          </a:solidFill>
+          <a:ln w="12700">
+            <a:solidFill>
+              <a:schemeClr val="accent3"/>
+            </a:solidFill>
+            <a:prstDash val="solid"/>
+          </a:ln>
+        </p:spPr>
+      </p:sp>
+      <p:pic>
+        <p:nvPicPr>
+          <p:cNvPr id="7" name="Connected apps" descr="Setup: Salesforce CLI installed and allowed, which unblocked API access on the new org.">    </p:cNvPr>
+          <p:cNvPicPr>
+            <a:picLocks noChangeAspect="1"/>
+          </p:cNvPicPr>
+          <p:nvPr/>
+        </p:nvPicPr>
+        <p:blipFill>
+          <a:blip r:embed="rId2"/>
+          <a:stretch>
+            <a:fillRect/>
+          </a:stretch>
+        </p:blipFill>
+        <p:spPr>
+          <a:xfrm>
+            <a:off x="6647926" y="1371600"/>
+            <a:ext cx="4649561" cy="3108960"/>
+          </a:xfrm>
+          <a:prstGeom prst="rect">
+            <a:avLst/>
+          </a:prstGeom>
+        </p:spPr>
+      </p:pic>
+      <p:sp>
+        <p:nvSpPr>
+          <p:cNvPr id="8" name="Connected apps caption"/>
+          <p:cNvSpPr txBox="1"/>
+          <p:nvPr/>
+        </p:nvSpPr>
+        <p:spPr>
+          <a:xfrm>
+            <a:off x="6647926" y="4663440"/>
+            <a:ext cx="4649561" cy="685800"/>
+          </a:xfrm>
+          <a:prstGeom prst="rect">
+            <a:avLst/>
+          </a:prstGeom>
+          <a:noFill/>
+          <a:ln/>
+        </p:spPr>
+        <p:txBody>
+          <a:bodyPr wrap="square" lIns="0" tIns="0" rIns="0" bIns="0" rtlCol="0" anchor="t"/>
+          <a:lstStyle/>
+          <a:p>
+            <a:pPr indent="0" marL="0">
+              <a:buNone/>
+            </a:pPr>
+            <a:r>
+              <a:rPr lang="en-US" sz="1400" dirty="0">
+                <a:solidFill>
+                  <a:schemeClr val="tx2"/>
+                </a:solidFill>
+              </a:rPr>
+              <a:t>Setup: Salesforce CLI installed and allowed, which unblocked API access on the new org.</a:t>
+            </a:r>
+            <a:endParaRPr lang="en-US" sz="1400" dirty="0"/>
+          </a:p>
+        </p:txBody>
+      </p:sp>
+      <p:sp>
+        <p:nvSpPr>
+          <p:cNvPr id="25" name="Slide Number Placeholder 0"/>
+          <p:cNvSpPr>
+            <a:spLocks noGrp="1"/>
+          </p:cNvSpPr>
+          <p:nvPr>
+            <p:ph type="sldNum" sz="quarter" idx="4294967295"/>
+          </p:nvPr>
+        </p:nvSpPr>
+        <p:spPr>
+          <a:xfrm>
+            <a:off x="11155680" y="6400800"/>
+            <a:ext cx="457200" cy="274320"/>
+          </a:xfrm>
+          <a:prstGeom prst="rect">
+            <a:avLst/>
+          </a:prstGeom>
+          <a:extLst>
+            <a:ext uri="{C572A759-6A51-4108-AA02-DFA0A04FC94B}">
+              <ma14:wrappingTextBoxFlag xmlns:ma14="http://schemas.microsoft.com/office/mac/drawingml/2011/main" val="0"/>
+            </a:ext>
+          </a:extLst>
+        </p:spPr>
+        <p:txBody>
+          <a:bodyPr/>
+          <a:lstStyle>
+            <a:lvl1pPr>
+              <a:defRPr sz="1000">
+                <a:solidFill>
+                  <a:schemeClr val="accent6"/>
+                </a:solidFill>
+              </a:defRPr>
+            </a:lvl1pPr>
+          </a:lstStyle>
+          <a:p>
+            <a:pPr algn="r"/>
+            <a:fld id="{F7021451-1387-4CA6-816F-3879F97B5CBC}" type="slidenum">
+              <a:rPr b="0" lang="en-US"/>
+              <a:t>13</a:t>
+            </a:fld>
+            <a:endParaRPr lang="en-US"/>
+          </a:p>
+        </p:txBody>
+      </p:sp>
+    </p:spTree>
+  </p:cSld>
+  <p:clrMapOvr>
+    <a:masterClrMapping/>
+  </p:clrMapOvr>
+</p:sld>
+</file>
+
 <file path=ppt/slides/slide2.xml><?xml version="1.0" encoding="utf-8"?>
 <p:sld xmlns:a="http://schemas.openxmlformats.org/drawingml/2006/main" xmlns:r="http://schemas.openxmlformats.org/officeDocument/2006/relationships" xmlns:p="http://schemas.openxmlformats.org/presentationml/2006/main">
   <p:cSld name="Slide 2">

</xml_diff>

<commit_message>
Deck: evidence slide with the org (URL visible) and extract.py SOQL
Reformat the SOQL in extract.py for readability; queries unchanged and
re-checked against the org.

Co-Authored-By: Claude Opus 5.5 <noreply@anthropic.com>
</commit_message>
<xml_diff>
--- a/deck/salesforce-process-intelligence.pptx
+++ b/deck/salesforce-process-intelligence.pptx
@@ -114,30 +114,30 @@
   <p:extLst>
     <p:ext uri="{521415D9-36F7-43E2-AB2F-B90AF26B5E84}">
       <p14:sectionLst xmlns:p14="http://schemas.microsoft.com/office/powerpoint/2010/main">
-        <p14:section name="Opening" id="{6d4e9b07-343f-868e-eeea-517fcf0838c2}">
+        <p14:section name="Opening" id="{cea02240-3fcf-10ae-6263-30fbd8c30f57}">
           <p14:sldIdLst>
             <p14:sldId id="256"/>
             <p14:sldId id="257"/>
           </p14:sldIdLst>
         </p14:section>
-        <p14:section name="Evidence" id="{1dd6c548-78cb-5c1c-5b65-d0d9a3c71872}">
+        <p14:section name="Evidence" id="{4006877a-e396-3548-454c-fcd91d84a0df}">
           <p14:sldIdLst>
             <p14:sldId id="258"/>
             <p14:sldId id="259"/>
           </p14:sldIdLst>
         </p14:section>
-        <p14:section name="Value" id="{c8cb17a7-d113-2aac-648b-11b8cd1aa483}">
+        <p14:section name="Value" id="{2a5f094b-0090-a4f9-b8cc-53fb2d756d58}">
           <p14:sldIdLst>
             <p14:sldId id="260"/>
           </p14:sldIdLst>
         </p14:section>
-        <p14:section name="Tech setup" id="{88a7235b-cfa3-08a1-0eb0-c01130c35b4e}">
+        <p14:section name="Tech setup" id="{82d0bfbe-626b-3fa9-d2b6-98154d9de801}">
           <p14:sldIdLst>
             <p14:sldId id="261"/>
             <p14:sldId id="262"/>
           </p14:sldIdLst>
         </p14:section>
-        <p14:section name="Close" id="{08e747ec-fce7-5748-f1b8-2b3585baebcf}">
+        <p14:section name="Close" id="{b9043b03-107a-2b7d-1f74-464bac0320d0}">
           <p14:sldIdLst>
             <p14:sldId id="263"/>
           </p14:sldIdLst>
@@ -1831,7 +1831,7 @@
           <a:p>
             <a:r>
               <a:rPr lang="en-US" dirty="0"/>
-              <a:t>Every step is real: the CLI fix in Setup, the seeded deals, the raw stage history the extract reads, and the published output. Opportunity is the case; leads join via ConvertedOpportunityId and tasks via WhatId. Trial orgs can't backdate history, so the 10-month dataset is simulated in the same object shape.</a:t>
+              <a:t>Left: the trial org standing in for a client's CRM, seeded by seed.py so there's real OpportunityHistory to read. Right: the exact SOQL the extractor runs. Opportunity is the case; leads join via ConvertedOpportunityId and tasks via WhatId. Trial orgs can't backdate history, so the 10-month dataset is simulated in the same object shape.</a:t>
             </a:r>
             <a:endParaRPr lang="en-US" dirty="0"/>
           </a:p>
@@ -6112,7 +6112,7 @@
                   <a:schemeClr val="tx2"/>
                 </a:solidFill>
               </a:rPr>
-              <a:t>Tech setup: the key steps, as they ran</a:t>
+              <a:t>Tech setup: from a Salesforce org to an event log</a:t>
             </a:r>
             <a:endParaRPr lang="en-US" sz="3000" dirty="0"/>
           </a:p>
@@ -6120,36 +6120,14 @@
       </p:sp>
       <p:sp>
         <p:nvSpPr>
-          <p:cNvPr id="3" name="Key step 1 card"/>
+          <p:cNvPr id="3" name="Org screenshot frame"/>
           <p:cNvSpPr/>
           <p:nvPr/>
         </p:nvSpPr>
         <p:spPr>
           <a:xfrm>
-            <a:off x="548640" y="1280160"/>
-            <a:ext cx="5440680" cy="2331720"/>
-          </a:xfrm>
-          <a:prstGeom prst="roundRect">
-            <a:avLst>
-              <a:gd name="adj" fmla="val 4706"/>
-            </a:avLst>
-          </a:prstGeom>
-          <a:solidFill>
-            <a:schemeClr val="bg2"/>
-          </a:solidFill>
-          <a:ln/>
-        </p:spPr>
-      </p:sp>
-      <p:sp>
-        <p:nvSpPr>
-          <p:cNvPr id="4" name="Key step 1 frame"/>
-          <p:cNvSpPr/>
-          <p:nvPr/>
-        </p:nvSpPr>
-        <p:spPr>
-          <a:xfrm>
-            <a:off x="658368" y="1440316"/>
-            <a:ext cx="2980944" cy="2011407"/>
+            <a:off x="512064" y="1243584"/>
+            <a:ext cx="5148072" cy="3910582"/>
           </a:xfrm>
           <a:prstGeom prst="rect">
             <a:avLst/>
@@ -6167,7 +6145,7 @@
       </p:sp>
       <p:pic>
         <p:nvPicPr>
-          <p:cNvPr id="5" name="Key step 1 image" descr="Salesforce CLI allowed under Connected Apps OAuth Usage; the CLI session signs every API call.">    </p:cNvPr>
+          <p:cNvPr id="4" name="Org screenshot" descr="Salesforce trial org with seeded demo records">    </p:cNvPr>
           <p:cNvPicPr>
             <a:picLocks noChangeAspect="1"/>
           </p:cNvPicPr>
@@ -6181,8 +6159,8 @@
         </p:blipFill>
         <p:spPr>
           <a:xfrm>
-            <a:off x="685800" y="1467748"/>
-            <a:ext cx="2926080" cy="1956543"/>
+            <a:off x="548640" y="1280160"/>
+            <a:ext cx="5074920" cy="3837430"/>
           </a:xfrm>
           <a:prstGeom prst="rect">
             <a:avLst/>
@@ -6191,269 +6169,179 @@
       </p:pic>
       <p:sp>
         <p:nvSpPr>
-          <p:cNvPr id="6" name="Key step 1 marker"/>
+          <p:cNvPr id="5" name="Org caption"/>
+          <p:cNvSpPr txBox="1"/>
+          <p:nvPr/>
+        </p:nvSpPr>
+        <p:spPr>
+          <a:xfrm>
+            <a:off x="548640" y="5669280"/>
+            <a:ext cx="5074920" cy="685800"/>
+          </a:xfrm>
+          <a:prstGeom prst="rect">
+            <a:avLst/>
+          </a:prstGeom>
+          <a:noFill/>
+          <a:ln/>
+        </p:spPr>
+        <p:txBody>
+          <a:bodyPr wrap="square" lIns="0" tIns="0" rIns="0" bIns="0" rtlCol="0" anchor="t"/>
+          <a:lstStyle/>
+          <a:p>
+            <a:pPr indent="0" marL="0">
+              <a:buNone/>
+            </a:pPr>
+            <a:r>
+              <a:rPr lang="en-US" sz="1400" b="1" dirty="0">
+                <a:solidFill>
+                  <a:schemeClr val="tx2"/>
+                </a:solidFill>
+              </a:rPr>
+              <a:t>Salesforce trial org: </a:t>
+            </a:r>
+            <a:pPr indent="0" marL="0">
+              <a:buNone/>
+            </a:pPr>
+            <a:r>
+              <a:rPr lang="en-US" sz="1400" dirty="0">
+                <a:solidFill>
+                  <a:schemeClr val="tx2"/>
+                </a:solidFill>
+              </a:rPr>
+              <a:t>seed.py loaded 40 [Demo] deals through real stage changes to simulate a client's CRM.</a:t>
+            </a:r>
+            <a:endParaRPr lang="en-US" sz="1400" dirty="0"/>
+          </a:p>
+        </p:txBody>
+      </p:sp>
+      <p:sp>
+        <p:nvSpPr>
+          <p:cNvPr id="6" name="Code panel"/>
           <p:cNvSpPr/>
           <p:nvPr/>
         </p:nvSpPr>
         <p:spPr>
           <a:xfrm>
-            <a:off x="3794760" y="1508760"/>
-            <a:ext cx="411480" cy="411480"/>
-          </a:xfrm>
-          <a:prstGeom prst="ellipse">
-            <a:avLst/>
-          </a:prstGeom>
-          <a:solidFill>
-            <a:schemeClr val="accent1"/>
-          </a:solidFill>
-          <a:ln/>
-        </p:spPr>
-      </p:sp>
-      <p:sp>
-        <p:nvSpPr>
-          <p:cNvPr id="7" name="Key step 1 number"/>
-          <p:cNvSpPr txBox="1"/>
-          <p:nvPr/>
-        </p:nvSpPr>
-        <p:spPr>
-          <a:xfrm>
-            <a:off x="3794760" y="1508760"/>
-            <a:ext cx="411480" cy="411480"/>
-          </a:xfrm>
-          <a:prstGeom prst="rect">
-            <a:avLst/>
-          </a:prstGeom>
-          <a:noFill/>
-          <a:ln/>
-        </p:spPr>
-        <p:txBody>
-          <a:bodyPr wrap="square" lIns="0" tIns="0" rIns="0" bIns="0" rtlCol="0" anchor="ctr"/>
-          <a:lstStyle/>
-          <a:p>
-            <a:pPr algn="ctr" indent="0" marL="0">
-              <a:buNone/>
-            </a:pPr>
-            <a:r>
-              <a:rPr lang="en-US" sz="1600" b="1" dirty="0">
-                <a:solidFill>
-                  <a:schemeClr val="bg1"/>
-                </a:solidFill>
-              </a:rPr>
-              <a:t>1</a:t>
-            </a:r>
-            <a:endParaRPr lang="en-US" sz="1600" dirty="0"/>
-          </a:p>
-        </p:txBody>
-      </p:sp>
-      <p:sp>
-        <p:nvSpPr>
-          <p:cNvPr id="8" name="Key step 1 title"/>
-          <p:cNvSpPr txBox="1"/>
-          <p:nvPr/>
-        </p:nvSpPr>
-        <p:spPr>
-          <a:xfrm>
-            <a:off x="3794760" y="2011680"/>
-            <a:ext cx="2057400" cy="365760"/>
-          </a:xfrm>
-          <a:prstGeom prst="rect">
-            <a:avLst/>
-          </a:prstGeom>
-          <a:noFill/>
-          <a:ln/>
-        </p:spPr>
-        <p:txBody>
-          <a:bodyPr wrap="square" lIns="0" tIns="0" rIns="0" bIns="0" rtlCol="0" anchor="t"/>
-          <a:lstStyle/>
-          <a:p>
-            <a:pPr indent="0" marL="0">
-              <a:buNone/>
-            </a:pPr>
-            <a:r>
-              <a:rPr lang="en-US" sz="1600" b="1" dirty="0">
-                <a:solidFill>
-                  <a:schemeClr val="tx2"/>
-                </a:solidFill>
-              </a:rPr>
-              <a:t>Connect</a:t>
-            </a:r>
-            <a:endParaRPr lang="en-US" sz="1600" dirty="0"/>
-          </a:p>
-        </p:txBody>
-      </p:sp>
-      <p:sp>
-        <p:nvSpPr>
-          <p:cNvPr id="9" name="Key step 1 body"/>
-          <p:cNvSpPr txBox="1"/>
-          <p:nvPr/>
-        </p:nvSpPr>
-        <p:spPr>
-          <a:xfrm>
-            <a:off x="3794760" y="2377440"/>
-            <a:ext cx="2057400" cy="1143000"/>
-          </a:xfrm>
-          <a:prstGeom prst="rect">
-            <a:avLst/>
-          </a:prstGeom>
-          <a:noFill/>
-          <a:ln/>
-        </p:spPr>
-        <p:txBody>
-          <a:bodyPr wrap="square" lIns="0" tIns="0" rIns="0" bIns="0" rtlCol="0" anchor="t"/>
-          <a:lstStyle/>
-          <a:p>
-            <a:pPr indent="0" marL="0">
-              <a:buNone/>
-            </a:pPr>
-            <a:r>
-              <a:rPr lang="en-US" sz="1400" dirty="0">
-                <a:solidFill>
-                  <a:schemeClr val="tx1"/>
-                </a:solidFill>
-              </a:rPr>
-              <a:t>Salesforce CLI allowed under Connected Apps OAuth Usage; the CLI session signs every API call.</a:t>
-            </a:r>
-            <a:endParaRPr lang="en-US" sz="1400" dirty="0"/>
-          </a:p>
-        </p:txBody>
-      </p:sp>
-      <p:sp>
-        <p:nvSpPr>
-          <p:cNvPr id="10" name="Key step 2 card"/>
-          <p:cNvSpPr/>
-          <p:nvPr/>
-        </p:nvSpPr>
-        <p:spPr>
-          <a:xfrm>
-            <a:off x="6172200" y="1280160"/>
-            <a:ext cx="5440680" cy="2331720"/>
+            <a:off x="5897880" y="1280160"/>
+            <a:ext cx="5715000" cy="4297680"/>
           </a:xfrm>
           <a:prstGeom prst="roundRect">
             <a:avLst>
-              <a:gd name="adj" fmla="val 4706"/>
+              <a:gd name="adj" fmla="val 2553"/>
             </a:avLst>
           </a:prstGeom>
           <a:solidFill>
-            <a:schemeClr val="bg2"/>
+            <a:schemeClr val="tx2"/>
           </a:solidFill>
           <a:ln/>
         </p:spPr>
       </p:sp>
       <p:sp>
         <p:nvSpPr>
-          <p:cNvPr id="11" name="Key step 2 frame"/>
+          <p:cNvPr id="7" name="Code panel dot 1"/>
           <p:cNvSpPr/>
           <p:nvPr/>
         </p:nvSpPr>
         <p:spPr>
           <a:xfrm>
-            <a:off x="6281928" y="1434694"/>
-            <a:ext cx="2980944" cy="2022653"/>
-          </a:xfrm>
-          <a:prstGeom prst="rect">
+            <a:off x="6080760" y="1417320"/>
+            <a:ext cx="109728" cy="109728"/>
+          </a:xfrm>
+          <a:prstGeom prst="ellipse">
             <a:avLst/>
           </a:prstGeom>
           <a:solidFill>
-            <a:schemeClr val="bg1"/>
+            <a:srgbClr val="FE9339"/>
           </a:solidFill>
-          <a:ln w="12700">
-            <a:solidFill>
-              <a:schemeClr val="accent3"/>
-            </a:solidFill>
-            <a:prstDash val="solid"/>
-          </a:ln>
-        </p:spPr>
-      </p:sp>
-      <p:pic>
-        <p:nvPicPr>
-          <p:cNvPr id="12" name="Key step 2 image" descr="seed.py loads 40 [Demo] deals and walks them through the org's own stages.">    </p:cNvPr>
-          <p:cNvPicPr>
-            <a:picLocks noChangeAspect="1"/>
-          </p:cNvPicPr>
-          <p:nvPr/>
-        </p:nvPicPr>
-        <p:blipFill>
-          <a:blip r:embed="rId2"/>
-          <a:stretch>
-            <a:fillRect/>
-          </a:stretch>
-        </p:blipFill>
-        <p:spPr>
-          <a:xfrm>
-            <a:off x="6309360" y="1462126"/>
-            <a:ext cx="2926080" cy="1967789"/>
-          </a:xfrm>
-          <a:prstGeom prst="rect">
-            <a:avLst/>
-          </a:prstGeom>
-        </p:spPr>
-      </p:pic>
-      <p:sp>
-        <p:nvSpPr>
-          <p:cNvPr id="13" name="Key step 2 marker"/>
+          <a:ln/>
+        </p:spPr>
+      </p:sp>
+      <p:sp>
+        <p:nvSpPr>
+          <p:cNvPr id="8" name="Code panel dot 2"/>
           <p:cNvSpPr/>
           <p:nvPr/>
         </p:nvSpPr>
         <p:spPr>
           <a:xfrm>
-            <a:off x="9418320" y="1508760"/>
-            <a:ext cx="411480" cy="411480"/>
+            <a:off x="6263640" y="1417320"/>
+            <a:ext cx="109728" cy="109728"/>
           </a:xfrm>
           <a:prstGeom prst="ellipse">
             <a:avLst/>
           </a:prstGeom>
           <a:solidFill>
-            <a:schemeClr val="accent1"/>
+            <a:srgbClr val="F6C344"/>
           </a:solidFill>
           <a:ln/>
         </p:spPr>
       </p:sp>
       <p:sp>
         <p:nvSpPr>
-          <p:cNvPr id="14" name="Key step 2 number"/>
+          <p:cNvPr id="9" name="Code panel dot 3"/>
+          <p:cNvSpPr/>
+          <p:nvPr/>
+        </p:nvSpPr>
+        <p:spPr>
+          <a:xfrm>
+            <a:off x="6446520" y="1417320"/>
+            <a:ext cx="109728" cy="109728"/>
+          </a:xfrm>
+          <a:prstGeom prst="ellipse">
+            <a:avLst/>
+          </a:prstGeom>
+          <a:solidFill>
+            <a:srgbClr val="2E844A"/>
+          </a:solidFill>
+          <a:ln/>
+        </p:spPr>
+      </p:sp>
+      <p:sp>
+        <p:nvSpPr>
+          <p:cNvPr id="10" name="Code panel filename"/>
           <p:cNvSpPr txBox="1"/>
           <p:nvPr/>
         </p:nvSpPr>
         <p:spPr>
           <a:xfrm>
-            <a:off x="9418320" y="1508760"/>
-            <a:ext cx="411480" cy="411480"/>
-          </a:xfrm>
-          <a:prstGeom prst="rect">
-            <a:avLst/>
-          </a:prstGeom>
-          <a:noFill/>
-          <a:ln/>
-        </p:spPr>
-        <p:txBody>
-          <a:bodyPr wrap="square" lIns="0" tIns="0" rIns="0" bIns="0" rtlCol="0" anchor="ctr"/>
-          <a:lstStyle/>
-          <a:p>
-            <a:pPr algn="ctr" indent="0" marL="0">
-              <a:buNone/>
-            </a:pPr>
-            <a:r>
-              <a:rPr lang="en-US" sz="1600" b="1" dirty="0">
-                <a:solidFill>
-                  <a:schemeClr val="bg1"/>
-                </a:solidFill>
-              </a:rPr>
-              <a:t>2</a:t>
-            </a:r>
-            <a:endParaRPr lang="en-US" sz="1600" dirty="0"/>
-          </a:p>
-        </p:txBody>
-      </p:sp>
-      <p:sp>
-        <p:nvSpPr>
-          <p:cNvPr id="15" name="Key step 2 title"/>
+            <a:off x="6675120" y="1353312"/>
+            <a:ext cx="2743200" cy="237744"/>
+          </a:xfrm>
+          <a:prstGeom prst="rect">
+            <a:avLst/>
+          </a:prstGeom>
+          <a:noFill/>
+          <a:ln/>
+        </p:spPr>
+        <p:txBody>
+          <a:bodyPr wrap="square" lIns="0" tIns="0" rIns="0" bIns="0" rtlCol="0" anchor="t"/>
+          <a:lstStyle/>
+          <a:p>
+            <a:pPr indent="0" marL="0">
+              <a:buNone/>
+            </a:pPr>
+            <a:r>
+              <a:rPr lang="en-US" sz="1100" dirty="0">
+                <a:solidFill>
+                  <a:schemeClr val="accent3"/>
+                </a:solidFill>
+              </a:rPr>
+              <a:t>pipeline/extract.py</a:t>
+            </a:r>
+            <a:endParaRPr lang="en-US" sz="1100" dirty="0"/>
+          </a:p>
+        </p:txBody>
+      </p:sp>
+      <p:sp>
+        <p:nvSpPr>
+          <p:cNvPr id="11" name="SOQL code"/>
           <p:cNvSpPr txBox="1"/>
           <p:nvPr/>
         </p:nvSpPr>
         <p:spPr>
           <a:xfrm>
-            <a:off x="9418320" y="2011680"/>
-            <a:ext cx="2057400" cy="365760"/>
+            <a:off x="6080760" y="1664208"/>
+            <a:ext cx="5440680" cy="3840480"/>
           </a:xfrm>
           <a:prstGeom prst="rect">
             <a:avLst/>
@@ -6466,449 +6354,1086 @@
           <a:lstStyle/>
           <a:p>
             <a:pPr indent="0" marL="0">
-              <a:buNone/>
-            </a:pPr>
-            <a:r>
-              <a:rPr lang="en-US" sz="1600" b="1" dirty="0">
+              <a:lnSpc>
+                <a:spcPct val="100000"/>
+              </a:lnSpc>
+              <a:buNone/>
+            </a:pPr>
+            <a:r>
+              <a:rPr lang="en-US" sz="1000" dirty="0">
+                <a:solidFill>
+                  <a:srgbClr val="CFE9FE"/>
+                </a:solidFill>
+                <a:latin typeface="Courier New" pitchFamily="34" charset="0"/>
+                <a:ea typeface="Courier New" pitchFamily="34" charset="-122"/>
+                <a:cs typeface="Courier New" pitchFamily="34" charset="-120"/>
+              </a:rPr>
+              <a:t>QUERIES = {</a:t>
+            </a:r>
+            <a:endParaRPr lang="en-US" sz="1000" dirty="0"/>
+          </a:p>
+          <a:p>
+            <a:pPr indent="0" marL="0">
+              <a:lnSpc>
+                <a:spcPct val="100000"/>
+              </a:lnSpc>
+              <a:buNone/>
+            </a:pPr>
+            <a:r>
+              <a:rPr lang="en-US" sz="1000" dirty="0">
+                <a:solidFill>
+                  <a:srgbClr val="CFE9FE"/>
+                </a:solidFill>
+                <a:latin typeface="Courier New" pitchFamily="34" charset="0"/>
+                <a:ea typeface="Courier New" pitchFamily="34" charset="-122"/>
+                <a:cs typeface="Courier New" pitchFamily="34" charset="-120"/>
+              </a:rPr>
+              <a:t>    </a:t>
+            </a:r>
+            <a:pPr indent="0" marL="0">
+              <a:lnSpc>
+                <a:spcPct val="100000"/>
+              </a:lnSpc>
+              <a:buNone/>
+            </a:pPr>
+            <a:r>
+              <a:rPr lang="en-US" sz="1000" dirty="0">
+                <a:solidFill>
+                  <a:srgbClr val="FE9339"/>
+                </a:solidFill>
+                <a:latin typeface="Courier New" pitchFamily="34" charset="0"/>
+                <a:ea typeface="Courier New" pitchFamily="34" charset="-122"/>
+                <a:cs typeface="Courier New" pitchFamily="34" charset="-120"/>
+              </a:rPr>
+              <a:t>"opportunities"</a:t>
+            </a:r>
+            <a:pPr indent="0" marL="0">
+              <a:lnSpc>
+                <a:spcPct val="100000"/>
+              </a:lnSpc>
+              <a:buNone/>
+            </a:pPr>
+            <a:r>
+              <a:rPr lang="en-US" sz="1000" dirty="0">
+                <a:solidFill>
+                  <a:srgbClr val="CFE9FE"/>
+                </a:solidFill>
+                <a:latin typeface="Courier New" pitchFamily="34" charset="0"/>
+                <a:ea typeface="Courier New" pitchFamily="34" charset="-122"/>
+                <a:cs typeface="Courier New" pitchFamily="34" charset="-120"/>
+              </a:rPr>
+              <a:t>: """</a:t>
+            </a:r>
+            <a:endParaRPr lang="en-US" sz="1000" dirty="0"/>
+          </a:p>
+          <a:p>
+            <a:pPr indent="0" marL="0">
+              <a:lnSpc>
+                <a:spcPct val="100000"/>
+              </a:lnSpc>
+              <a:buNone/>
+            </a:pPr>
+            <a:r>
+              <a:rPr lang="en-US" sz="1000" dirty="0">
+                <a:solidFill>
+                  <a:srgbClr val="CFE9FE"/>
+                </a:solidFill>
+                <a:latin typeface="Courier New" pitchFamily="34" charset="0"/>
+                <a:ea typeface="Courier New" pitchFamily="34" charset="-122"/>
+                <a:cs typeface="Courier New" pitchFamily="34" charset="-120"/>
+              </a:rPr>
+              <a:t>    </a:t>
+            </a:r>
+            <a:pPr indent="0" marL="0">
+              <a:lnSpc>
+                <a:spcPct val="100000"/>
+              </a:lnSpc>
+              <a:buNone/>
+            </a:pPr>
+            <a:r>
+              <a:rPr lang="en-US" sz="1000" b="1" dirty="0">
+                <a:solidFill>
+                  <a:srgbClr val="0B9DE0"/>
+                </a:solidFill>
+                <a:latin typeface="Courier New" pitchFamily="34" charset="0"/>
+                <a:ea typeface="Courier New" pitchFamily="34" charset="-122"/>
+                <a:cs typeface="Courier New" pitchFamily="34" charset="-120"/>
+              </a:rPr>
+              <a:t>SELECT</a:t>
+            </a:r>
+            <a:pPr indent="0" marL="0">
+              <a:lnSpc>
+                <a:spcPct val="100000"/>
+              </a:lnSpc>
+              <a:buNone/>
+            </a:pPr>
+            <a:r>
+              <a:rPr lang="en-US" sz="1000" dirty="0">
+                <a:solidFill>
+                  <a:srgbClr val="CFE9FE"/>
+                </a:solidFill>
+                <a:latin typeface="Courier New" pitchFamily="34" charset="0"/>
+                <a:ea typeface="Courier New" pitchFamily="34" charset="-122"/>
+                <a:cs typeface="Courier New" pitchFamily="34" charset="-120"/>
+              </a:rPr>
+              <a:t> Id, Name, Amount, StageName, IsWon, IsClosed,</a:t>
+            </a:r>
+            <a:endParaRPr lang="en-US" sz="1000" dirty="0"/>
+          </a:p>
+          <a:p>
+            <a:pPr indent="0" marL="0">
+              <a:lnSpc>
+                <a:spcPct val="100000"/>
+              </a:lnSpc>
+              <a:buNone/>
+            </a:pPr>
+            <a:r>
+              <a:rPr lang="en-US" sz="1000" dirty="0">
+                <a:solidFill>
+                  <a:srgbClr val="CFE9FE"/>
+                </a:solidFill>
+                <a:latin typeface="Courier New" pitchFamily="34" charset="0"/>
+                <a:ea typeface="Courier New" pitchFamily="34" charset="-122"/>
+                <a:cs typeface="Courier New" pitchFamily="34" charset="-120"/>
+              </a:rPr>
+              <a:t>           LeadSource, CreatedDate, CloseDate, OwnerId, Owner.Name,</a:t>
+            </a:r>
+            <a:endParaRPr lang="en-US" sz="1000" dirty="0"/>
+          </a:p>
+          <a:p>
+            <a:pPr indent="0" marL="0">
+              <a:lnSpc>
+                <a:spcPct val="100000"/>
+              </a:lnSpc>
+              <a:buNone/>
+            </a:pPr>
+            <a:r>
+              <a:rPr lang="en-US" sz="1000" dirty="0">
+                <a:solidFill>
+                  <a:srgbClr val="CFE9FE"/>
+                </a:solidFill>
+                <a:latin typeface="Courier New" pitchFamily="34" charset="0"/>
+                <a:ea typeface="Courier New" pitchFamily="34" charset="-122"/>
+                <a:cs typeface="Courier New" pitchFamily="34" charset="-120"/>
+              </a:rPr>
+              <a:t>           Account.Industry, Account.BillingCountry</a:t>
+            </a:r>
+            <a:endParaRPr lang="en-US" sz="1000" dirty="0"/>
+          </a:p>
+          <a:p>
+            <a:pPr indent="0" marL="0">
+              <a:lnSpc>
+                <a:spcPct val="100000"/>
+              </a:lnSpc>
+              <a:buNone/>
+            </a:pPr>
+            <a:r>
+              <a:rPr lang="en-US" sz="1000" dirty="0">
+                <a:solidFill>
+                  <a:srgbClr val="CFE9FE"/>
+                </a:solidFill>
+                <a:latin typeface="Courier New" pitchFamily="34" charset="0"/>
+                <a:ea typeface="Courier New" pitchFamily="34" charset="-122"/>
+                <a:cs typeface="Courier New" pitchFamily="34" charset="-120"/>
+              </a:rPr>
+              <a:t>    </a:t>
+            </a:r>
+            <a:pPr indent="0" marL="0">
+              <a:lnSpc>
+                <a:spcPct val="100000"/>
+              </a:lnSpc>
+              <a:buNone/>
+            </a:pPr>
+            <a:r>
+              <a:rPr lang="en-US" sz="1000" b="1" dirty="0">
+                <a:solidFill>
+                  <a:srgbClr val="0B9DE0"/>
+                </a:solidFill>
+                <a:latin typeface="Courier New" pitchFamily="34" charset="0"/>
+                <a:ea typeface="Courier New" pitchFamily="34" charset="-122"/>
+                <a:cs typeface="Courier New" pitchFamily="34" charset="-120"/>
+              </a:rPr>
+              <a:t>FROM</a:t>
+            </a:r>
+            <a:pPr indent="0" marL="0">
+              <a:lnSpc>
+                <a:spcPct val="100000"/>
+              </a:lnSpc>
+              <a:buNone/>
+            </a:pPr>
+            <a:r>
+              <a:rPr lang="en-US" sz="1000" dirty="0">
+                <a:solidFill>
+                  <a:srgbClr val="CFE9FE"/>
+                </a:solidFill>
+                <a:latin typeface="Courier New" pitchFamily="34" charset="0"/>
+                <a:ea typeface="Courier New" pitchFamily="34" charset="-122"/>
+                <a:cs typeface="Courier New" pitchFamily="34" charset="-120"/>
+              </a:rPr>
+              <a:t> Opportunity""",</a:t>
+            </a:r>
+            <a:endParaRPr lang="en-US" sz="1000" dirty="0"/>
+          </a:p>
+          <a:p>
+            <a:pPr indent="0" marL="0">
+              <a:lnSpc>
+                <a:spcPct val="100000"/>
+              </a:lnSpc>
+              <a:buNone/>
+            </a:pPr>
+            <a:r>
+              <a:rPr lang="en-US" sz="1000" dirty="0">
+                <a:solidFill>
+                  <a:srgbClr val="CFE9FE"/>
+                </a:solidFill>
+                <a:latin typeface="Courier New" pitchFamily="34" charset="0"/>
+                <a:ea typeface="Courier New" pitchFamily="34" charset="-122"/>
+                <a:cs typeface="Courier New" pitchFamily="34" charset="-120"/>
+              </a:rPr>
+              <a:t>    </a:t>
+            </a:r>
+            <a:pPr indent="0" marL="0">
+              <a:lnSpc>
+                <a:spcPct val="100000"/>
+              </a:lnSpc>
+              <a:buNone/>
+            </a:pPr>
+            <a:r>
+              <a:rPr lang="en-US" sz="1000" dirty="0">
+                <a:solidFill>
+                  <a:srgbClr val="FE9339"/>
+                </a:solidFill>
+                <a:latin typeface="Courier New" pitchFamily="34" charset="0"/>
+                <a:ea typeface="Courier New" pitchFamily="34" charset="-122"/>
+                <a:cs typeface="Courier New" pitchFamily="34" charset="-120"/>
+              </a:rPr>
+              <a:t>"stage_history"</a:t>
+            </a:r>
+            <a:pPr indent="0" marL="0">
+              <a:lnSpc>
+                <a:spcPct val="100000"/>
+              </a:lnSpc>
+              <a:buNone/>
+            </a:pPr>
+            <a:r>
+              <a:rPr lang="en-US" sz="1000" dirty="0">
+                <a:solidFill>
+                  <a:srgbClr val="CFE9FE"/>
+                </a:solidFill>
+                <a:latin typeface="Courier New" pitchFamily="34" charset="0"/>
+                <a:ea typeface="Courier New" pitchFamily="34" charset="-122"/>
+                <a:cs typeface="Courier New" pitchFamily="34" charset="-120"/>
+              </a:rPr>
+              <a:t>: """</a:t>
+            </a:r>
+            <a:endParaRPr lang="en-US" sz="1000" dirty="0"/>
+          </a:p>
+          <a:p>
+            <a:pPr indent="0" marL="0">
+              <a:lnSpc>
+                <a:spcPct val="100000"/>
+              </a:lnSpc>
+              <a:buNone/>
+            </a:pPr>
+            <a:r>
+              <a:rPr lang="en-US" sz="1000" dirty="0">
+                <a:solidFill>
+                  <a:srgbClr val="CFE9FE"/>
+                </a:solidFill>
+                <a:latin typeface="Courier New" pitchFamily="34" charset="0"/>
+                <a:ea typeface="Courier New" pitchFamily="34" charset="-122"/>
+                <a:cs typeface="Courier New" pitchFamily="34" charset="-120"/>
+              </a:rPr>
+              <a:t>    </a:t>
+            </a:r>
+            <a:pPr indent="0" marL="0">
+              <a:lnSpc>
+                <a:spcPct val="100000"/>
+              </a:lnSpc>
+              <a:buNone/>
+            </a:pPr>
+            <a:r>
+              <a:rPr lang="en-US" sz="1000" b="1" dirty="0">
+                <a:solidFill>
+                  <a:srgbClr val="0B9DE0"/>
+                </a:solidFill>
+                <a:latin typeface="Courier New" pitchFamily="34" charset="0"/>
+                <a:ea typeface="Courier New" pitchFamily="34" charset="-122"/>
+                <a:cs typeface="Courier New" pitchFamily="34" charset="-120"/>
+              </a:rPr>
+              <a:t>SELECT</a:t>
+            </a:r>
+            <a:pPr indent="0" marL="0">
+              <a:lnSpc>
+                <a:spcPct val="100000"/>
+              </a:lnSpc>
+              <a:buNone/>
+            </a:pPr>
+            <a:r>
+              <a:rPr lang="en-US" sz="1000" dirty="0">
+                <a:solidFill>
+                  <a:srgbClr val="CFE9FE"/>
+                </a:solidFill>
+                <a:latin typeface="Courier New" pitchFamily="34" charset="0"/>
+                <a:ea typeface="Courier New" pitchFamily="34" charset="-122"/>
+                <a:cs typeface="Courier New" pitchFamily="34" charset="-120"/>
+              </a:rPr>
+              <a:t> OpportunityId, StageName, CreatedDate,</a:t>
+            </a:r>
+            <a:endParaRPr lang="en-US" sz="1000" dirty="0"/>
+          </a:p>
+          <a:p>
+            <a:pPr indent="0" marL="0">
+              <a:lnSpc>
+                <a:spcPct val="100000"/>
+              </a:lnSpc>
+              <a:buNone/>
+            </a:pPr>
+            <a:r>
+              <a:rPr lang="en-US" sz="1000" dirty="0">
+                <a:solidFill>
+                  <a:srgbClr val="CFE9FE"/>
+                </a:solidFill>
+                <a:latin typeface="Courier New" pitchFamily="34" charset="0"/>
+                <a:ea typeface="Courier New" pitchFamily="34" charset="-122"/>
+                <a:cs typeface="Courier New" pitchFamily="34" charset="-120"/>
+              </a:rPr>
+              <a:t>           CreatedById, CreatedBy.Name</a:t>
+            </a:r>
+            <a:endParaRPr lang="en-US" sz="1000" dirty="0"/>
+          </a:p>
+          <a:p>
+            <a:pPr indent="0" marL="0">
+              <a:lnSpc>
+                <a:spcPct val="100000"/>
+              </a:lnSpc>
+              <a:buNone/>
+            </a:pPr>
+            <a:r>
+              <a:rPr lang="en-US" sz="1000" dirty="0">
+                <a:solidFill>
+                  <a:srgbClr val="CFE9FE"/>
+                </a:solidFill>
+                <a:latin typeface="Courier New" pitchFamily="34" charset="0"/>
+                <a:ea typeface="Courier New" pitchFamily="34" charset="-122"/>
+                <a:cs typeface="Courier New" pitchFamily="34" charset="-120"/>
+              </a:rPr>
+              <a:t>    </a:t>
+            </a:r>
+            <a:pPr indent="0" marL="0">
+              <a:lnSpc>
+                <a:spcPct val="100000"/>
+              </a:lnSpc>
+              <a:buNone/>
+            </a:pPr>
+            <a:r>
+              <a:rPr lang="en-US" sz="1000" b="1" dirty="0">
+                <a:solidFill>
+                  <a:srgbClr val="0B9DE0"/>
+                </a:solidFill>
+                <a:latin typeface="Courier New" pitchFamily="34" charset="0"/>
+                <a:ea typeface="Courier New" pitchFamily="34" charset="-122"/>
+                <a:cs typeface="Courier New" pitchFamily="34" charset="-120"/>
+              </a:rPr>
+              <a:t>FROM</a:t>
+            </a:r>
+            <a:pPr indent="0" marL="0">
+              <a:lnSpc>
+                <a:spcPct val="100000"/>
+              </a:lnSpc>
+              <a:buNone/>
+            </a:pPr>
+            <a:r>
+              <a:rPr lang="en-US" sz="1000" dirty="0">
+                <a:solidFill>
+                  <a:srgbClr val="CFE9FE"/>
+                </a:solidFill>
+                <a:latin typeface="Courier New" pitchFamily="34" charset="0"/>
+                <a:ea typeface="Courier New" pitchFamily="34" charset="-122"/>
+                <a:cs typeface="Courier New" pitchFamily="34" charset="-120"/>
+              </a:rPr>
+              <a:t> OpportunityHistory</a:t>
+            </a:r>
+            <a:endParaRPr lang="en-US" sz="1000" dirty="0"/>
+          </a:p>
+          <a:p>
+            <a:pPr indent="0" marL="0">
+              <a:lnSpc>
+                <a:spcPct val="100000"/>
+              </a:lnSpc>
+              <a:buNone/>
+            </a:pPr>
+            <a:r>
+              <a:rPr lang="en-US" sz="1000" dirty="0">
+                <a:solidFill>
+                  <a:srgbClr val="CFE9FE"/>
+                </a:solidFill>
+                <a:latin typeface="Courier New" pitchFamily="34" charset="0"/>
+                <a:ea typeface="Courier New" pitchFamily="34" charset="-122"/>
+                <a:cs typeface="Courier New" pitchFamily="34" charset="-120"/>
+              </a:rPr>
+              <a:t>    </a:t>
+            </a:r>
+            <a:pPr indent="0" marL="0">
+              <a:lnSpc>
+                <a:spcPct val="100000"/>
+              </a:lnSpc>
+              <a:buNone/>
+            </a:pPr>
+            <a:r>
+              <a:rPr lang="en-US" sz="1000" b="1" dirty="0">
+                <a:solidFill>
+                  <a:srgbClr val="0B9DE0"/>
+                </a:solidFill>
+                <a:latin typeface="Courier New" pitchFamily="34" charset="0"/>
+                <a:ea typeface="Courier New" pitchFamily="34" charset="-122"/>
+                <a:cs typeface="Courier New" pitchFamily="34" charset="-120"/>
+              </a:rPr>
+              <a:t>ORDER BY</a:t>
+            </a:r>
+            <a:pPr indent="0" marL="0">
+              <a:lnSpc>
+                <a:spcPct val="100000"/>
+              </a:lnSpc>
+              <a:buNone/>
+            </a:pPr>
+            <a:r>
+              <a:rPr lang="en-US" sz="1000" dirty="0">
+                <a:solidFill>
+                  <a:srgbClr val="CFE9FE"/>
+                </a:solidFill>
+                <a:latin typeface="Courier New" pitchFamily="34" charset="0"/>
+                <a:ea typeface="Courier New" pitchFamily="34" charset="-122"/>
+                <a:cs typeface="Courier New" pitchFamily="34" charset="-120"/>
+              </a:rPr>
+              <a:t> OpportunityId, CreatedDate""",</a:t>
+            </a:r>
+            <a:endParaRPr lang="en-US" sz="1000" dirty="0"/>
+          </a:p>
+          <a:p>
+            <a:pPr indent="0" marL="0">
+              <a:lnSpc>
+                <a:spcPct val="100000"/>
+              </a:lnSpc>
+              <a:buNone/>
+            </a:pPr>
+            <a:r>
+              <a:rPr lang="en-US" sz="1000" dirty="0">
+                <a:solidFill>
+                  <a:srgbClr val="CFE9FE"/>
+                </a:solidFill>
+                <a:latin typeface="Courier New" pitchFamily="34" charset="0"/>
+                <a:ea typeface="Courier New" pitchFamily="34" charset="-122"/>
+                <a:cs typeface="Courier New" pitchFamily="34" charset="-120"/>
+              </a:rPr>
+              <a:t>    </a:t>
+            </a:r>
+            <a:pPr indent="0" marL="0">
+              <a:lnSpc>
+                <a:spcPct val="100000"/>
+              </a:lnSpc>
+              <a:buNone/>
+            </a:pPr>
+            <a:r>
+              <a:rPr lang="en-US" sz="1000" dirty="0">
+                <a:solidFill>
+                  <a:srgbClr val="FE9339"/>
+                </a:solidFill>
+                <a:latin typeface="Courier New" pitchFamily="34" charset="0"/>
+                <a:ea typeface="Courier New" pitchFamily="34" charset="-122"/>
+                <a:cs typeface="Courier New" pitchFamily="34" charset="-120"/>
+              </a:rPr>
+              <a:t>"tasks"</a:t>
+            </a:r>
+            <a:pPr indent="0" marL="0">
+              <a:lnSpc>
+                <a:spcPct val="100000"/>
+              </a:lnSpc>
+              <a:buNone/>
+            </a:pPr>
+            <a:r>
+              <a:rPr lang="en-US" sz="1000" dirty="0">
+                <a:solidFill>
+                  <a:srgbClr val="CFE9FE"/>
+                </a:solidFill>
+                <a:latin typeface="Courier New" pitchFamily="34" charset="0"/>
+                <a:ea typeface="Courier New" pitchFamily="34" charset="-122"/>
+                <a:cs typeface="Courier New" pitchFamily="34" charset="-120"/>
+              </a:rPr>
+              <a:t>: """</a:t>
+            </a:r>
+            <a:endParaRPr lang="en-US" sz="1000" dirty="0"/>
+          </a:p>
+          <a:p>
+            <a:pPr indent="0" marL="0">
+              <a:lnSpc>
+                <a:spcPct val="100000"/>
+              </a:lnSpc>
+              <a:buNone/>
+            </a:pPr>
+            <a:r>
+              <a:rPr lang="en-US" sz="1000" dirty="0">
+                <a:solidFill>
+                  <a:srgbClr val="CFE9FE"/>
+                </a:solidFill>
+                <a:latin typeface="Courier New" pitchFamily="34" charset="0"/>
+                <a:ea typeface="Courier New" pitchFamily="34" charset="-122"/>
+                <a:cs typeface="Courier New" pitchFamily="34" charset="-120"/>
+              </a:rPr>
+              <a:t>    </a:t>
+            </a:r>
+            <a:pPr indent="0" marL="0">
+              <a:lnSpc>
+                <a:spcPct val="100000"/>
+              </a:lnSpc>
+              <a:buNone/>
+            </a:pPr>
+            <a:r>
+              <a:rPr lang="en-US" sz="1000" b="1" dirty="0">
+                <a:solidFill>
+                  <a:srgbClr val="0B9DE0"/>
+                </a:solidFill>
+                <a:latin typeface="Courier New" pitchFamily="34" charset="0"/>
+                <a:ea typeface="Courier New" pitchFamily="34" charset="-122"/>
+                <a:cs typeface="Courier New" pitchFamily="34" charset="-120"/>
+              </a:rPr>
+              <a:t>SELECT</a:t>
+            </a:r>
+            <a:pPr indent="0" marL="0">
+              <a:lnSpc>
+                <a:spcPct val="100000"/>
+              </a:lnSpc>
+              <a:buNone/>
+            </a:pPr>
+            <a:r>
+              <a:rPr lang="en-US" sz="1000" dirty="0">
+                <a:solidFill>
+                  <a:srgbClr val="CFE9FE"/>
+                </a:solidFill>
+                <a:latin typeface="Courier New" pitchFamily="34" charset="0"/>
+                <a:ea typeface="Courier New" pitchFamily="34" charset="-122"/>
+                <a:cs typeface="Courier New" pitchFamily="34" charset="-120"/>
+              </a:rPr>
+              <a:t> WhatId, Subject, CreatedDate, CompletedDateTime,</a:t>
+            </a:r>
+            <a:endParaRPr lang="en-US" sz="1000" dirty="0"/>
+          </a:p>
+          <a:p>
+            <a:pPr indent="0" marL="0">
+              <a:lnSpc>
+                <a:spcPct val="100000"/>
+              </a:lnSpc>
+              <a:buNone/>
+            </a:pPr>
+            <a:r>
+              <a:rPr lang="en-US" sz="1000" dirty="0">
+                <a:solidFill>
+                  <a:srgbClr val="CFE9FE"/>
+                </a:solidFill>
+                <a:latin typeface="Courier New" pitchFamily="34" charset="0"/>
+                <a:ea typeface="Courier New" pitchFamily="34" charset="-122"/>
+                <a:cs typeface="Courier New" pitchFamily="34" charset="-120"/>
+              </a:rPr>
+              <a:t>           OwnerId, Owner.Name, Status</a:t>
+            </a:r>
+            <a:endParaRPr lang="en-US" sz="1000" dirty="0"/>
+          </a:p>
+          <a:p>
+            <a:pPr indent="0" marL="0">
+              <a:lnSpc>
+                <a:spcPct val="100000"/>
+              </a:lnSpc>
+              <a:buNone/>
+            </a:pPr>
+            <a:r>
+              <a:rPr lang="en-US" sz="1000" dirty="0">
+                <a:solidFill>
+                  <a:srgbClr val="CFE9FE"/>
+                </a:solidFill>
+                <a:latin typeface="Courier New" pitchFamily="34" charset="0"/>
+                <a:ea typeface="Courier New" pitchFamily="34" charset="-122"/>
+                <a:cs typeface="Courier New" pitchFamily="34" charset="-120"/>
+              </a:rPr>
+              <a:t>    </a:t>
+            </a:r>
+            <a:pPr indent="0" marL="0">
+              <a:lnSpc>
+                <a:spcPct val="100000"/>
+              </a:lnSpc>
+              <a:buNone/>
+            </a:pPr>
+            <a:r>
+              <a:rPr lang="en-US" sz="1000" b="1" dirty="0">
+                <a:solidFill>
+                  <a:srgbClr val="0B9DE0"/>
+                </a:solidFill>
+                <a:latin typeface="Courier New" pitchFamily="34" charset="0"/>
+                <a:ea typeface="Courier New" pitchFamily="34" charset="-122"/>
+                <a:cs typeface="Courier New" pitchFamily="34" charset="-120"/>
+              </a:rPr>
+              <a:t>FROM</a:t>
+            </a:r>
+            <a:pPr indent="0" marL="0">
+              <a:lnSpc>
+                <a:spcPct val="100000"/>
+              </a:lnSpc>
+              <a:buNone/>
+            </a:pPr>
+            <a:r>
+              <a:rPr lang="en-US" sz="1000" dirty="0">
+                <a:solidFill>
+                  <a:srgbClr val="CFE9FE"/>
+                </a:solidFill>
+                <a:latin typeface="Courier New" pitchFamily="34" charset="0"/>
+                <a:ea typeface="Courier New" pitchFamily="34" charset="-122"/>
+                <a:cs typeface="Courier New" pitchFamily="34" charset="-120"/>
+              </a:rPr>
+              <a:t> Task</a:t>
+            </a:r>
+            <a:endParaRPr lang="en-US" sz="1000" dirty="0"/>
+          </a:p>
+          <a:p>
+            <a:pPr indent="0" marL="0">
+              <a:lnSpc>
+                <a:spcPct val="100000"/>
+              </a:lnSpc>
+              <a:buNone/>
+            </a:pPr>
+            <a:r>
+              <a:rPr lang="en-US" sz="1000" dirty="0">
+                <a:solidFill>
+                  <a:srgbClr val="CFE9FE"/>
+                </a:solidFill>
+                <a:latin typeface="Courier New" pitchFamily="34" charset="0"/>
+                <a:ea typeface="Courier New" pitchFamily="34" charset="-122"/>
+                <a:cs typeface="Courier New" pitchFamily="34" charset="-120"/>
+              </a:rPr>
+              <a:t>    </a:t>
+            </a:r>
+            <a:pPr indent="0" marL="0">
+              <a:lnSpc>
+                <a:spcPct val="100000"/>
+              </a:lnSpc>
+              <a:buNone/>
+            </a:pPr>
+            <a:r>
+              <a:rPr lang="en-US" sz="1000" b="1" dirty="0">
+                <a:solidFill>
+                  <a:srgbClr val="0B9DE0"/>
+                </a:solidFill>
+                <a:latin typeface="Courier New" pitchFamily="34" charset="0"/>
+                <a:ea typeface="Courier New" pitchFamily="34" charset="-122"/>
+                <a:cs typeface="Courier New" pitchFamily="34" charset="-120"/>
+              </a:rPr>
+              <a:t>WHERE</a:t>
+            </a:r>
+            <a:pPr indent="0" marL="0">
+              <a:lnSpc>
+                <a:spcPct val="100000"/>
+              </a:lnSpc>
+              <a:buNone/>
+            </a:pPr>
+            <a:r>
+              <a:rPr lang="en-US" sz="1000" dirty="0">
+                <a:solidFill>
+                  <a:srgbClr val="CFE9FE"/>
+                </a:solidFill>
+                <a:latin typeface="Courier New" pitchFamily="34" charset="0"/>
+                <a:ea typeface="Courier New" pitchFamily="34" charset="-122"/>
+                <a:cs typeface="Courier New" pitchFamily="34" charset="-120"/>
+              </a:rPr>
+              <a:t> What.Type = </a:t>
+            </a:r>
+            <a:pPr indent="0" marL="0">
+              <a:lnSpc>
+                <a:spcPct val="100000"/>
+              </a:lnSpc>
+              <a:buNone/>
+            </a:pPr>
+            <a:r>
+              <a:rPr lang="en-US" sz="1000" dirty="0">
+                <a:solidFill>
+                  <a:srgbClr val="FE9339"/>
+                </a:solidFill>
+                <a:latin typeface="Courier New" pitchFamily="34" charset="0"/>
+                <a:ea typeface="Courier New" pitchFamily="34" charset="-122"/>
+                <a:cs typeface="Courier New" pitchFamily="34" charset="-120"/>
+              </a:rPr>
+              <a:t>'Opportunity'</a:t>
+            </a:r>
+            <a:pPr indent="0" marL="0">
+              <a:lnSpc>
+                <a:spcPct val="100000"/>
+              </a:lnSpc>
+              <a:buNone/>
+            </a:pPr>
+            <a:r>
+              <a:rPr lang="en-US" sz="1000" dirty="0">
+                <a:solidFill>
+                  <a:srgbClr val="FE9339"/>
+                </a:solidFill>
+                <a:latin typeface="Courier New" pitchFamily="34" charset="0"/>
+                <a:ea typeface="Courier New" pitchFamily="34" charset="-122"/>
+                <a:cs typeface="Courier New" pitchFamily="34" charset="-120"/>
+              </a:rPr>
+              <a:t>""",</a:t>
+            </a:r>
+            <a:endParaRPr lang="en-US" sz="1000" dirty="0"/>
+          </a:p>
+          <a:p>
+            <a:pPr indent="0" marL="0">
+              <a:lnSpc>
+                <a:spcPct val="100000"/>
+              </a:lnSpc>
+              <a:buNone/>
+            </a:pPr>
+            <a:r>
+              <a:rPr lang="en-US" sz="1000" dirty="0">
+                <a:solidFill>
+                  <a:srgbClr val="CFE9FE"/>
+                </a:solidFill>
+                <a:latin typeface="Courier New" pitchFamily="34" charset="0"/>
+                <a:ea typeface="Courier New" pitchFamily="34" charset="-122"/>
+                <a:cs typeface="Courier New" pitchFamily="34" charset="-120"/>
+              </a:rPr>
+              <a:t>    </a:t>
+            </a:r>
+            <a:pPr indent="0" marL="0">
+              <a:lnSpc>
+                <a:spcPct val="100000"/>
+              </a:lnSpc>
+              <a:buNone/>
+            </a:pPr>
+            <a:r>
+              <a:rPr lang="en-US" sz="1000" dirty="0">
+                <a:solidFill>
+                  <a:srgbClr val="FE9339"/>
+                </a:solidFill>
+                <a:latin typeface="Courier New" pitchFamily="34" charset="0"/>
+                <a:ea typeface="Courier New" pitchFamily="34" charset="-122"/>
+                <a:cs typeface="Courier New" pitchFamily="34" charset="-120"/>
+              </a:rPr>
+              <a:t>"leads"</a:t>
+            </a:r>
+            <a:pPr indent="0" marL="0">
+              <a:lnSpc>
+                <a:spcPct val="100000"/>
+              </a:lnSpc>
+              <a:buNone/>
+            </a:pPr>
+            <a:r>
+              <a:rPr lang="en-US" sz="1000" dirty="0">
+                <a:solidFill>
+                  <a:srgbClr val="CFE9FE"/>
+                </a:solidFill>
+                <a:latin typeface="Courier New" pitchFamily="34" charset="0"/>
+                <a:ea typeface="Courier New" pitchFamily="34" charset="-122"/>
+                <a:cs typeface="Courier New" pitchFamily="34" charset="-120"/>
+              </a:rPr>
+              <a:t>: """</a:t>
+            </a:r>
+            <a:endParaRPr lang="en-US" sz="1000" dirty="0"/>
+          </a:p>
+          <a:p>
+            <a:pPr indent="0" marL="0">
+              <a:lnSpc>
+                <a:spcPct val="100000"/>
+              </a:lnSpc>
+              <a:buNone/>
+            </a:pPr>
+            <a:r>
+              <a:rPr lang="en-US" sz="1000" dirty="0">
+                <a:solidFill>
+                  <a:srgbClr val="CFE9FE"/>
+                </a:solidFill>
+                <a:latin typeface="Courier New" pitchFamily="34" charset="0"/>
+                <a:ea typeface="Courier New" pitchFamily="34" charset="-122"/>
+                <a:cs typeface="Courier New" pitchFamily="34" charset="-120"/>
+              </a:rPr>
+              <a:t>    </a:t>
+            </a:r>
+            <a:pPr indent="0" marL="0">
+              <a:lnSpc>
+                <a:spcPct val="100000"/>
+              </a:lnSpc>
+              <a:buNone/>
+            </a:pPr>
+            <a:r>
+              <a:rPr lang="en-US" sz="1000" b="1" dirty="0">
+                <a:solidFill>
+                  <a:srgbClr val="0B9DE0"/>
+                </a:solidFill>
+                <a:latin typeface="Courier New" pitchFamily="34" charset="0"/>
+                <a:ea typeface="Courier New" pitchFamily="34" charset="-122"/>
+                <a:cs typeface="Courier New" pitchFamily="34" charset="-120"/>
+              </a:rPr>
+              <a:t>SELECT</a:t>
+            </a:r>
+            <a:pPr indent="0" marL="0">
+              <a:lnSpc>
+                <a:spcPct val="100000"/>
+              </a:lnSpc>
+              <a:buNone/>
+            </a:pPr>
+            <a:r>
+              <a:rPr lang="en-US" sz="1000" dirty="0">
+                <a:solidFill>
+                  <a:srgbClr val="CFE9FE"/>
+                </a:solidFill>
+                <a:latin typeface="Courier New" pitchFamily="34" charset="0"/>
+                <a:ea typeface="Courier New" pitchFamily="34" charset="-122"/>
+                <a:cs typeface="Courier New" pitchFamily="34" charset="-120"/>
+              </a:rPr>
+              <a:t> Id, CreatedDate, ConvertedDate, ConvertedOpportunityId,</a:t>
+            </a:r>
+            <a:endParaRPr lang="en-US" sz="1000" dirty="0"/>
+          </a:p>
+          <a:p>
+            <a:pPr indent="0" marL="0">
+              <a:lnSpc>
+                <a:spcPct val="100000"/>
+              </a:lnSpc>
+              <a:buNone/>
+            </a:pPr>
+            <a:r>
+              <a:rPr lang="en-US" sz="1000" dirty="0">
+                <a:solidFill>
+                  <a:srgbClr val="CFE9FE"/>
+                </a:solidFill>
+                <a:latin typeface="Courier New" pitchFamily="34" charset="0"/>
+                <a:ea typeface="Courier New" pitchFamily="34" charset="-122"/>
+                <a:cs typeface="Courier New" pitchFamily="34" charset="-120"/>
+              </a:rPr>
+              <a:t>           OwnerId, Owner.Name</a:t>
+            </a:r>
+            <a:endParaRPr lang="en-US" sz="1000" dirty="0"/>
+          </a:p>
+          <a:p>
+            <a:pPr indent="0" marL="0">
+              <a:lnSpc>
+                <a:spcPct val="100000"/>
+              </a:lnSpc>
+              <a:buNone/>
+            </a:pPr>
+            <a:r>
+              <a:rPr lang="en-US" sz="1000" dirty="0">
+                <a:solidFill>
+                  <a:srgbClr val="CFE9FE"/>
+                </a:solidFill>
+                <a:latin typeface="Courier New" pitchFamily="34" charset="0"/>
+                <a:ea typeface="Courier New" pitchFamily="34" charset="-122"/>
+                <a:cs typeface="Courier New" pitchFamily="34" charset="-120"/>
+              </a:rPr>
+              <a:t>    </a:t>
+            </a:r>
+            <a:pPr indent="0" marL="0">
+              <a:lnSpc>
+                <a:spcPct val="100000"/>
+              </a:lnSpc>
+              <a:buNone/>
+            </a:pPr>
+            <a:r>
+              <a:rPr lang="en-US" sz="1000" b="1" dirty="0">
+                <a:solidFill>
+                  <a:srgbClr val="0B9DE0"/>
+                </a:solidFill>
+                <a:latin typeface="Courier New" pitchFamily="34" charset="0"/>
+                <a:ea typeface="Courier New" pitchFamily="34" charset="-122"/>
+                <a:cs typeface="Courier New" pitchFamily="34" charset="-120"/>
+              </a:rPr>
+              <a:t>FROM</a:t>
+            </a:r>
+            <a:pPr indent="0" marL="0">
+              <a:lnSpc>
+                <a:spcPct val="100000"/>
+              </a:lnSpc>
+              <a:buNone/>
+            </a:pPr>
+            <a:r>
+              <a:rPr lang="en-US" sz="1000" dirty="0">
+                <a:solidFill>
+                  <a:srgbClr val="CFE9FE"/>
+                </a:solidFill>
+                <a:latin typeface="Courier New" pitchFamily="34" charset="0"/>
+                <a:ea typeface="Courier New" pitchFamily="34" charset="-122"/>
+                <a:cs typeface="Courier New" pitchFamily="34" charset="-120"/>
+              </a:rPr>
+              <a:t> Lead</a:t>
+            </a:r>
+            <a:endParaRPr lang="en-US" sz="1000" dirty="0"/>
+          </a:p>
+          <a:p>
+            <a:pPr indent="0" marL="0">
+              <a:lnSpc>
+                <a:spcPct val="100000"/>
+              </a:lnSpc>
+              <a:buNone/>
+            </a:pPr>
+            <a:r>
+              <a:rPr lang="en-US" sz="1000" dirty="0">
+                <a:solidFill>
+                  <a:srgbClr val="CFE9FE"/>
+                </a:solidFill>
+                <a:latin typeface="Courier New" pitchFamily="34" charset="0"/>
+                <a:ea typeface="Courier New" pitchFamily="34" charset="-122"/>
+                <a:cs typeface="Courier New" pitchFamily="34" charset="-120"/>
+              </a:rPr>
+              <a:t>    </a:t>
+            </a:r>
+            <a:pPr indent="0" marL="0">
+              <a:lnSpc>
+                <a:spcPct val="100000"/>
+              </a:lnSpc>
+              <a:buNone/>
+            </a:pPr>
+            <a:r>
+              <a:rPr lang="en-US" sz="1000" b="1" dirty="0">
+                <a:solidFill>
+                  <a:srgbClr val="0B9DE0"/>
+                </a:solidFill>
+                <a:latin typeface="Courier New" pitchFamily="34" charset="0"/>
+                <a:ea typeface="Courier New" pitchFamily="34" charset="-122"/>
+                <a:cs typeface="Courier New" pitchFamily="34" charset="-120"/>
+              </a:rPr>
+              <a:t>WHERE</a:t>
+            </a:r>
+            <a:pPr indent="0" marL="0">
+              <a:lnSpc>
+                <a:spcPct val="100000"/>
+              </a:lnSpc>
+              <a:buNone/>
+            </a:pPr>
+            <a:r>
+              <a:rPr lang="en-US" sz="1000" dirty="0">
+                <a:solidFill>
+                  <a:srgbClr val="CFE9FE"/>
+                </a:solidFill>
+                <a:latin typeface="Courier New" pitchFamily="34" charset="0"/>
+                <a:ea typeface="Courier New" pitchFamily="34" charset="-122"/>
+                <a:cs typeface="Courier New" pitchFamily="34" charset="-120"/>
+              </a:rPr>
+              <a:t> IsConverted = true</a:t>
+            </a:r>
+            <a:endParaRPr lang="en-US" sz="1000" dirty="0"/>
+          </a:p>
+          <a:p>
+            <a:pPr indent="0" marL="0">
+              <a:lnSpc>
+                <a:spcPct val="100000"/>
+              </a:lnSpc>
+              <a:buNone/>
+            </a:pPr>
+            <a:r>
+              <a:rPr lang="en-US" sz="1000" dirty="0">
+                <a:solidFill>
+                  <a:srgbClr val="CFE9FE"/>
+                </a:solidFill>
+                <a:latin typeface="Courier New" pitchFamily="34" charset="0"/>
+                <a:ea typeface="Courier New" pitchFamily="34" charset="-122"/>
+                <a:cs typeface="Courier New" pitchFamily="34" charset="-120"/>
+              </a:rPr>
+              <a:t>      </a:t>
+            </a:r>
+            <a:pPr indent="0" marL="0">
+              <a:lnSpc>
+                <a:spcPct val="100000"/>
+              </a:lnSpc>
+              <a:buNone/>
+            </a:pPr>
+            <a:r>
+              <a:rPr lang="en-US" sz="1000" b="1" dirty="0">
+                <a:solidFill>
+                  <a:srgbClr val="0B9DE0"/>
+                </a:solidFill>
+                <a:latin typeface="Courier New" pitchFamily="34" charset="0"/>
+                <a:ea typeface="Courier New" pitchFamily="34" charset="-122"/>
+                <a:cs typeface="Courier New" pitchFamily="34" charset="-120"/>
+              </a:rPr>
+              <a:t>AND</a:t>
+            </a:r>
+            <a:pPr indent="0" marL="0">
+              <a:lnSpc>
+                <a:spcPct val="100000"/>
+              </a:lnSpc>
+              <a:buNone/>
+            </a:pPr>
+            <a:r>
+              <a:rPr lang="en-US" sz="1000" dirty="0">
+                <a:solidFill>
+                  <a:srgbClr val="CFE9FE"/>
+                </a:solidFill>
+                <a:latin typeface="Courier New" pitchFamily="34" charset="0"/>
+                <a:ea typeface="Courier New" pitchFamily="34" charset="-122"/>
+                <a:cs typeface="Courier New" pitchFamily="34" charset="-120"/>
+              </a:rPr>
+              <a:t> ConvertedOpportunityId != null""",</a:t>
+            </a:r>
+            <a:endParaRPr lang="en-US" sz="1000" dirty="0"/>
+          </a:p>
+          <a:p>
+            <a:pPr indent="0" marL="0">
+              <a:lnSpc>
+                <a:spcPct val="100000"/>
+              </a:lnSpc>
+              <a:buNone/>
+            </a:pPr>
+            <a:r>
+              <a:rPr lang="en-US" sz="1000" dirty="0">
+                <a:solidFill>
+                  <a:srgbClr val="CFE9FE"/>
+                </a:solidFill>
+                <a:latin typeface="Courier New" pitchFamily="34" charset="0"/>
+                <a:ea typeface="Courier New" pitchFamily="34" charset="-122"/>
+                <a:cs typeface="Courier New" pitchFamily="34" charset="-120"/>
+              </a:rPr>
+              <a:t>}</a:t>
+            </a:r>
+            <a:endParaRPr lang="en-US" sz="1000" dirty="0"/>
+          </a:p>
+        </p:txBody>
+      </p:sp>
+      <p:sp>
+        <p:nvSpPr>
+          <p:cNvPr id="12" name="Code caption"/>
+          <p:cNvSpPr txBox="1"/>
+          <p:nvPr/>
+        </p:nvSpPr>
+        <p:spPr>
+          <a:xfrm>
+            <a:off x="5897880" y="5669280"/>
+            <a:ext cx="5715000" cy="685800"/>
+          </a:xfrm>
+          <a:prstGeom prst="rect">
+            <a:avLst/>
+          </a:prstGeom>
+          <a:noFill/>
+          <a:ln/>
+        </p:spPr>
+        <p:txBody>
+          <a:bodyPr wrap="square" lIns="0" tIns="0" rIns="0" bIns="0" rtlCol="0" anchor="t"/>
+          <a:lstStyle/>
+          <a:p>
+            <a:pPr indent="0" marL="0">
+              <a:buNone/>
+            </a:pPr>
+            <a:r>
+              <a:rPr lang="en-US" sz="1400" b="1" dirty="0">
                 <a:solidFill>
                   <a:schemeClr val="tx2"/>
                 </a:solidFill>
               </a:rPr>
-              <a:t>Seed</a:t>
-            </a:r>
-            <a:endParaRPr lang="en-US" sz="1600" dirty="0"/>
-          </a:p>
-        </p:txBody>
-      </p:sp>
-      <p:sp>
-        <p:nvSpPr>
-          <p:cNvPr id="16" name="Key step 2 body"/>
-          <p:cNvSpPr txBox="1"/>
-          <p:nvPr/>
-        </p:nvSpPr>
-        <p:spPr>
-          <a:xfrm>
-            <a:off x="9418320" y="2377440"/>
-            <a:ext cx="2057400" cy="1143000"/>
-          </a:xfrm>
-          <a:prstGeom prst="rect">
-            <a:avLst/>
-          </a:prstGeom>
-          <a:noFill/>
-          <a:ln/>
-        </p:spPr>
-        <p:txBody>
-          <a:bodyPr wrap="square" lIns="0" tIns="0" rIns="0" bIns="0" rtlCol="0" anchor="t"/>
-          <a:lstStyle/>
-          <a:p>
+              <a:t>extract.py: </a:t>
+            </a:r>
             <a:pPr indent="0" marL="0">
               <a:buNone/>
             </a:pPr>
             <a:r>
               <a:rPr lang="en-US" sz="1400" dirty="0">
                 <a:solidFill>
-                  <a:schemeClr val="tx1"/>
-                </a:solidFill>
-              </a:rPr>
-              <a:t>seed.py loads 40 [Demo] deals and walks them through the org's own stages.</a:t>
-            </a:r>
-            <a:endParaRPr lang="en-US" sz="1400" dirty="0"/>
-          </a:p>
-        </p:txBody>
-      </p:sp>
-      <p:sp>
-        <p:nvSpPr>
-          <p:cNvPr id="17" name="Key step 3 card"/>
-          <p:cNvSpPr/>
-          <p:nvPr/>
-        </p:nvSpPr>
-        <p:spPr>
-          <a:xfrm>
-            <a:off x="548640" y="3794760"/>
-            <a:ext cx="5440680" cy="2331720"/>
-          </a:xfrm>
-          <a:prstGeom prst="roundRect">
-            <a:avLst>
-              <a:gd name="adj" fmla="val 4706"/>
-            </a:avLst>
-          </a:prstGeom>
-          <a:solidFill>
-            <a:schemeClr val="bg2"/>
-          </a:solidFill>
-          <a:ln/>
-        </p:spPr>
-      </p:sp>
-      <p:sp>
-        <p:nvSpPr>
-          <p:cNvPr id="18" name="Key step 3 frame"/>
-          <p:cNvSpPr/>
-          <p:nvPr/>
-        </p:nvSpPr>
-        <p:spPr>
-          <a:xfrm>
-            <a:off x="658368" y="4152319"/>
-            <a:ext cx="2980944" cy="1616601"/>
-          </a:xfrm>
-          <a:prstGeom prst="rect">
-            <a:avLst/>
-          </a:prstGeom>
-          <a:solidFill>
-            <a:schemeClr val="bg1"/>
-          </a:solidFill>
-          <a:ln w="12700">
-            <a:solidFill>
-              <a:schemeClr val="accent3"/>
-            </a:solidFill>
-            <a:prstDash val="solid"/>
-          </a:ln>
-        </p:spPr>
-      </p:sp>
-      <p:pic>
-        <p:nvPicPr>
-          <p:cNvPr id="19" name="Key step 3 image" descr="OpportunityHistory and Task become events, one case per Opportunity. Shown: a re-quote loop.">    </p:cNvPr>
-          <p:cNvPicPr>
-            <a:picLocks noChangeAspect="1"/>
-          </p:cNvPicPr>
-          <p:nvPr/>
-        </p:nvPicPr>
-        <p:blipFill>
-          <a:blip r:embed="rId3"/>
-          <a:stretch>
-            <a:fillRect/>
-          </a:stretch>
-        </p:blipFill>
-        <p:spPr>
-          <a:xfrm>
-            <a:off x="685800" y="4179751"/>
-            <a:ext cx="2926080" cy="1561737"/>
-          </a:xfrm>
-          <a:prstGeom prst="rect">
-            <a:avLst/>
-          </a:prstGeom>
-        </p:spPr>
-      </p:pic>
-      <p:sp>
-        <p:nvSpPr>
-          <p:cNvPr id="20" name="Key step 3 marker"/>
-          <p:cNvSpPr/>
-          <p:nvPr/>
-        </p:nvSpPr>
-        <p:spPr>
-          <a:xfrm>
-            <a:off x="3794760" y="4023360"/>
-            <a:ext cx="411480" cy="411480"/>
-          </a:xfrm>
-          <a:prstGeom prst="ellipse">
-            <a:avLst/>
-          </a:prstGeom>
-          <a:solidFill>
-            <a:schemeClr val="accent1"/>
-          </a:solidFill>
-          <a:ln/>
-        </p:spPr>
-      </p:sp>
-      <p:sp>
-        <p:nvSpPr>
-          <p:cNvPr id="21" name="Key step 3 number"/>
-          <p:cNvSpPr txBox="1"/>
-          <p:nvPr/>
-        </p:nvSpPr>
-        <p:spPr>
-          <a:xfrm>
-            <a:off x="3794760" y="4023360"/>
-            <a:ext cx="411480" cy="411480"/>
-          </a:xfrm>
-          <a:prstGeom prst="rect">
-            <a:avLst/>
-          </a:prstGeom>
-          <a:noFill/>
-          <a:ln/>
-        </p:spPr>
-        <p:txBody>
-          <a:bodyPr wrap="square" lIns="0" tIns="0" rIns="0" bIns="0" rtlCol="0" anchor="ctr"/>
-          <a:lstStyle/>
-          <a:p>
-            <a:pPr algn="ctr" indent="0" marL="0">
-              <a:buNone/>
-            </a:pPr>
-            <a:r>
-              <a:rPr lang="en-US" sz="1600" b="1" dirty="0">
-                <a:solidFill>
-                  <a:schemeClr val="bg1"/>
-                </a:solidFill>
-              </a:rPr>
-              <a:t>3</a:t>
-            </a:r>
-            <a:endParaRPr lang="en-US" sz="1600" dirty="0"/>
-          </a:p>
-        </p:txBody>
-      </p:sp>
-      <p:sp>
-        <p:nvSpPr>
-          <p:cNvPr id="22" name="Key step 3 title"/>
-          <p:cNvSpPr txBox="1"/>
-          <p:nvPr/>
-        </p:nvSpPr>
-        <p:spPr>
-          <a:xfrm>
-            <a:off x="3794760" y="4526280"/>
-            <a:ext cx="2057400" cy="365760"/>
-          </a:xfrm>
-          <a:prstGeom prst="rect">
-            <a:avLst/>
-          </a:prstGeom>
-          <a:noFill/>
-          <a:ln/>
-        </p:spPr>
-        <p:txBody>
-          <a:bodyPr wrap="square" lIns="0" tIns="0" rIns="0" bIns="0" rtlCol="0" anchor="t"/>
-          <a:lstStyle/>
-          <a:p>
-            <a:pPr indent="0" marL="0">
-              <a:buNone/>
-            </a:pPr>
-            <a:r>
-              <a:rPr lang="en-US" sz="1600" b="1" dirty="0">
-                <a:solidFill>
                   <a:schemeClr val="tx2"/>
                 </a:solidFill>
               </a:rPr>
-              <a:t>Extract</a:t>
-            </a:r>
-            <a:endParaRPr lang="en-US" sz="1600" dirty="0"/>
-          </a:p>
-        </p:txBody>
-      </p:sp>
-      <p:sp>
-        <p:nvSpPr>
-          <p:cNvPr id="23" name="Key step 3 body"/>
-          <p:cNvSpPr txBox="1"/>
-          <p:nvPr/>
-        </p:nvSpPr>
-        <p:spPr>
-          <a:xfrm>
-            <a:off x="3794760" y="4892040"/>
-            <a:ext cx="2057400" cy="1143000"/>
-          </a:xfrm>
-          <a:prstGeom prst="rect">
-            <a:avLst/>
-          </a:prstGeom>
-          <a:noFill/>
-          <a:ln/>
-        </p:spPr>
-        <p:txBody>
-          <a:bodyPr wrap="square" lIns="0" tIns="0" rIns="0" bIns="0" rtlCol="0" anchor="t"/>
-          <a:lstStyle/>
-          <a:p>
-            <a:pPr indent="0" marL="0">
-              <a:buNone/>
-            </a:pPr>
-            <a:r>
-              <a:rPr lang="en-US" sz="1400" dirty="0">
-                <a:solidFill>
-                  <a:schemeClr val="tx1"/>
-                </a:solidFill>
-              </a:rPr>
-              <a:t>OpportunityHistory and Task become events, one case per Opportunity. Shown: a re-quote loop.</a:t>
-            </a:r>
-            <a:endParaRPr lang="en-US" sz="1400" dirty="0"/>
-          </a:p>
-        </p:txBody>
-      </p:sp>
-      <p:sp>
-        <p:nvSpPr>
-          <p:cNvPr id="24" name="Key step 4 card"/>
-          <p:cNvSpPr/>
-          <p:nvPr/>
-        </p:nvSpPr>
-        <p:spPr>
-          <a:xfrm>
-            <a:off x="6172200" y="3794760"/>
-            <a:ext cx="5440680" cy="2331720"/>
-          </a:xfrm>
-          <a:prstGeom prst="roundRect">
-            <a:avLst>
-              <a:gd name="adj" fmla="val 4706"/>
-            </a:avLst>
-          </a:prstGeom>
-          <a:solidFill>
-            <a:schemeClr val="bg2"/>
-          </a:solidFill>
-          <a:ln/>
-        </p:spPr>
-      </p:sp>
-      <p:sp>
-        <p:nvSpPr>
-          <p:cNvPr id="25" name="Key step 4 frame"/>
-          <p:cNvSpPr/>
-          <p:nvPr/>
-        </p:nvSpPr>
-        <p:spPr>
-          <a:xfrm>
-            <a:off x="6281928" y="3949420"/>
-            <a:ext cx="2980944" cy="2022401"/>
-          </a:xfrm>
-          <a:prstGeom prst="rect">
-            <a:avLst/>
-          </a:prstGeom>
-          <a:solidFill>
-            <a:schemeClr val="bg1"/>
-          </a:solidFill>
-          <a:ln w="12700">
-            <a:solidFill>
-              <a:schemeClr val="accent3"/>
-            </a:solidFill>
-            <a:prstDash val="solid"/>
-          </a:ln>
-        </p:spPr>
-      </p:sp>
-      <p:pic>
-        <p:nvPicPr>
-          <p:cNvPr id="26" name="Key step 4 image" descr="The event log (CSV / XES) feeds the hosted dashboard and value case.">    </p:cNvPr>
-          <p:cNvPicPr>
-            <a:picLocks noChangeAspect="1"/>
-          </p:cNvPicPr>
-          <p:nvPr/>
-        </p:nvPicPr>
-        <p:blipFill>
-          <a:blip r:embed="rId4"/>
-          <a:stretch>
-            <a:fillRect/>
-          </a:stretch>
-        </p:blipFill>
-        <p:spPr>
-          <a:xfrm>
-            <a:off x="6309360" y="3976852"/>
-            <a:ext cx="2926080" cy="1967537"/>
-          </a:xfrm>
-          <a:prstGeom prst="rect">
-            <a:avLst/>
-          </a:prstGeom>
-        </p:spPr>
-      </p:pic>
-      <p:sp>
-        <p:nvSpPr>
-          <p:cNvPr id="27" name="Key step 4 marker"/>
-          <p:cNvSpPr/>
-          <p:nvPr/>
-        </p:nvSpPr>
-        <p:spPr>
-          <a:xfrm>
-            <a:off x="9418320" y="4023360"/>
-            <a:ext cx="411480" cy="411480"/>
-          </a:xfrm>
-          <a:prstGeom prst="ellipse">
-            <a:avLst/>
-          </a:prstGeom>
-          <a:solidFill>
-            <a:schemeClr val="accent1"/>
-          </a:solidFill>
-          <a:ln/>
-        </p:spPr>
-      </p:sp>
-      <p:sp>
-        <p:nvSpPr>
-          <p:cNvPr id="28" name="Key step 4 number"/>
-          <p:cNvSpPr txBox="1"/>
-          <p:nvPr/>
-        </p:nvSpPr>
-        <p:spPr>
-          <a:xfrm>
-            <a:off x="9418320" y="4023360"/>
-            <a:ext cx="411480" cy="411480"/>
-          </a:xfrm>
-          <a:prstGeom prst="rect">
-            <a:avLst/>
-          </a:prstGeom>
-          <a:noFill/>
-          <a:ln/>
-        </p:spPr>
-        <p:txBody>
-          <a:bodyPr wrap="square" lIns="0" tIns="0" rIns="0" bIns="0" rtlCol="0" anchor="ctr"/>
-          <a:lstStyle/>
-          <a:p>
-            <a:pPr algn="ctr" indent="0" marL="0">
-              <a:buNone/>
-            </a:pPr>
-            <a:r>
-              <a:rPr lang="en-US" sz="1600" b="1" dirty="0">
-                <a:solidFill>
-                  <a:schemeClr val="bg1"/>
-                </a:solidFill>
-              </a:rPr>
-              <a:t>4</a:t>
-            </a:r>
-            <a:endParaRPr lang="en-US" sz="1600" dirty="0"/>
-          </a:p>
-        </p:txBody>
-      </p:sp>
-      <p:sp>
-        <p:nvSpPr>
-          <p:cNvPr id="29" name="Key step 4 title"/>
-          <p:cNvSpPr txBox="1"/>
-          <p:nvPr/>
-        </p:nvSpPr>
-        <p:spPr>
-          <a:xfrm>
-            <a:off x="9418320" y="4526280"/>
-            <a:ext cx="2057400" cy="365760"/>
-          </a:xfrm>
-          <a:prstGeom prst="rect">
-            <a:avLst/>
-          </a:prstGeom>
-          <a:noFill/>
-          <a:ln/>
-        </p:spPr>
-        <p:txBody>
-          <a:bodyPr wrap="square" lIns="0" tIns="0" rIns="0" bIns="0" rtlCol="0" anchor="t"/>
-          <a:lstStyle/>
-          <a:p>
-            <a:pPr indent="0" marL="0">
-              <a:buNone/>
-            </a:pPr>
-            <a:r>
-              <a:rPr lang="en-US" sz="1600" b="1" dirty="0">
-                <a:solidFill>
-                  <a:schemeClr val="tx2"/>
-                </a:solidFill>
-              </a:rPr>
-              <a:t>Mine and publish</a:t>
-            </a:r>
-            <a:endParaRPr lang="en-US" sz="1600" dirty="0"/>
-          </a:p>
-        </p:txBody>
-      </p:sp>
-      <p:sp>
-        <p:nvSpPr>
-          <p:cNvPr id="30" name="Key step 4 body"/>
-          <p:cNvSpPr txBox="1"/>
-          <p:nvPr/>
-        </p:nvSpPr>
-        <p:spPr>
-          <a:xfrm>
-            <a:off x="9418320" y="4892040"/>
-            <a:ext cx="2057400" cy="1143000"/>
-          </a:xfrm>
-          <a:prstGeom prst="rect">
-            <a:avLst/>
-          </a:prstGeom>
-          <a:noFill/>
-          <a:ln/>
-        </p:spPr>
-        <p:txBody>
-          <a:bodyPr wrap="square" lIns="0" tIns="0" rIns="0" bIns="0" rtlCol="0" anchor="t"/>
-          <a:lstStyle/>
-          <a:p>
-            <a:pPr indent="0" marL="0">
-              <a:buNone/>
-            </a:pPr>
-            <a:r>
-              <a:rPr lang="en-US" sz="1400" dirty="0">
-                <a:solidFill>
-                  <a:schemeClr val="tx1"/>
-                </a:solidFill>
-              </a:rPr>
-              <a:t>The event log (CSV / XES) feeds the hosted dashboard and value case.</a:t>
+              <a:t>four SOQL queries over the REST API, signed by the Salesforce CLI session. Opportunity Id becomes the case ID.</a:t>
             </a:r>
             <a:endParaRPr lang="en-US" sz="1400" dirty="0"/>
           </a:p>

</xml_diff>

<commit_message>
Deck: split tech setup into its own deck, add numbered callouts
The story deck is now six slides. The tech setup deck has a title, the
org/SOQL evidence slide with numbered popups, and the live-links slide.

Co-Authored-By: Claude Opus 5.5 <noreply@anthropic.com>
</commit_message>
<xml_diff>
--- a/deck/salesforce-process-intelligence.pptx
+++ b/deck/salesforce-process-intelligence.pptx
@@ -11,11 +11,9 @@
     <p:sldId id="259" r:id="rId5"/>
     <p:sldId id="260" r:id="rId6"/>
     <p:sldId id="261" r:id="rId7"/>
-    <p:sldId id="262" r:id="rId8"/>
-    <p:sldId id="263" r:id="rId9"/>
   </p:sldIdLst>
   <p:notesMasterIdLst>
-    <p:notesMasterId r:id="rId10"/>
+    <p:notesMasterId r:id="rId8"/>
   </p:notesMasterIdLst>
   <p:sldSz cx="12192000" cy="6858000"/>
   <p:notesSz cx="6858000" cy="12192000"/>
@@ -114,32 +112,26 @@
   <p:extLst>
     <p:ext uri="{521415D9-36F7-43E2-AB2F-B90AF26B5E84}">
       <p14:sectionLst xmlns:p14="http://schemas.microsoft.com/office/powerpoint/2010/main">
-        <p14:section name="Opening" id="{cea02240-3fcf-10ae-6263-30fbd8c30f57}">
+        <p14:section name="Opening" id="{b87f9b5a-8c23-0298-4637-f3eef46d7f19}">
           <p14:sldIdLst>
             <p14:sldId id="256"/>
             <p14:sldId id="257"/>
           </p14:sldIdLst>
         </p14:section>
-        <p14:section name="Evidence" id="{4006877a-e396-3548-454c-fcd91d84a0df}">
+        <p14:section name="Evidence" id="{dcb4ef80-7e70-5379-1753-03bc14d16646}">
           <p14:sldIdLst>
             <p14:sldId id="258"/>
             <p14:sldId id="259"/>
           </p14:sldIdLst>
         </p14:section>
-        <p14:section name="Value" id="{2a5f094b-0090-a4f9-b8cc-53fb2d756d58}">
+        <p14:section name="Value" id="{7b0a5b99-2548-4d99-cde0-9339839278f9}">
           <p14:sldIdLst>
             <p14:sldId id="260"/>
           </p14:sldIdLst>
         </p14:section>
-        <p14:section name="Tech setup" id="{82d0bfbe-626b-3fa9-d2b6-98154d9de801}">
+        <p14:section name="Close" id="{020c7d8d-8fb0-4948-27e5-c03d0b5c69a7}">
           <p14:sldIdLst>
             <p14:sldId id="261"/>
-            <p14:sldId id="262"/>
-          </p14:sldIdLst>
-        </p14:section>
-        <p14:section name="Close" id="{b9043b03-107a-2b7d-1f74-464bac0320d0}">
-          <p14:sldIdLst>
-            <p14:sldId id="263"/>
           </p14:sldIdLst>
         </p14:section>
       </p14:sectionLst>
@@ -1831,7 +1823,7 @@
           <a:p>
             <a:r>
               <a:rPr lang="en-US" dirty="0"/>
-              <a:t>Left: the trial org standing in for a client's CRM, seeded by seed.py so there's real OpportunityHistory to read. Right: the exact SOQL the extractor runs. Opportunity is the case; leads join via ConvertedOpportunityId and tasks via WhatId. Trial orgs can't backdate history, so the 10-month dataset is simulated in the same object shape.</a:t>
+              <a:t>Close on the decision: validate on production data, pilot one policy change, then monitor value realised in Apromore.</a:t>
             </a:r>
             <a:endParaRPr lang="en-US" dirty="0"/>
           </a:p>
@@ -1855,182 +1847,6 @@
             <a:fld id="{F7021451-1387-4CA6-816F-3879F97B5CBC}" type="slidenum">
               <a:rPr lang="en-US"/>
               <a:t>6</a:t>
-            </a:fld>
-            <a:endParaRPr lang="en-US"/>
-          </a:p>
-        </p:txBody>
-      </p:sp>
-    </p:spTree>
-    <p:extLst>
-      <p:ext uri="{BB962C8B-B14F-4D97-AF65-F5344CB8AC3E}">
-        <p14:creationId xmlns:p14="http://schemas.microsoft.com/office/powerpoint/2010/main" val="1024086991"/>
-      </p:ext>
-    </p:extLst>
-  </p:cSld>
-  <p:clrMapOvr>
-    <a:masterClrMapping/>
-  </p:clrMapOvr>
-</p:notes>
-</file>
-
-<file path=ppt/notesSlides/notesSlide7.xml><?xml version="1.0" encoding="utf-8"?>
-<p:notes xmlns:a="http://schemas.openxmlformats.org/drawingml/2006/main" xmlns:r="http://schemas.openxmlformats.org/officeDocument/2006/relationships" xmlns:p="http://schemas.openxmlformats.org/presentationml/2006/main">
-  <p:cSld>
-    <p:spTree>
-      <p:nvGrpSpPr>
-        <p:cNvPr id="1" name=""/>
-        <p:cNvGrpSpPr/>
-        <p:nvPr/>
-      </p:nvGrpSpPr>
-      <p:grpSpPr>
-        <a:xfrm>
-          <a:off x="0" y="0"/>
-          <a:ext cx="0" cy="0"/>
-          <a:chOff x="0" y="0"/>
-          <a:chExt cx="0" cy="0"/>
-        </a:xfrm>
-      </p:grpSpPr>
-      <p:sp>
-        <p:nvSpPr>
-          <p:cNvPr id="2" name="Slide Image Placeholder 1"/>
-          <p:cNvSpPr>
-            <a:spLocks noGrp="1" noRot="1" noChangeAspect="1"/>
-          </p:cNvSpPr>
-          <p:nvPr>
-            <p:ph type="sldImg"/>
-          </p:nvPr>
-        </p:nvSpPr>
-        <p:spPr/>
-      </p:sp>
-      <p:sp>
-        <p:nvSpPr>
-          <p:cNvPr id="3" name="Notes Placeholder 2"/>
-          <p:cNvSpPr>
-            <a:spLocks noGrp="1"/>
-          </p:cNvSpPr>
-          <p:nvPr>
-            <p:ph type="body" idx="1"/>
-          </p:nvPr>
-        </p:nvSpPr>
-        <p:spPr/>
-        <p:txBody>
-          <a:bodyPr/>
-          <a:lstStyle/>
-          <a:p>
-            <a:r>
-              <a:rPr lang="en-US" dirty="0"/>
-              <a:t>All of this is hosted. The repo has the pipeline, the seeding script and the README with the setup gotchas I hit on a new trial org.</a:t>
-            </a:r>
-            <a:endParaRPr lang="en-US" dirty="0"/>
-          </a:p>
-        </p:txBody>
-      </p:sp>
-      <p:sp>
-        <p:nvSpPr>
-          <p:cNvPr id="4" name="Slide Number Placeholder 3"/>
-          <p:cNvSpPr>
-            <a:spLocks noGrp="1"/>
-          </p:cNvSpPr>
-          <p:nvPr>
-            <p:ph type="sldNum" sz="quarter" idx="10"/>
-          </p:nvPr>
-        </p:nvSpPr>
-        <p:spPr/>
-        <p:txBody>
-          <a:bodyPr/>
-          <a:lstStyle/>
-          <a:p>
-            <a:fld id="{F7021451-1387-4CA6-816F-3879F97B5CBC}" type="slidenum">
-              <a:rPr lang="en-US"/>
-              <a:t>7</a:t>
-            </a:fld>
-            <a:endParaRPr lang="en-US"/>
-          </a:p>
-        </p:txBody>
-      </p:sp>
-    </p:spTree>
-    <p:extLst>
-      <p:ext uri="{BB962C8B-B14F-4D97-AF65-F5344CB8AC3E}">
-        <p14:creationId xmlns:p14="http://schemas.microsoft.com/office/powerpoint/2010/main" val="1024086991"/>
-      </p:ext>
-    </p:extLst>
-  </p:cSld>
-  <p:clrMapOvr>
-    <a:masterClrMapping/>
-  </p:clrMapOvr>
-</p:notes>
-</file>
-
-<file path=ppt/notesSlides/notesSlide8.xml><?xml version="1.0" encoding="utf-8"?>
-<p:notes xmlns:a="http://schemas.openxmlformats.org/drawingml/2006/main" xmlns:r="http://schemas.openxmlformats.org/officeDocument/2006/relationships" xmlns:p="http://schemas.openxmlformats.org/presentationml/2006/main">
-  <p:cSld>
-    <p:spTree>
-      <p:nvGrpSpPr>
-        <p:cNvPr id="1" name=""/>
-        <p:cNvGrpSpPr/>
-        <p:nvPr/>
-      </p:nvGrpSpPr>
-      <p:grpSpPr>
-        <a:xfrm>
-          <a:off x="0" y="0"/>
-          <a:ext cx="0" cy="0"/>
-          <a:chOff x="0" y="0"/>
-          <a:chExt cx="0" cy="0"/>
-        </a:xfrm>
-      </p:grpSpPr>
-      <p:sp>
-        <p:nvSpPr>
-          <p:cNvPr id="2" name="Slide Image Placeholder 1"/>
-          <p:cNvSpPr>
-            <a:spLocks noGrp="1" noRot="1" noChangeAspect="1"/>
-          </p:cNvSpPr>
-          <p:nvPr>
-            <p:ph type="sldImg"/>
-          </p:nvPr>
-        </p:nvSpPr>
-        <p:spPr/>
-      </p:sp>
-      <p:sp>
-        <p:nvSpPr>
-          <p:cNvPr id="3" name="Notes Placeholder 2"/>
-          <p:cNvSpPr>
-            <a:spLocks noGrp="1"/>
-          </p:cNvSpPr>
-          <p:nvPr>
-            <p:ph type="body" idx="1"/>
-          </p:nvPr>
-        </p:nvSpPr>
-        <p:spPr/>
-        <p:txBody>
-          <a:bodyPr/>
-          <a:lstStyle/>
-          <a:p>
-            <a:r>
-              <a:rPr lang="en-US" dirty="0"/>
-              <a:t>Close on the decision: validate on production data, pilot one policy change, then monitor value realised in Apromore.</a:t>
-            </a:r>
-            <a:endParaRPr lang="en-US" dirty="0"/>
-          </a:p>
-        </p:txBody>
-      </p:sp>
-      <p:sp>
-        <p:nvSpPr>
-          <p:cNvPr id="4" name="Slide Number Placeholder 3"/>
-          <p:cNvSpPr>
-            <a:spLocks noGrp="1"/>
-          </p:cNvSpPr>
-          <p:nvPr>
-            <p:ph type="sldNum" sz="quarter" idx="10"/>
-          </p:nvPr>
-        </p:nvSpPr>
-        <p:spPr/>
-        <p:txBody>
-          <a:bodyPr/>
-          <a:lstStyle/>
-          <a:p>
-            <a:fld id="{F7021451-1387-4CA6-816F-3879F97B5CBC}" type="slidenum">
-              <a:rPr lang="en-US"/>
-              <a:t>8</a:t>
             </a:fld>
             <a:endParaRPr lang="en-US"/>
           </a:p>
@@ -6066,2220 +5882,6 @@
 <file path=ppt/slides/slide6.xml><?xml version="1.0" encoding="utf-8"?>
 <p:sld xmlns:a="http://schemas.openxmlformats.org/drawingml/2006/main" xmlns:r="http://schemas.openxmlformats.org/officeDocument/2006/relationships" xmlns:p="http://schemas.openxmlformats.org/presentationml/2006/main">
   <p:cSld name="Slide 6">
-    <p:spTree>
-      <p:nvGrpSpPr>
-        <p:cNvPr id="1" name=""/>
-        <p:cNvGrpSpPr/>
-        <p:nvPr/>
-      </p:nvGrpSpPr>
-      <p:grpSpPr>
-        <a:xfrm>
-          <a:off x="0" y="0"/>
-          <a:ext cx="0" cy="0"/>
-          <a:chOff x="0" y="0"/>
-          <a:chExt cx="0" cy="0"/>
-        </a:xfrm>
-      </p:grpSpPr>
-      <p:sp>
-        <p:nvSpPr>
-          <p:cNvPr id="2" name="Text 0"/>
-          <p:cNvSpPr/>
-          <p:nvPr>
-            <p:ph idx="100" type="title" hasCustomPrompt="1"/>
-          </p:nvPr>
-        </p:nvSpPr>
-        <p:spPr>
-          <a:xfrm>
-            <a:off x="548640" y="320040"/>
-            <a:ext cx="11064240" cy="822960"/>
-          </a:xfrm>
-          <a:prstGeom prst="rect">
-            <a:avLst/>
-          </a:prstGeom>
-          <a:noFill/>
-          <a:ln/>
-        </p:spPr>
-        <p:txBody>
-          <a:bodyPr wrap="square" lIns="0" tIns="0" rIns="0" bIns="0" rtlCol="0" anchor="ctr"/>
-          <a:lstStyle/>
-          <a:p>
-            <a:pPr algn="l" indent="0" marL="0">
-              <a:buNone/>
-            </a:pPr>
-            <a:r>
-              <a:rPr lang="en-US" sz="3000" b="1" dirty="0">
-                <a:solidFill>
-                  <a:schemeClr val="tx2"/>
-                </a:solidFill>
-              </a:rPr>
-              <a:t>Tech setup: from a Salesforce org to an event log</a:t>
-            </a:r>
-            <a:endParaRPr lang="en-US" sz="3000" dirty="0"/>
-          </a:p>
-        </p:txBody>
-      </p:sp>
-      <p:sp>
-        <p:nvSpPr>
-          <p:cNvPr id="3" name="Org screenshot frame"/>
-          <p:cNvSpPr/>
-          <p:nvPr/>
-        </p:nvSpPr>
-        <p:spPr>
-          <a:xfrm>
-            <a:off x="512064" y="1243584"/>
-            <a:ext cx="5148072" cy="3910582"/>
-          </a:xfrm>
-          <a:prstGeom prst="rect">
-            <a:avLst/>
-          </a:prstGeom>
-          <a:solidFill>
-            <a:schemeClr val="bg1"/>
-          </a:solidFill>
-          <a:ln w="12700">
-            <a:solidFill>
-              <a:schemeClr val="accent3"/>
-            </a:solidFill>
-            <a:prstDash val="solid"/>
-          </a:ln>
-        </p:spPr>
-      </p:sp>
-      <p:pic>
-        <p:nvPicPr>
-          <p:cNvPr id="4" name="Org screenshot" descr="Salesforce trial org with seeded demo records">    </p:cNvPr>
-          <p:cNvPicPr>
-            <a:picLocks noChangeAspect="1"/>
-          </p:cNvPicPr>
-          <p:nvPr/>
-        </p:nvPicPr>
-        <p:blipFill>
-          <a:blip r:embed="rId1"/>
-          <a:stretch>
-            <a:fillRect/>
-          </a:stretch>
-        </p:blipFill>
-        <p:spPr>
-          <a:xfrm>
-            <a:off x="548640" y="1280160"/>
-            <a:ext cx="5074920" cy="3837430"/>
-          </a:xfrm>
-          <a:prstGeom prst="rect">
-            <a:avLst/>
-          </a:prstGeom>
-        </p:spPr>
-      </p:pic>
-      <p:sp>
-        <p:nvSpPr>
-          <p:cNvPr id="5" name="Org caption"/>
-          <p:cNvSpPr txBox="1"/>
-          <p:nvPr/>
-        </p:nvSpPr>
-        <p:spPr>
-          <a:xfrm>
-            <a:off x="548640" y="5669280"/>
-            <a:ext cx="5074920" cy="685800"/>
-          </a:xfrm>
-          <a:prstGeom prst="rect">
-            <a:avLst/>
-          </a:prstGeom>
-          <a:noFill/>
-          <a:ln/>
-        </p:spPr>
-        <p:txBody>
-          <a:bodyPr wrap="square" lIns="0" tIns="0" rIns="0" bIns="0" rtlCol="0" anchor="t"/>
-          <a:lstStyle/>
-          <a:p>
-            <a:pPr indent="0" marL="0">
-              <a:buNone/>
-            </a:pPr>
-            <a:r>
-              <a:rPr lang="en-US" sz="1400" b="1" dirty="0">
-                <a:solidFill>
-                  <a:schemeClr val="tx2"/>
-                </a:solidFill>
-              </a:rPr>
-              <a:t>Salesforce trial org: </a:t>
-            </a:r>
-            <a:pPr indent="0" marL="0">
-              <a:buNone/>
-            </a:pPr>
-            <a:r>
-              <a:rPr lang="en-US" sz="1400" dirty="0">
-                <a:solidFill>
-                  <a:schemeClr val="tx2"/>
-                </a:solidFill>
-              </a:rPr>
-              <a:t>seed.py loaded 40 [Demo] deals through real stage changes to simulate a client's CRM.</a:t>
-            </a:r>
-            <a:endParaRPr lang="en-US" sz="1400" dirty="0"/>
-          </a:p>
-        </p:txBody>
-      </p:sp>
-      <p:sp>
-        <p:nvSpPr>
-          <p:cNvPr id="6" name="Code panel"/>
-          <p:cNvSpPr/>
-          <p:nvPr/>
-        </p:nvSpPr>
-        <p:spPr>
-          <a:xfrm>
-            <a:off x="5897880" y="1280160"/>
-            <a:ext cx="5715000" cy="4297680"/>
-          </a:xfrm>
-          <a:prstGeom prst="roundRect">
-            <a:avLst>
-              <a:gd name="adj" fmla="val 2553"/>
-            </a:avLst>
-          </a:prstGeom>
-          <a:solidFill>
-            <a:schemeClr val="tx2"/>
-          </a:solidFill>
-          <a:ln/>
-        </p:spPr>
-      </p:sp>
-      <p:sp>
-        <p:nvSpPr>
-          <p:cNvPr id="7" name="Code panel dot 1"/>
-          <p:cNvSpPr/>
-          <p:nvPr/>
-        </p:nvSpPr>
-        <p:spPr>
-          <a:xfrm>
-            <a:off x="6080760" y="1417320"/>
-            <a:ext cx="109728" cy="109728"/>
-          </a:xfrm>
-          <a:prstGeom prst="ellipse">
-            <a:avLst/>
-          </a:prstGeom>
-          <a:solidFill>
-            <a:srgbClr val="FE9339"/>
-          </a:solidFill>
-          <a:ln/>
-        </p:spPr>
-      </p:sp>
-      <p:sp>
-        <p:nvSpPr>
-          <p:cNvPr id="8" name="Code panel dot 2"/>
-          <p:cNvSpPr/>
-          <p:nvPr/>
-        </p:nvSpPr>
-        <p:spPr>
-          <a:xfrm>
-            <a:off x="6263640" y="1417320"/>
-            <a:ext cx="109728" cy="109728"/>
-          </a:xfrm>
-          <a:prstGeom prst="ellipse">
-            <a:avLst/>
-          </a:prstGeom>
-          <a:solidFill>
-            <a:srgbClr val="F6C344"/>
-          </a:solidFill>
-          <a:ln/>
-        </p:spPr>
-      </p:sp>
-      <p:sp>
-        <p:nvSpPr>
-          <p:cNvPr id="9" name="Code panel dot 3"/>
-          <p:cNvSpPr/>
-          <p:nvPr/>
-        </p:nvSpPr>
-        <p:spPr>
-          <a:xfrm>
-            <a:off x="6446520" y="1417320"/>
-            <a:ext cx="109728" cy="109728"/>
-          </a:xfrm>
-          <a:prstGeom prst="ellipse">
-            <a:avLst/>
-          </a:prstGeom>
-          <a:solidFill>
-            <a:srgbClr val="2E844A"/>
-          </a:solidFill>
-          <a:ln/>
-        </p:spPr>
-      </p:sp>
-      <p:sp>
-        <p:nvSpPr>
-          <p:cNvPr id="10" name="Code panel filename"/>
-          <p:cNvSpPr txBox="1"/>
-          <p:nvPr/>
-        </p:nvSpPr>
-        <p:spPr>
-          <a:xfrm>
-            <a:off x="6675120" y="1353312"/>
-            <a:ext cx="2743200" cy="237744"/>
-          </a:xfrm>
-          <a:prstGeom prst="rect">
-            <a:avLst/>
-          </a:prstGeom>
-          <a:noFill/>
-          <a:ln/>
-        </p:spPr>
-        <p:txBody>
-          <a:bodyPr wrap="square" lIns="0" tIns="0" rIns="0" bIns="0" rtlCol="0" anchor="t"/>
-          <a:lstStyle/>
-          <a:p>
-            <a:pPr indent="0" marL="0">
-              <a:buNone/>
-            </a:pPr>
-            <a:r>
-              <a:rPr lang="en-US" sz="1100" dirty="0">
-                <a:solidFill>
-                  <a:schemeClr val="accent3"/>
-                </a:solidFill>
-              </a:rPr>
-              <a:t>pipeline/extract.py</a:t>
-            </a:r>
-            <a:endParaRPr lang="en-US" sz="1100" dirty="0"/>
-          </a:p>
-        </p:txBody>
-      </p:sp>
-      <p:sp>
-        <p:nvSpPr>
-          <p:cNvPr id="11" name="SOQL code"/>
-          <p:cNvSpPr txBox="1"/>
-          <p:nvPr/>
-        </p:nvSpPr>
-        <p:spPr>
-          <a:xfrm>
-            <a:off x="6080760" y="1664208"/>
-            <a:ext cx="5440680" cy="3840480"/>
-          </a:xfrm>
-          <a:prstGeom prst="rect">
-            <a:avLst/>
-          </a:prstGeom>
-          <a:noFill/>
-          <a:ln/>
-        </p:spPr>
-        <p:txBody>
-          <a:bodyPr wrap="square" lIns="0" tIns="0" rIns="0" bIns="0" rtlCol="0" anchor="t"/>
-          <a:lstStyle/>
-          <a:p>
-            <a:pPr indent="0" marL="0">
-              <a:lnSpc>
-                <a:spcPct val="100000"/>
-              </a:lnSpc>
-              <a:buNone/>
-            </a:pPr>
-            <a:r>
-              <a:rPr lang="en-US" sz="1000" dirty="0">
-                <a:solidFill>
-                  <a:srgbClr val="CFE9FE"/>
-                </a:solidFill>
-                <a:latin typeface="Courier New" pitchFamily="34" charset="0"/>
-                <a:ea typeface="Courier New" pitchFamily="34" charset="-122"/>
-                <a:cs typeface="Courier New" pitchFamily="34" charset="-120"/>
-              </a:rPr>
-              <a:t>QUERIES = {</a:t>
-            </a:r>
-            <a:endParaRPr lang="en-US" sz="1000" dirty="0"/>
-          </a:p>
-          <a:p>
-            <a:pPr indent="0" marL="0">
-              <a:lnSpc>
-                <a:spcPct val="100000"/>
-              </a:lnSpc>
-              <a:buNone/>
-            </a:pPr>
-            <a:r>
-              <a:rPr lang="en-US" sz="1000" dirty="0">
-                <a:solidFill>
-                  <a:srgbClr val="CFE9FE"/>
-                </a:solidFill>
-                <a:latin typeface="Courier New" pitchFamily="34" charset="0"/>
-                <a:ea typeface="Courier New" pitchFamily="34" charset="-122"/>
-                <a:cs typeface="Courier New" pitchFamily="34" charset="-120"/>
-              </a:rPr>
-              <a:t>    </a:t>
-            </a:r>
-            <a:pPr indent="0" marL="0">
-              <a:lnSpc>
-                <a:spcPct val="100000"/>
-              </a:lnSpc>
-              <a:buNone/>
-            </a:pPr>
-            <a:r>
-              <a:rPr lang="en-US" sz="1000" dirty="0">
-                <a:solidFill>
-                  <a:srgbClr val="FE9339"/>
-                </a:solidFill>
-                <a:latin typeface="Courier New" pitchFamily="34" charset="0"/>
-                <a:ea typeface="Courier New" pitchFamily="34" charset="-122"/>
-                <a:cs typeface="Courier New" pitchFamily="34" charset="-120"/>
-              </a:rPr>
-              <a:t>"opportunities"</a:t>
-            </a:r>
-            <a:pPr indent="0" marL="0">
-              <a:lnSpc>
-                <a:spcPct val="100000"/>
-              </a:lnSpc>
-              <a:buNone/>
-            </a:pPr>
-            <a:r>
-              <a:rPr lang="en-US" sz="1000" dirty="0">
-                <a:solidFill>
-                  <a:srgbClr val="CFE9FE"/>
-                </a:solidFill>
-                <a:latin typeface="Courier New" pitchFamily="34" charset="0"/>
-                <a:ea typeface="Courier New" pitchFamily="34" charset="-122"/>
-                <a:cs typeface="Courier New" pitchFamily="34" charset="-120"/>
-              </a:rPr>
-              <a:t>: """</a:t>
-            </a:r>
-            <a:endParaRPr lang="en-US" sz="1000" dirty="0"/>
-          </a:p>
-          <a:p>
-            <a:pPr indent="0" marL="0">
-              <a:lnSpc>
-                <a:spcPct val="100000"/>
-              </a:lnSpc>
-              <a:buNone/>
-            </a:pPr>
-            <a:r>
-              <a:rPr lang="en-US" sz="1000" dirty="0">
-                <a:solidFill>
-                  <a:srgbClr val="CFE9FE"/>
-                </a:solidFill>
-                <a:latin typeface="Courier New" pitchFamily="34" charset="0"/>
-                <a:ea typeface="Courier New" pitchFamily="34" charset="-122"/>
-                <a:cs typeface="Courier New" pitchFamily="34" charset="-120"/>
-              </a:rPr>
-              <a:t>    </a:t>
-            </a:r>
-            <a:pPr indent="0" marL="0">
-              <a:lnSpc>
-                <a:spcPct val="100000"/>
-              </a:lnSpc>
-              <a:buNone/>
-            </a:pPr>
-            <a:r>
-              <a:rPr lang="en-US" sz="1000" b="1" dirty="0">
-                <a:solidFill>
-                  <a:srgbClr val="0B9DE0"/>
-                </a:solidFill>
-                <a:latin typeface="Courier New" pitchFamily="34" charset="0"/>
-                <a:ea typeface="Courier New" pitchFamily="34" charset="-122"/>
-                <a:cs typeface="Courier New" pitchFamily="34" charset="-120"/>
-              </a:rPr>
-              <a:t>SELECT</a:t>
-            </a:r>
-            <a:pPr indent="0" marL="0">
-              <a:lnSpc>
-                <a:spcPct val="100000"/>
-              </a:lnSpc>
-              <a:buNone/>
-            </a:pPr>
-            <a:r>
-              <a:rPr lang="en-US" sz="1000" dirty="0">
-                <a:solidFill>
-                  <a:srgbClr val="CFE9FE"/>
-                </a:solidFill>
-                <a:latin typeface="Courier New" pitchFamily="34" charset="0"/>
-                <a:ea typeface="Courier New" pitchFamily="34" charset="-122"/>
-                <a:cs typeface="Courier New" pitchFamily="34" charset="-120"/>
-              </a:rPr>
-              <a:t> Id, Name, Amount, StageName, IsWon, IsClosed,</a:t>
-            </a:r>
-            <a:endParaRPr lang="en-US" sz="1000" dirty="0"/>
-          </a:p>
-          <a:p>
-            <a:pPr indent="0" marL="0">
-              <a:lnSpc>
-                <a:spcPct val="100000"/>
-              </a:lnSpc>
-              <a:buNone/>
-            </a:pPr>
-            <a:r>
-              <a:rPr lang="en-US" sz="1000" dirty="0">
-                <a:solidFill>
-                  <a:srgbClr val="CFE9FE"/>
-                </a:solidFill>
-                <a:latin typeface="Courier New" pitchFamily="34" charset="0"/>
-                <a:ea typeface="Courier New" pitchFamily="34" charset="-122"/>
-                <a:cs typeface="Courier New" pitchFamily="34" charset="-120"/>
-              </a:rPr>
-              <a:t>           LeadSource, CreatedDate, CloseDate, OwnerId, Owner.Name,</a:t>
-            </a:r>
-            <a:endParaRPr lang="en-US" sz="1000" dirty="0"/>
-          </a:p>
-          <a:p>
-            <a:pPr indent="0" marL="0">
-              <a:lnSpc>
-                <a:spcPct val="100000"/>
-              </a:lnSpc>
-              <a:buNone/>
-            </a:pPr>
-            <a:r>
-              <a:rPr lang="en-US" sz="1000" dirty="0">
-                <a:solidFill>
-                  <a:srgbClr val="CFE9FE"/>
-                </a:solidFill>
-                <a:latin typeface="Courier New" pitchFamily="34" charset="0"/>
-                <a:ea typeface="Courier New" pitchFamily="34" charset="-122"/>
-                <a:cs typeface="Courier New" pitchFamily="34" charset="-120"/>
-              </a:rPr>
-              <a:t>           Account.Industry, Account.BillingCountry</a:t>
-            </a:r>
-            <a:endParaRPr lang="en-US" sz="1000" dirty="0"/>
-          </a:p>
-          <a:p>
-            <a:pPr indent="0" marL="0">
-              <a:lnSpc>
-                <a:spcPct val="100000"/>
-              </a:lnSpc>
-              <a:buNone/>
-            </a:pPr>
-            <a:r>
-              <a:rPr lang="en-US" sz="1000" dirty="0">
-                <a:solidFill>
-                  <a:srgbClr val="CFE9FE"/>
-                </a:solidFill>
-                <a:latin typeface="Courier New" pitchFamily="34" charset="0"/>
-                <a:ea typeface="Courier New" pitchFamily="34" charset="-122"/>
-                <a:cs typeface="Courier New" pitchFamily="34" charset="-120"/>
-              </a:rPr>
-              <a:t>    </a:t>
-            </a:r>
-            <a:pPr indent="0" marL="0">
-              <a:lnSpc>
-                <a:spcPct val="100000"/>
-              </a:lnSpc>
-              <a:buNone/>
-            </a:pPr>
-            <a:r>
-              <a:rPr lang="en-US" sz="1000" b="1" dirty="0">
-                <a:solidFill>
-                  <a:srgbClr val="0B9DE0"/>
-                </a:solidFill>
-                <a:latin typeface="Courier New" pitchFamily="34" charset="0"/>
-                <a:ea typeface="Courier New" pitchFamily="34" charset="-122"/>
-                <a:cs typeface="Courier New" pitchFamily="34" charset="-120"/>
-              </a:rPr>
-              <a:t>FROM</a:t>
-            </a:r>
-            <a:pPr indent="0" marL="0">
-              <a:lnSpc>
-                <a:spcPct val="100000"/>
-              </a:lnSpc>
-              <a:buNone/>
-            </a:pPr>
-            <a:r>
-              <a:rPr lang="en-US" sz="1000" dirty="0">
-                <a:solidFill>
-                  <a:srgbClr val="CFE9FE"/>
-                </a:solidFill>
-                <a:latin typeface="Courier New" pitchFamily="34" charset="0"/>
-                <a:ea typeface="Courier New" pitchFamily="34" charset="-122"/>
-                <a:cs typeface="Courier New" pitchFamily="34" charset="-120"/>
-              </a:rPr>
-              <a:t> Opportunity""",</a:t>
-            </a:r>
-            <a:endParaRPr lang="en-US" sz="1000" dirty="0"/>
-          </a:p>
-          <a:p>
-            <a:pPr indent="0" marL="0">
-              <a:lnSpc>
-                <a:spcPct val="100000"/>
-              </a:lnSpc>
-              <a:buNone/>
-            </a:pPr>
-            <a:r>
-              <a:rPr lang="en-US" sz="1000" dirty="0">
-                <a:solidFill>
-                  <a:srgbClr val="CFE9FE"/>
-                </a:solidFill>
-                <a:latin typeface="Courier New" pitchFamily="34" charset="0"/>
-                <a:ea typeface="Courier New" pitchFamily="34" charset="-122"/>
-                <a:cs typeface="Courier New" pitchFamily="34" charset="-120"/>
-              </a:rPr>
-              <a:t>    </a:t>
-            </a:r>
-            <a:pPr indent="0" marL="0">
-              <a:lnSpc>
-                <a:spcPct val="100000"/>
-              </a:lnSpc>
-              <a:buNone/>
-            </a:pPr>
-            <a:r>
-              <a:rPr lang="en-US" sz="1000" dirty="0">
-                <a:solidFill>
-                  <a:srgbClr val="FE9339"/>
-                </a:solidFill>
-                <a:latin typeface="Courier New" pitchFamily="34" charset="0"/>
-                <a:ea typeface="Courier New" pitchFamily="34" charset="-122"/>
-                <a:cs typeface="Courier New" pitchFamily="34" charset="-120"/>
-              </a:rPr>
-              <a:t>"stage_history"</a:t>
-            </a:r>
-            <a:pPr indent="0" marL="0">
-              <a:lnSpc>
-                <a:spcPct val="100000"/>
-              </a:lnSpc>
-              <a:buNone/>
-            </a:pPr>
-            <a:r>
-              <a:rPr lang="en-US" sz="1000" dirty="0">
-                <a:solidFill>
-                  <a:srgbClr val="CFE9FE"/>
-                </a:solidFill>
-                <a:latin typeface="Courier New" pitchFamily="34" charset="0"/>
-                <a:ea typeface="Courier New" pitchFamily="34" charset="-122"/>
-                <a:cs typeface="Courier New" pitchFamily="34" charset="-120"/>
-              </a:rPr>
-              <a:t>: """</a:t>
-            </a:r>
-            <a:endParaRPr lang="en-US" sz="1000" dirty="0"/>
-          </a:p>
-          <a:p>
-            <a:pPr indent="0" marL="0">
-              <a:lnSpc>
-                <a:spcPct val="100000"/>
-              </a:lnSpc>
-              <a:buNone/>
-            </a:pPr>
-            <a:r>
-              <a:rPr lang="en-US" sz="1000" dirty="0">
-                <a:solidFill>
-                  <a:srgbClr val="CFE9FE"/>
-                </a:solidFill>
-                <a:latin typeface="Courier New" pitchFamily="34" charset="0"/>
-                <a:ea typeface="Courier New" pitchFamily="34" charset="-122"/>
-                <a:cs typeface="Courier New" pitchFamily="34" charset="-120"/>
-              </a:rPr>
-              <a:t>    </a:t>
-            </a:r>
-            <a:pPr indent="0" marL="0">
-              <a:lnSpc>
-                <a:spcPct val="100000"/>
-              </a:lnSpc>
-              <a:buNone/>
-            </a:pPr>
-            <a:r>
-              <a:rPr lang="en-US" sz="1000" b="1" dirty="0">
-                <a:solidFill>
-                  <a:srgbClr val="0B9DE0"/>
-                </a:solidFill>
-                <a:latin typeface="Courier New" pitchFamily="34" charset="0"/>
-                <a:ea typeface="Courier New" pitchFamily="34" charset="-122"/>
-                <a:cs typeface="Courier New" pitchFamily="34" charset="-120"/>
-              </a:rPr>
-              <a:t>SELECT</a:t>
-            </a:r>
-            <a:pPr indent="0" marL="0">
-              <a:lnSpc>
-                <a:spcPct val="100000"/>
-              </a:lnSpc>
-              <a:buNone/>
-            </a:pPr>
-            <a:r>
-              <a:rPr lang="en-US" sz="1000" dirty="0">
-                <a:solidFill>
-                  <a:srgbClr val="CFE9FE"/>
-                </a:solidFill>
-                <a:latin typeface="Courier New" pitchFamily="34" charset="0"/>
-                <a:ea typeface="Courier New" pitchFamily="34" charset="-122"/>
-                <a:cs typeface="Courier New" pitchFamily="34" charset="-120"/>
-              </a:rPr>
-              <a:t> OpportunityId, StageName, CreatedDate,</a:t>
-            </a:r>
-            <a:endParaRPr lang="en-US" sz="1000" dirty="0"/>
-          </a:p>
-          <a:p>
-            <a:pPr indent="0" marL="0">
-              <a:lnSpc>
-                <a:spcPct val="100000"/>
-              </a:lnSpc>
-              <a:buNone/>
-            </a:pPr>
-            <a:r>
-              <a:rPr lang="en-US" sz="1000" dirty="0">
-                <a:solidFill>
-                  <a:srgbClr val="CFE9FE"/>
-                </a:solidFill>
-                <a:latin typeface="Courier New" pitchFamily="34" charset="0"/>
-                <a:ea typeface="Courier New" pitchFamily="34" charset="-122"/>
-                <a:cs typeface="Courier New" pitchFamily="34" charset="-120"/>
-              </a:rPr>
-              <a:t>           CreatedById, CreatedBy.Name</a:t>
-            </a:r>
-            <a:endParaRPr lang="en-US" sz="1000" dirty="0"/>
-          </a:p>
-          <a:p>
-            <a:pPr indent="0" marL="0">
-              <a:lnSpc>
-                <a:spcPct val="100000"/>
-              </a:lnSpc>
-              <a:buNone/>
-            </a:pPr>
-            <a:r>
-              <a:rPr lang="en-US" sz="1000" dirty="0">
-                <a:solidFill>
-                  <a:srgbClr val="CFE9FE"/>
-                </a:solidFill>
-                <a:latin typeface="Courier New" pitchFamily="34" charset="0"/>
-                <a:ea typeface="Courier New" pitchFamily="34" charset="-122"/>
-                <a:cs typeface="Courier New" pitchFamily="34" charset="-120"/>
-              </a:rPr>
-              <a:t>    </a:t>
-            </a:r>
-            <a:pPr indent="0" marL="0">
-              <a:lnSpc>
-                <a:spcPct val="100000"/>
-              </a:lnSpc>
-              <a:buNone/>
-            </a:pPr>
-            <a:r>
-              <a:rPr lang="en-US" sz="1000" b="1" dirty="0">
-                <a:solidFill>
-                  <a:srgbClr val="0B9DE0"/>
-                </a:solidFill>
-                <a:latin typeface="Courier New" pitchFamily="34" charset="0"/>
-                <a:ea typeface="Courier New" pitchFamily="34" charset="-122"/>
-                <a:cs typeface="Courier New" pitchFamily="34" charset="-120"/>
-              </a:rPr>
-              <a:t>FROM</a:t>
-            </a:r>
-            <a:pPr indent="0" marL="0">
-              <a:lnSpc>
-                <a:spcPct val="100000"/>
-              </a:lnSpc>
-              <a:buNone/>
-            </a:pPr>
-            <a:r>
-              <a:rPr lang="en-US" sz="1000" dirty="0">
-                <a:solidFill>
-                  <a:srgbClr val="CFE9FE"/>
-                </a:solidFill>
-                <a:latin typeface="Courier New" pitchFamily="34" charset="0"/>
-                <a:ea typeface="Courier New" pitchFamily="34" charset="-122"/>
-                <a:cs typeface="Courier New" pitchFamily="34" charset="-120"/>
-              </a:rPr>
-              <a:t> OpportunityHistory</a:t>
-            </a:r>
-            <a:endParaRPr lang="en-US" sz="1000" dirty="0"/>
-          </a:p>
-          <a:p>
-            <a:pPr indent="0" marL="0">
-              <a:lnSpc>
-                <a:spcPct val="100000"/>
-              </a:lnSpc>
-              <a:buNone/>
-            </a:pPr>
-            <a:r>
-              <a:rPr lang="en-US" sz="1000" dirty="0">
-                <a:solidFill>
-                  <a:srgbClr val="CFE9FE"/>
-                </a:solidFill>
-                <a:latin typeface="Courier New" pitchFamily="34" charset="0"/>
-                <a:ea typeface="Courier New" pitchFamily="34" charset="-122"/>
-                <a:cs typeface="Courier New" pitchFamily="34" charset="-120"/>
-              </a:rPr>
-              <a:t>    </a:t>
-            </a:r>
-            <a:pPr indent="0" marL="0">
-              <a:lnSpc>
-                <a:spcPct val="100000"/>
-              </a:lnSpc>
-              <a:buNone/>
-            </a:pPr>
-            <a:r>
-              <a:rPr lang="en-US" sz="1000" b="1" dirty="0">
-                <a:solidFill>
-                  <a:srgbClr val="0B9DE0"/>
-                </a:solidFill>
-                <a:latin typeface="Courier New" pitchFamily="34" charset="0"/>
-                <a:ea typeface="Courier New" pitchFamily="34" charset="-122"/>
-                <a:cs typeface="Courier New" pitchFamily="34" charset="-120"/>
-              </a:rPr>
-              <a:t>ORDER BY</a:t>
-            </a:r>
-            <a:pPr indent="0" marL="0">
-              <a:lnSpc>
-                <a:spcPct val="100000"/>
-              </a:lnSpc>
-              <a:buNone/>
-            </a:pPr>
-            <a:r>
-              <a:rPr lang="en-US" sz="1000" dirty="0">
-                <a:solidFill>
-                  <a:srgbClr val="CFE9FE"/>
-                </a:solidFill>
-                <a:latin typeface="Courier New" pitchFamily="34" charset="0"/>
-                <a:ea typeface="Courier New" pitchFamily="34" charset="-122"/>
-                <a:cs typeface="Courier New" pitchFamily="34" charset="-120"/>
-              </a:rPr>
-              <a:t> OpportunityId, CreatedDate""",</a:t>
-            </a:r>
-            <a:endParaRPr lang="en-US" sz="1000" dirty="0"/>
-          </a:p>
-          <a:p>
-            <a:pPr indent="0" marL="0">
-              <a:lnSpc>
-                <a:spcPct val="100000"/>
-              </a:lnSpc>
-              <a:buNone/>
-            </a:pPr>
-            <a:r>
-              <a:rPr lang="en-US" sz="1000" dirty="0">
-                <a:solidFill>
-                  <a:srgbClr val="CFE9FE"/>
-                </a:solidFill>
-                <a:latin typeface="Courier New" pitchFamily="34" charset="0"/>
-                <a:ea typeface="Courier New" pitchFamily="34" charset="-122"/>
-                <a:cs typeface="Courier New" pitchFamily="34" charset="-120"/>
-              </a:rPr>
-              <a:t>    </a:t>
-            </a:r>
-            <a:pPr indent="0" marL="0">
-              <a:lnSpc>
-                <a:spcPct val="100000"/>
-              </a:lnSpc>
-              <a:buNone/>
-            </a:pPr>
-            <a:r>
-              <a:rPr lang="en-US" sz="1000" dirty="0">
-                <a:solidFill>
-                  <a:srgbClr val="FE9339"/>
-                </a:solidFill>
-                <a:latin typeface="Courier New" pitchFamily="34" charset="0"/>
-                <a:ea typeface="Courier New" pitchFamily="34" charset="-122"/>
-                <a:cs typeface="Courier New" pitchFamily="34" charset="-120"/>
-              </a:rPr>
-              <a:t>"tasks"</a:t>
-            </a:r>
-            <a:pPr indent="0" marL="0">
-              <a:lnSpc>
-                <a:spcPct val="100000"/>
-              </a:lnSpc>
-              <a:buNone/>
-            </a:pPr>
-            <a:r>
-              <a:rPr lang="en-US" sz="1000" dirty="0">
-                <a:solidFill>
-                  <a:srgbClr val="CFE9FE"/>
-                </a:solidFill>
-                <a:latin typeface="Courier New" pitchFamily="34" charset="0"/>
-                <a:ea typeface="Courier New" pitchFamily="34" charset="-122"/>
-                <a:cs typeface="Courier New" pitchFamily="34" charset="-120"/>
-              </a:rPr>
-              <a:t>: """</a:t>
-            </a:r>
-            <a:endParaRPr lang="en-US" sz="1000" dirty="0"/>
-          </a:p>
-          <a:p>
-            <a:pPr indent="0" marL="0">
-              <a:lnSpc>
-                <a:spcPct val="100000"/>
-              </a:lnSpc>
-              <a:buNone/>
-            </a:pPr>
-            <a:r>
-              <a:rPr lang="en-US" sz="1000" dirty="0">
-                <a:solidFill>
-                  <a:srgbClr val="CFE9FE"/>
-                </a:solidFill>
-                <a:latin typeface="Courier New" pitchFamily="34" charset="0"/>
-                <a:ea typeface="Courier New" pitchFamily="34" charset="-122"/>
-                <a:cs typeface="Courier New" pitchFamily="34" charset="-120"/>
-              </a:rPr>
-              <a:t>    </a:t>
-            </a:r>
-            <a:pPr indent="0" marL="0">
-              <a:lnSpc>
-                <a:spcPct val="100000"/>
-              </a:lnSpc>
-              <a:buNone/>
-            </a:pPr>
-            <a:r>
-              <a:rPr lang="en-US" sz="1000" b="1" dirty="0">
-                <a:solidFill>
-                  <a:srgbClr val="0B9DE0"/>
-                </a:solidFill>
-                <a:latin typeface="Courier New" pitchFamily="34" charset="0"/>
-                <a:ea typeface="Courier New" pitchFamily="34" charset="-122"/>
-                <a:cs typeface="Courier New" pitchFamily="34" charset="-120"/>
-              </a:rPr>
-              <a:t>SELECT</a:t>
-            </a:r>
-            <a:pPr indent="0" marL="0">
-              <a:lnSpc>
-                <a:spcPct val="100000"/>
-              </a:lnSpc>
-              <a:buNone/>
-            </a:pPr>
-            <a:r>
-              <a:rPr lang="en-US" sz="1000" dirty="0">
-                <a:solidFill>
-                  <a:srgbClr val="CFE9FE"/>
-                </a:solidFill>
-                <a:latin typeface="Courier New" pitchFamily="34" charset="0"/>
-                <a:ea typeface="Courier New" pitchFamily="34" charset="-122"/>
-                <a:cs typeface="Courier New" pitchFamily="34" charset="-120"/>
-              </a:rPr>
-              <a:t> WhatId, Subject, CreatedDate, CompletedDateTime,</a:t>
-            </a:r>
-            <a:endParaRPr lang="en-US" sz="1000" dirty="0"/>
-          </a:p>
-          <a:p>
-            <a:pPr indent="0" marL="0">
-              <a:lnSpc>
-                <a:spcPct val="100000"/>
-              </a:lnSpc>
-              <a:buNone/>
-            </a:pPr>
-            <a:r>
-              <a:rPr lang="en-US" sz="1000" dirty="0">
-                <a:solidFill>
-                  <a:srgbClr val="CFE9FE"/>
-                </a:solidFill>
-                <a:latin typeface="Courier New" pitchFamily="34" charset="0"/>
-                <a:ea typeface="Courier New" pitchFamily="34" charset="-122"/>
-                <a:cs typeface="Courier New" pitchFamily="34" charset="-120"/>
-              </a:rPr>
-              <a:t>           OwnerId, Owner.Name, Status</a:t>
-            </a:r>
-            <a:endParaRPr lang="en-US" sz="1000" dirty="0"/>
-          </a:p>
-          <a:p>
-            <a:pPr indent="0" marL="0">
-              <a:lnSpc>
-                <a:spcPct val="100000"/>
-              </a:lnSpc>
-              <a:buNone/>
-            </a:pPr>
-            <a:r>
-              <a:rPr lang="en-US" sz="1000" dirty="0">
-                <a:solidFill>
-                  <a:srgbClr val="CFE9FE"/>
-                </a:solidFill>
-                <a:latin typeface="Courier New" pitchFamily="34" charset="0"/>
-                <a:ea typeface="Courier New" pitchFamily="34" charset="-122"/>
-                <a:cs typeface="Courier New" pitchFamily="34" charset="-120"/>
-              </a:rPr>
-              <a:t>    </a:t>
-            </a:r>
-            <a:pPr indent="0" marL="0">
-              <a:lnSpc>
-                <a:spcPct val="100000"/>
-              </a:lnSpc>
-              <a:buNone/>
-            </a:pPr>
-            <a:r>
-              <a:rPr lang="en-US" sz="1000" b="1" dirty="0">
-                <a:solidFill>
-                  <a:srgbClr val="0B9DE0"/>
-                </a:solidFill>
-                <a:latin typeface="Courier New" pitchFamily="34" charset="0"/>
-                <a:ea typeface="Courier New" pitchFamily="34" charset="-122"/>
-                <a:cs typeface="Courier New" pitchFamily="34" charset="-120"/>
-              </a:rPr>
-              <a:t>FROM</a:t>
-            </a:r>
-            <a:pPr indent="0" marL="0">
-              <a:lnSpc>
-                <a:spcPct val="100000"/>
-              </a:lnSpc>
-              <a:buNone/>
-            </a:pPr>
-            <a:r>
-              <a:rPr lang="en-US" sz="1000" dirty="0">
-                <a:solidFill>
-                  <a:srgbClr val="CFE9FE"/>
-                </a:solidFill>
-                <a:latin typeface="Courier New" pitchFamily="34" charset="0"/>
-                <a:ea typeface="Courier New" pitchFamily="34" charset="-122"/>
-                <a:cs typeface="Courier New" pitchFamily="34" charset="-120"/>
-              </a:rPr>
-              <a:t> Task</a:t>
-            </a:r>
-            <a:endParaRPr lang="en-US" sz="1000" dirty="0"/>
-          </a:p>
-          <a:p>
-            <a:pPr indent="0" marL="0">
-              <a:lnSpc>
-                <a:spcPct val="100000"/>
-              </a:lnSpc>
-              <a:buNone/>
-            </a:pPr>
-            <a:r>
-              <a:rPr lang="en-US" sz="1000" dirty="0">
-                <a:solidFill>
-                  <a:srgbClr val="CFE9FE"/>
-                </a:solidFill>
-                <a:latin typeface="Courier New" pitchFamily="34" charset="0"/>
-                <a:ea typeface="Courier New" pitchFamily="34" charset="-122"/>
-                <a:cs typeface="Courier New" pitchFamily="34" charset="-120"/>
-              </a:rPr>
-              <a:t>    </a:t>
-            </a:r>
-            <a:pPr indent="0" marL="0">
-              <a:lnSpc>
-                <a:spcPct val="100000"/>
-              </a:lnSpc>
-              <a:buNone/>
-            </a:pPr>
-            <a:r>
-              <a:rPr lang="en-US" sz="1000" b="1" dirty="0">
-                <a:solidFill>
-                  <a:srgbClr val="0B9DE0"/>
-                </a:solidFill>
-                <a:latin typeface="Courier New" pitchFamily="34" charset="0"/>
-                <a:ea typeface="Courier New" pitchFamily="34" charset="-122"/>
-                <a:cs typeface="Courier New" pitchFamily="34" charset="-120"/>
-              </a:rPr>
-              <a:t>WHERE</a:t>
-            </a:r>
-            <a:pPr indent="0" marL="0">
-              <a:lnSpc>
-                <a:spcPct val="100000"/>
-              </a:lnSpc>
-              <a:buNone/>
-            </a:pPr>
-            <a:r>
-              <a:rPr lang="en-US" sz="1000" dirty="0">
-                <a:solidFill>
-                  <a:srgbClr val="CFE9FE"/>
-                </a:solidFill>
-                <a:latin typeface="Courier New" pitchFamily="34" charset="0"/>
-                <a:ea typeface="Courier New" pitchFamily="34" charset="-122"/>
-                <a:cs typeface="Courier New" pitchFamily="34" charset="-120"/>
-              </a:rPr>
-              <a:t> What.Type = </a:t>
-            </a:r>
-            <a:pPr indent="0" marL="0">
-              <a:lnSpc>
-                <a:spcPct val="100000"/>
-              </a:lnSpc>
-              <a:buNone/>
-            </a:pPr>
-            <a:r>
-              <a:rPr lang="en-US" sz="1000" dirty="0">
-                <a:solidFill>
-                  <a:srgbClr val="FE9339"/>
-                </a:solidFill>
-                <a:latin typeface="Courier New" pitchFamily="34" charset="0"/>
-                <a:ea typeface="Courier New" pitchFamily="34" charset="-122"/>
-                <a:cs typeface="Courier New" pitchFamily="34" charset="-120"/>
-              </a:rPr>
-              <a:t>'Opportunity'</a:t>
-            </a:r>
-            <a:pPr indent="0" marL="0">
-              <a:lnSpc>
-                <a:spcPct val="100000"/>
-              </a:lnSpc>
-              <a:buNone/>
-            </a:pPr>
-            <a:r>
-              <a:rPr lang="en-US" sz="1000" dirty="0">
-                <a:solidFill>
-                  <a:srgbClr val="FE9339"/>
-                </a:solidFill>
-                <a:latin typeface="Courier New" pitchFamily="34" charset="0"/>
-                <a:ea typeface="Courier New" pitchFamily="34" charset="-122"/>
-                <a:cs typeface="Courier New" pitchFamily="34" charset="-120"/>
-              </a:rPr>
-              <a:t>""",</a:t>
-            </a:r>
-            <a:endParaRPr lang="en-US" sz="1000" dirty="0"/>
-          </a:p>
-          <a:p>
-            <a:pPr indent="0" marL="0">
-              <a:lnSpc>
-                <a:spcPct val="100000"/>
-              </a:lnSpc>
-              <a:buNone/>
-            </a:pPr>
-            <a:r>
-              <a:rPr lang="en-US" sz="1000" dirty="0">
-                <a:solidFill>
-                  <a:srgbClr val="CFE9FE"/>
-                </a:solidFill>
-                <a:latin typeface="Courier New" pitchFamily="34" charset="0"/>
-                <a:ea typeface="Courier New" pitchFamily="34" charset="-122"/>
-                <a:cs typeface="Courier New" pitchFamily="34" charset="-120"/>
-              </a:rPr>
-              <a:t>    </a:t>
-            </a:r>
-            <a:pPr indent="0" marL="0">
-              <a:lnSpc>
-                <a:spcPct val="100000"/>
-              </a:lnSpc>
-              <a:buNone/>
-            </a:pPr>
-            <a:r>
-              <a:rPr lang="en-US" sz="1000" dirty="0">
-                <a:solidFill>
-                  <a:srgbClr val="FE9339"/>
-                </a:solidFill>
-                <a:latin typeface="Courier New" pitchFamily="34" charset="0"/>
-                <a:ea typeface="Courier New" pitchFamily="34" charset="-122"/>
-                <a:cs typeface="Courier New" pitchFamily="34" charset="-120"/>
-              </a:rPr>
-              <a:t>"leads"</a:t>
-            </a:r>
-            <a:pPr indent="0" marL="0">
-              <a:lnSpc>
-                <a:spcPct val="100000"/>
-              </a:lnSpc>
-              <a:buNone/>
-            </a:pPr>
-            <a:r>
-              <a:rPr lang="en-US" sz="1000" dirty="0">
-                <a:solidFill>
-                  <a:srgbClr val="CFE9FE"/>
-                </a:solidFill>
-                <a:latin typeface="Courier New" pitchFamily="34" charset="0"/>
-                <a:ea typeface="Courier New" pitchFamily="34" charset="-122"/>
-                <a:cs typeface="Courier New" pitchFamily="34" charset="-120"/>
-              </a:rPr>
-              <a:t>: """</a:t>
-            </a:r>
-            <a:endParaRPr lang="en-US" sz="1000" dirty="0"/>
-          </a:p>
-          <a:p>
-            <a:pPr indent="0" marL="0">
-              <a:lnSpc>
-                <a:spcPct val="100000"/>
-              </a:lnSpc>
-              <a:buNone/>
-            </a:pPr>
-            <a:r>
-              <a:rPr lang="en-US" sz="1000" dirty="0">
-                <a:solidFill>
-                  <a:srgbClr val="CFE9FE"/>
-                </a:solidFill>
-                <a:latin typeface="Courier New" pitchFamily="34" charset="0"/>
-                <a:ea typeface="Courier New" pitchFamily="34" charset="-122"/>
-                <a:cs typeface="Courier New" pitchFamily="34" charset="-120"/>
-              </a:rPr>
-              <a:t>    </a:t>
-            </a:r>
-            <a:pPr indent="0" marL="0">
-              <a:lnSpc>
-                <a:spcPct val="100000"/>
-              </a:lnSpc>
-              <a:buNone/>
-            </a:pPr>
-            <a:r>
-              <a:rPr lang="en-US" sz="1000" b="1" dirty="0">
-                <a:solidFill>
-                  <a:srgbClr val="0B9DE0"/>
-                </a:solidFill>
-                <a:latin typeface="Courier New" pitchFamily="34" charset="0"/>
-                <a:ea typeface="Courier New" pitchFamily="34" charset="-122"/>
-                <a:cs typeface="Courier New" pitchFamily="34" charset="-120"/>
-              </a:rPr>
-              <a:t>SELECT</a:t>
-            </a:r>
-            <a:pPr indent="0" marL="0">
-              <a:lnSpc>
-                <a:spcPct val="100000"/>
-              </a:lnSpc>
-              <a:buNone/>
-            </a:pPr>
-            <a:r>
-              <a:rPr lang="en-US" sz="1000" dirty="0">
-                <a:solidFill>
-                  <a:srgbClr val="CFE9FE"/>
-                </a:solidFill>
-                <a:latin typeface="Courier New" pitchFamily="34" charset="0"/>
-                <a:ea typeface="Courier New" pitchFamily="34" charset="-122"/>
-                <a:cs typeface="Courier New" pitchFamily="34" charset="-120"/>
-              </a:rPr>
-              <a:t> Id, CreatedDate, ConvertedDate, ConvertedOpportunityId,</a:t>
-            </a:r>
-            <a:endParaRPr lang="en-US" sz="1000" dirty="0"/>
-          </a:p>
-          <a:p>
-            <a:pPr indent="0" marL="0">
-              <a:lnSpc>
-                <a:spcPct val="100000"/>
-              </a:lnSpc>
-              <a:buNone/>
-            </a:pPr>
-            <a:r>
-              <a:rPr lang="en-US" sz="1000" dirty="0">
-                <a:solidFill>
-                  <a:srgbClr val="CFE9FE"/>
-                </a:solidFill>
-                <a:latin typeface="Courier New" pitchFamily="34" charset="0"/>
-                <a:ea typeface="Courier New" pitchFamily="34" charset="-122"/>
-                <a:cs typeface="Courier New" pitchFamily="34" charset="-120"/>
-              </a:rPr>
-              <a:t>           OwnerId, Owner.Name</a:t>
-            </a:r>
-            <a:endParaRPr lang="en-US" sz="1000" dirty="0"/>
-          </a:p>
-          <a:p>
-            <a:pPr indent="0" marL="0">
-              <a:lnSpc>
-                <a:spcPct val="100000"/>
-              </a:lnSpc>
-              <a:buNone/>
-            </a:pPr>
-            <a:r>
-              <a:rPr lang="en-US" sz="1000" dirty="0">
-                <a:solidFill>
-                  <a:srgbClr val="CFE9FE"/>
-                </a:solidFill>
-                <a:latin typeface="Courier New" pitchFamily="34" charset="0"/>
-                <a:ea typeface="Courier New" pitchFamily="34" charset="-122"/>
-                <a:cs typeface="Courier New" pitchFamily="34" charset="-120"/>
-              </a:rPr>
-              <a:t>    </a:t>
-            </a:r>
-            <a:pPr indent="0" marL="0">
-              <a:lnSpc>
-                <a:spcPct val="100000"/>
-              </a:lnSpc>
-              <a:buNone/>
-            </a:pPr>
-            <a:r>
-              <a:rPr lang="en-US" sz="1000" b="1" dirty="0">
-                <a:solidFill>
-                  <a:srgbClr val="0B9DE0"/>
-                </a:solidFill>
-                <a:latin typeface="Courier New" pitchFamily="34" charset="0"/>
-                <a:ea typeface="Courier New" pitchFamily="34" charset="-122"/>
-                <a:cs typeface="Courier New" pitchFamily="34" charset="-120"/>
-              </a:rPr>
-              <a:t>FROM</a:t>
-            </a:r>
-            <a:pPr indent="0" marL="0">
-              <a:lnSpc>
-                <a:spcPct val="100000"/>
-              </a:lnSpc>
-              <a:buNone/>
-            </a:pPr>
-            <a:r>
-              <a:rPr lang="en-US" sz="1000" dirty="0">
-                <a:solidFill>
-                  <a:srgbClr val="CFE9FE"/>
-                </a:solidFill>
-                <a:latin typeface="Courier New" pitchFamily="34" charset="0"/>
-                <a:ea typeface="Courier New" pitchFamily="34" charset="-122"/>
-                <a:cs typeface="Courier New" pitchFamily="34" charset="-120"/>
-              </a:rPr>
-              <a:t> Lead</a:t>
-            </a:r>
-            <a:endParaRPr lang="en-US" sz="1000" dirty="0"/>
-          </a:p>
-          <a:p>
-            <a:pPr indent="0" marL="0">
-              <a:lnSpc>
-                <a:spcPct val="100000"/>
-              </a:lnSpc>
-              <a:buNone/>
-            </a:pPr>
-            <a:r>
-              <a:rPr lang="en-US" sz="1000" dirty="0">
-                <a:solidFill>
-                  <a:srgbClr val="CFE9FE"/>
-                </a:solidFill>
-                <a:latin typeface="Courier New" pitchFamily="34" charset="0"/>
-                <a:ea typeface="Courier New" pitchFamily="34" charset="-122"/>
-                <a:cs typeface="Courier New" pitchFamily="34" charset="-120"/>
-              </a:rPr>
-              <a:t>    </a:t>
-            </a:r>
-            <a:pPr indent="0" marL="0">
-              <a:lnSpc>
-                <a:spcPct val="100000"/>
-              </a:lnSpc>
-              <a:buNone/>
-            </a:pPr>
-            <a:r>
-              <a:rPr lang="en-US" sz="1000" b="1" dirty="0">
-                <a:solidFill>
-                  <a:srgbClr val="0B9DE0"/>
-                </a:solidFill>
-                <a:latin typeface="Courier New" pitchFamily="34" charset="0"/>
-                <a:ea typeface="Courier New" pitchFamily="34" charset="-122"/>
-                <a:cs typeface="Courier New" pitchFamily="34" charset="-120"/>
-              </a:rPr>
-              <a:t>WHERE</a:t>
-            </a:r>
-            <a:pPr indent="0" marL="0">
-              <a:lnSpc>
-                <a:spcPct val="100000"/>
-              </a:lnSpc>
-              <a:buNone/>
-            </a:pPr>
-            <a:r>
-              <a:rPr lang="en-US" sz="1000" dirty="0">
-                <a:solidFill>
-                  <a:srgbClr val="CFE9FE"/>
-                </a:solidFill>
-                <a:latin typeface="Courier New" pitchFamily="34" charset="0"/>
-                <a:ea typeface="Courier New" pitchFamily="34" charset="-122"/>
-                <a:cs typeface="Courier New" pitchFamily="34" charset="-120"/>
-              </a:rPr>
-              <a:t> IsConverted = true</a:t>
-            </a:r>
-            <a:endParaRPr lang="en-US" sz="1000" dirty="0"/>
-          </a:p>
-          <a:p>
-            <a:pPr indent="0" marL="0">
-              <a:lnSpc>
-                <a:spcPct val="100000"/>
-              </a:lnSpc>
-              <a:buNone/>
-            </a:pPr>
-            <a:r>
-              <a:rPr lang="en-US" sz="1000" dirty="0">
-                <a:solidFill>
-                  <a:srgbClr val="CFE9FE"/>
-                </a:solidFill>
-                <a:latin typeface="Courier New" pitchFamily="34" charset="0"/>
-                <a:ea typeface="Courier New" pitchFamily="34" charset="-122"/>
-                <a:cs typeface="Courier New" pitchFamily="34" charset="-120"/>
-              </a:rPr>
-              <a:t>      </a:t>
-            </a:r>
-            <a:pPr indent="0" marL="0">
-              <a:lnSpc>
-                <a:spcPct val="100000"/>
-              </a:lnSpc>
-              <a:buNone/>
-            </a:pPr>
-            <a:r>
-              <a:rPr lang="en-US" sz="1000" b="1" dirty="0">
-                <a:solidFill>
-                  <a:srgbClr val="0B9DE0"/>
-                </a:solidFill>
-                <a:latin typeface="Courier New" pitchFamily="34" charset="0"/>
-                <a:ea typeface="Courier New" pitchFamily="34" charset="-122"/>
-                <a:cs typeface="Courier New" pitchFamily="34" charset="-120"/>
-              </a:rPr>
-              <a:t>AND</a:t>
-            </a:r>
-            <a:pPr indent="0" marL="0">
-              <a:lnSpc>
-                <a:spcPct val="100000"/>
-              </a:lnSpc>
-              <a:buNone/>
-            </a:pPr>
-            <a:r>
-              <a:rPr lang="en-US" sz="1000" dirty="0">
-                <a:solidFill>
-                  <a:srgbClr val="CFE9FE"/>
-                </a:solidFill>
-                <a:latin typeface="Courier New" pitchFamily="34" charset="0"/>
-                <a:ea typeface="Courier New" pitchFamily="34" charset="-122"/>
-                <a:cs typeface="Courier New" pitchFamily="34" charset="-120"/>
-              </a:rPr>
-              <a:t> ConvertedOpportunityId != null""",</a:t>
-            </a:r>
-            <a:endParaRPr lang="en-US" sz="1000" dirty="0"/>
-          </a:p>
-          <a:p>
-            <a:pPr indent="0" marL="0">
-              <a:lnSpc>
-                <a:spcPct val="100000"/>
-              </a:lnSpc>
-              <a:buNone/>
-            </a:pPr>
-            <a:r>
-              <a:rPr lang="en-US" sz="1000" dirty="0">
-                <a:solidFill>
-                  <a:srgbClr val="CFE9FE"/>
-                </a:solidFill>
-                <a:latin typeface="Courier New" pitchFamily="34" charset="0"/>
-                <a:ea typeface="Courier New" pitchFamily="34" charset="-122"/>
-                <a:cs typeface="Courier New" pitchFamily="34" charset="-120"/>
-              </a:rPr>
-              <a:t>}</a:t>
-            </a:r>
-            <a:endParaRPr lang="en-US" sz="1000" dirty="0"/>
-          </a:p>
-        </p:txBody>
-      </p:sp>
-      <p:sp>
-        <p:nvSpPr>
-          <p:cNvPr id="12" name="Code caption"/>
-          <p:cNvSpPr txBox="1"/>
-          <p:nvPr/>
-        </p:nvSpPr>
-        <p:spPr>
-          <a:xfrm>
-            <a:off x="5897880" y="5669280"/>
-            <a:ext cx="5715000" cy="685800"/>
-          </a:xfrm>
-          <a:prstGeom prst="rect">
-            <a:avLst/>
-          </a:prstGeom>
-          <a:noFill/>
-          <a:ln/>
-        </p:spPr>
-        <p:txBody>
-          <a:bodyPr wrap="square" lIns="0" tIns="0" rIns="0" bIns="0" rtlCol="0" anchor="t"/>
-          <a:lstStyle/>
-          <a:p>
-            <a:pPr indent="0" marL="0">
-              <a:buNone/>
-            </a:pPr>
-            <a:r>
-              <a:rPr lang="en-US" sz="1400" b="1" dirty="0">
-                <a:solidFill>
-                  <a:schemeClr val="tx2"/>
-                </a:solidFill>
-              </a:rPr>
-              <a:t>extract.py: </a:t>
-            </a:r>
-            <a:pPr indent="0" marL="0">
-              <a:buNone/>
-            </a:pPr>
-            <a:r>
-              <a:rPr lang="en-US" sz="1400" dirty="0">
-                <a:solidFill>
-                  <a:schemeClr val="tx2"/>
-                </a:solidFill>
-              </a:rPr>
-              <a:t>four SOQL queries over the REST API, signed by the Salesforce CLI session. Opportunity Id becomes the case ID.</a:t>
-            </a:r>
-            <a:endParaRPr lang="en-US" sz="1400" dirty="0"/>
-          </a:p>
-        </p:txBody>
-      </p:sp>
-      <p:sp>
-        <p:nvSpPr>
-          <p:cNvPr id="25" name="Slide Number Placeholder 0"/>
-          <p:cNvSpPr>
-            <a:spLocks noGrp="1"/>
-          </p:cNvSpPr>
-          <p:nvPr>
-            <p:ph type="sldNum" sz="quarter" idx="4294967295"/>
-          </p:nvPr>
-        </p:nvSpPr>
-        <p:spPr>
-          <a:xfrm>
-            <a:off x="11155680" y="6400800"/>
-            <a:ext cx="457200" cy="274320"/>
-          </a:xfrm>
-          <a:prstGeom prst="rect">
-            <a:avLst/>
-          </a:prstGeom>
-          <a:extLst>
-            <a:ext uri="{C572A759-6A51-4108-AA02-DFA0A04FC94B}">
-              <ma14:wrappingTextBoxFlag xmlns:ma14="http://schemas.microsoft.com/office/mac/drawingml/2011/main" val="0"/>
-            </a:ext>
-          </a:extLst>
-        </p:spPr>
-        <p:txBody>
-          <a:bodyPr/>
-          <a:lstStyle>
-            <a:lvl1pPr>
-              <a:defRPr sz="1000">
-                <a:solidFill>
-                  <a:schemeClr val="accent6"/>
-                </a:solidFill>
-              </a:defRPr>
-            </a:lvl1pPr>
-          </a:lstStyle>
-          <a:p>
-            <a:pPr algn="r"/>
-            <a:fld id="{F7021451-1387-4CA6-816F-3879F97B5CBC}" type="slidenum">
-              <a:rPr b="0" lang="en-US"/>
-              <a:t>6</a:t>
-            </a:fld>
-            <a:endParaRPr lang="en-US"/>
-          </a:p>
-        </p:txBody>
-      </p:sp>
-    </p:spTree>
-  </p:cSld>
-  <p:clrMapOvr>
-    <a:masterClrMapping/>
-  </p:clrMapOvr>
-</p:sld>
-</file>
-
-<file path=ppt/slides/slide7.xml><?xml version="1.0" encoding="utf-8"?>
-<p:sld xmlns:a="http://schemas.openxmlformats.org/drawingml/2006/main" xmlns:r="http://schemas.openxmlformats.org/officeDocument/2006/relationships" xmlns:p="http://schemas.openxmlformats.org/presentationml/2006/main">
-  <p:cSld name="Slide 7">
-    <p:spTree>
-      <p:nvGrpSpPr>
-        <p:cNvPr id="1" name=""/>
-        <p:cNvGrpSpPr/>
-        <p:nvPr/>
-      </p:nvGrpSpPr>
-      <p:grpSpPr>
-        <a:xfrm>
-          <a:off x="0" y="0"/>
-          <a:ext cx="0" cy="0"/>
-          <a:chOff x="0" y="0"/>
-          <a:chExt cx="0" cy="0"/>
-        </a:xfrm>
-      </p:grpSpPr>
-      <p:sp>
-        <p:nvSpPr>
-          <p:cNvPr id="2" name="Text 0"/>
-          <p:cNvSpPr/>
-          <p:nvPr>
-            <p:ph idx="100" type="title" hasCustomPrompt="1"/>
-          </p:nvPr>
-        </p:nvSpPr>
-        <p:spPr>
-          <a:xfrm>
-            <a:off x="548640" y="320040"/>
-            <a:ext cx="11064240" cy="822960"/>
-          </a:xfrm>
-          <a:prstGeom prst="rect">
-            <a:avLst/>
-          </a:prstGeom>
-          <a:noFill/>
-          <a:ln/>
-        </p:spPr>
-        <p:txBody>
-          <a:bodyPr wrap="square" lIns="0" tIns="0" rIns="0" bIns="0" rtlCol="0" anchor="ctr"/>
-          <a:lstStyle/>
-          <a:p>
-            <a:pPr algn="l" indent="0" marL="0">
-              <a:buNone/>
-            </a:pPr>
-            <a:r>
-              <a:rPr lang="en-US" sz="3000" b="1" dirty="0">
-                <a:solidFill>
-                  <a:schemeClr val="tx2"/>
-                </a:solidFill>
-              </a:rPr>
-              <a:t>Everything is live and open to inspect</a:t>
-            </a:r>
-            <a:endParaRPr lang="en-US" sz="3000" dirty="0"/>
-          </a:p>
-        </p:txBody>
-      </p:sp>
-      <p:sp>
-        <p:nvSpPr>
-          <p:cNvPr id="3" name="Proof 1"/>
-          <p:cNvSpPr/>
-          <p:nvPr/>
-        </p:nvSpPr>
-        <p:spPr>
-          <a:xfrm>
-            <a:off x="548640" y="1417320"/>
-            <a:ext cx="6035040" cy="960120"/>
-          </a:xfrm>
-          <a:prstGeom prst="roundRect">
-            <a:avLst>
-              <a:gd name="adj" fmla="val 11429"/>
-            </a:avLst>
-          </a:prstGeom>
-          <a:solidFill>
-            <a:schemeClr val="bg2"/>
-          </a:solidFill>
-          <a:ln/>
-        </p:spPr>
-      </p:sp>
-      <p:sp>
-        <p:nvSpPr>
-          <p:cNvPr id="4" name="Proof 1 marker"/>
-          <p:cNvSpPr/>
-          <p:nvPr/>
-        </p:nvSpPr>
-        <p:spPr>
-          <a:xfrm>
-            <a:off x="749808" y="1691640"/>
-            <a:ext cx="411480" cy="411480"/>
-          </a:xfrm>
-          <a:prstGeom prst="ellipse">
-            <a:avLst/>
-          </a:prstGeom>
-          <a:solidFill>
-            <a:schemeClr val="accent1"/>
-          </a:solidFill>
-          <a:ln/>
-        </p:spPr>
-      </p:sp>
-      <p:sp>
-        <p:nvSpPr>
-          <p:cNvPr id="5" name="Proof 1 glyph"/>
-          <p:cNvSpPr txBox="1"/>
-          <p:nvPr/>
-        </p:nvSpPr>
-        <p:spPr>
-          <a:xfrm>
-            <a:off x="749808" y="1691640"/>
-            <a:ext cx="411480" cy="411480"/>
-          </a:xfrm>
-          <a:prstGeom prst="rect">
-            <a:avLst/>
-          </a:prstGeom>
-          <a:noFill/>
-          <a:ln/>
-        </p:spPr>
-        <p:txBody>
-          <a:bodyPr wrap="square" lIns="0" tIns="0" rIns="0" bIns="0" rtlCol="0" anchor="ctr"/>
-          <a:lstStyle/>
-          <a:p>
-            <a:pPr algn="ctr" indent="0" marL="0">
-              <a:buNone/>
-            </a:pPr>
-            <a:r>
-              <a:rPr lang="en-US" sz="1600" b="1" dirty="0">
-                <a:solidFill>
-                  <a:schemeClr val="bg1"/>
-                </a:solidFill>
-              </a:rPr>
-              <a:t>→</a:t>
-            </a:r>
-            <a:endParaRPr lang="en-US" sz="1600" dirty="0"/>
-          </a:p>
-        </p:txBody>
-      </p:sp>
-      <p:sp>
-        <p:nvSpPr>
-          <p:cNvPr id="6" name="Proof 1 label"/>
-          <p:cNvSpPr txBox="1"/>
-          <p:nvPr/>
-        </p:nvSpPr>
-        <p:spPr>
-          <a:xfrm>
-            <a:off x="1325880" y="1545336"/>
-            <a:ext cx="5120640" cy="347472"/>
-          </a:xfrm>
-          <a:prstGeom prst="rect">
-            <a:avLst/>
-          </a:prstGeom>
-          <a:noFill/>
-          <a:ln/>
-        </p:spPr>
-        <p:txBody>
-          <a:bodyPr wrap="square" lIns="0" tIns="0" rIns="0" bIns="0" rtlCol="0" anchor="t"/>
-          <a:lstStyle/>
-          <a:p>
-            <a:pPr indent="0" marL="0">
-              <a:buNone/>
-            </a:pPr>
-            <a:r>
-              <a:rPr lang="en-US" sz="1600" b="1" dirty="0">
-                <a:solidFill>
-                  <a:schemeClr val="tx2"/>
-                </a:solidFill>
-              </a:rPr>
-              <a:t>Process dashboard</a:t>
-            </a:r>
-            <a:endParaRPr lang="en-US" sz="1600" dirty="0"/>
-          </a:p>
-        </p:txBody>
-      </p:sp>
-      <p:sp>
-        <p:nvSpPr>
-          <p:cNvPr id="7" name="Proof 1 link"/>
-          <p:cNvSpPr txBox="1"/>
-          <p:nvPr/>
-        </p:nvSpPr>
-        <p:spPr>
-          <a:xfrm>
-            <a:off x="1325880" y="1911096"/>
-            <a:ext cx="5120640" cy="347472"/>
-          </a:xfrm>
-          <a:prstGeom prst="rect">
-            <a:avLst/>
-          </a:prstGeom>
-          <a:noFill/>
-          <a:ln/>
-        </p:spPr>
-        <p:txBody>
-          <a:bodyPr wrap="square" lIns="0" tIns="0" rIns="0" bIns="0" rtlCol="0" anchor="t"/>
-          <a:lstStyle/>
-          <a:p>
-            <a:pPr indent="0" marL="0">
-              <a:buNone/>
-            </a:pPr>
-            <a:r>
-              <a:rPr lang="en-US" sz="1400" u="sng" dirty="0">
-                <a:solidFill>
-                  <a:schemeClr val="accent6"/>
-                </a:solidFill>
-                <a:hlinkClick r:id="rId1" invalidUrl="" action="" tgtFrame="" tooltip="" history="1" highlightClick="0" endSnd="0">
-                  <a:extLst>
-                    <a:ext uri="{A12FA001-AC4F-418D-AE19-62706E023703}">
-                      <ahyp:hlinkClr xmlns:ahyp="http://schemas.microsoft.com/office/drawing/2018/hyperlinkcolor" val="tx"/>
-                    </a:ext>
-                  </a:extLst>
-                </a:hlinkClick>
-              </a:rPr>
-              <a:t>salesforce-process-intelligence.vercel.app</a:t>
-            </a:r>
-            <a:endParaRPr lang="en-US" sz="1400" dirty="0"/>
-          </a:p>
-        </p:txBody>
-      </p:sp>
-      <p:sp>
-        <p:nvSpPr>
-          <p:cNvPr id="8" name="Proof 2"/>
-          <p:cNvSpPr/>
-          <p:nvPr/>
-        </p:nvSpPr>
-        <p:spPr>
-          <a:xfrm>
-            <a:off x="548640" y="2532888"/>
-            <a:ext cx="6035040" cy="960120"/>
-          </a:xfrm>
-          <a:prstGeom prst="roundRect">
-            <a:avLst>
-              <a:gd name="adj" fmla="val 11429"/>
-            </a:avLst>
-          </a:prstGeom>
-          <a:solidFill>
-            <a:schemeClr val="bg2"/>
-          </a:solidFill>
-          <a:ln/>
-        </p:spPr>
-      </p:sp>
-      <p:sp>
-        <p:nvSpPr>
-          <p:cNvPr id="9" name="Proof 2 marker"/>
-          <p:cNvSpPr/>
-          <p:nvPr/>
-        </p:nvSpPr>
-        <p:spPr>
-          <a:xfrm>
-            <a:off x="749808" y="2807208"/>
-            <a:ext cx="411480" cy="411480"/>
-          </a:xfrm>
-          <a:prstGeom prst="ellipse">
-            <a:avLst/>
-          </a:prstGeom>
-          <a:solidFill>
-            <a:schemeClr val="accent1"/>
-          </a:solidFill>
-          <a:ln/>
-        </p:spPr>
-      </p:sp>
-      <p:sp>
-        <p:nvSpPr>
-          <p:cNvPr id="10" name="Proof 2 glyph"/>
-          <p:cNvSpPr txBox="1"/>
-          <p:nvPr/>
-        </p:nvSpPr>
-        <p:spPr>
-          <a:xfrm>
-            <a:off x="749808" y="2807208"/>
-            <a:ext cx="411480" cy="411480"/>
-          </a:xfrm>
-          <a:prstGeom prst="rect">
-            <a:avLst/>
-          </a:prstGeom>
-          <a:noFill/>
-          <a:ln/>
-        </p:spPr>
-        <p:txBody>
-          <a:bodyPr wrap="square" lIns="0" tIns="0" rIns="0" bIns="0" rtlCol="0" anchor="ctr"/>
-          <a:lstStyle/>
-          <a:p>
-            <a:pPr algn="ctr" indent="0" marL="0">
-              <a:buNone/>
-            </a:pPr>
-            <a:r>
-              <a:rPr lang="en-US" sz="1600" b="1" dirty="0">
-                <a:solidFill>
-                  <a:schemeClr val="bg1"/>
-                </a:solidFill>
-              </a:rPr>
-              <a:t>→</a:t>
-            </a:r>
-            <a:endParaRPr lang="en-US" sz="1600" dirty="0"/>
-          </a:p>
-        </p:txBody>
-      </p:sp>
-      <p:sp>
-        <p:nvSpPr>
-          <p:cNvPr id="11" name="Proof 2 label"/>
-          <p:cNvSpPr txBox="1"/>
-          <p:nvPr/>
-        </p:nvSpPr>
-        <p:spPr>
-          <a:xfrm>
-            <a:off x="1325880" y="2660904"/>
-            <a:ext cx="5120640" cy="347472"/>
-          </a:xfrm>
-          <a:prstGeom prst="rect">
-            <a:avLst/>
-          </a:prstGeom>
-          <a:noFill/>
-          <a:ln/>
-        </p:spPr>
-        <p:txBody>
-          <a:bodyPr wrap="square" lIns="0" tIns="0" rIns="0" bIns="0" rtlCol="0" anchor="t"/>
-          <a:lstStyle/>
-          <a:p>
-            <a:pPr indent="0" marL="0">
-              <a:buNone/>
-            </a:pPr>
-            <a:r>
-              <a:rPr lang="en-US" sz="1600" b="1" dirty="0">
-                <a:solidFill>
-                  <a:schemeClr val="tx2"/>
-                </a:solidFill>
-              </a:rPr>
-              <a:t>Value case one-pager</a:t>
-            </a:r>
-            <a:endParaRPr lang="en-US" sz="1600" dirty="0"/>
-          </a:p>
-        </p:txBody>
-      </p:sp>
-      <p:sp>
-        <p:nvSpPr>
-          <p:cNvPr id="12" name="Proof 2 link"/>
-          <p:cNvSpPr txBox="1"/>
-          <p:nvPr/>
-        </p:nvSpPr>
-        <p:spPr>
-          <a:xfrm>
-            <a:off x="1325880" y="3026664"/>
-            <a:ext cx="5120640" cy="347472"/>
-          </a:xfrm>
-          <a:prstGeom prst="rect">
-            <a:avLst/>
-          </a:prstGeom>
-          <a:noFill/>
-          <a:ln/>
-        </p:spPr>
-        <p:txBody>
-          <a:bodyPr wrap="square" lIns="0" tIns="0" rIns="0" bIns="0" rtlCol="0" anchor="t"/>
-          <a:lstStyle/>
-          <a:p>
-            <a:pPr indent="0" marL="0">
-              <a:buNone/>
-            </a:pPr>
-            <a:r>
-              <a:rPr lang="en-US" sz="1400" u="sng" dirty="0">
-                <a:solidFill>
-                  <a:schemeClr val="accent6"/>
-                </a:solidFill>
-                <a:hlinkClick r:id="rId2" invalidUrl="" action="" tgtFrame="" tooltip="" history="1" highlightClick="0" endSnd="0">
-                  <a:extLst>
-                    <a:ext uri="{A12FA001-AC4F-418D-AE19-62706E023703}">
-                      <ahyp:hlinkClr xmlns:ahyp="http://schemas.microsoft.com/office/drawing/2018/hyperlinkcolor" val="tx"/>
-                    </a:ext>
-                  </a:extLst>
-                </a:hlinkClick>
-              </a:rPr>
-              <a:t>salesforce-process-intelligence.vercel.app/value-case.html</a:t>
-            </a:r>
-            <a:endParaRPr lang="en-US" sz="1400" dirty="0"/>
-          </a:p>
-        </p:txBody>
-      </p:sp>
-      <p:sp>
-        <p:nvSpPr>
-          <p:cNvPr id="13" name="Proof 3"/>
-          <p:cNvSpPr/>
-          <p:nvPr/>
-        </p:nvSpPr>
-        <p:spPr>
-          <a:xfrm>
-            <a:off x="548640" y="3648456"/>
-            <a:ext cx="6035040" cy="960120"/>
-          </a:xfrm>
-          <a:prstGeom prst="roundRect">
-            <a:avLst>
-              <a:gd name="adj" fmla="val 11429"/>
-            </a:avLst>
-          </a:prstGeom>
-          <a:solidFill>
-            <a:schemeClr val="bg2"/>
-          </a:solidFill>
-          <a:ln/>
-        </p:spPr>
-      </p:sp>
-      <p:sp>
-        <p:nvSpPr>
-          <p:cNvPr id="14" name="Proof 3 marker"/>
-          <p:cNvSpPr/>
-          <p:nvPr/>
-        </p:nvSpPr>
-        <p:spPr>
-          <a:xfrm>
-            <a:off x="749808" y="3922776"/>
-            <a:ext cx="411480" cy="411480"/>
-          </a:xfrm>
-          <a:prstGeom prst="ellipse">
-            <a:avLst/>
-          </a:prstGeom>
-          <a:solidFill>
-            <a:schemeClr val="accent1"/>
-          </a:solidFill>
-          <a:ln/>
-        </p:spPr>
-      </p:sp>
-      <p:sp>
-        <p:nvSpPr>
-          <p:cNvPr id="15" name="Proof 3 glyph"/>
-          <p:cNvSpPr txBox="1"/>
-          <p:nvPr/>
-        </p:nvSpPr>
-        <p:spPr>
-          <a:xfrm>
-            <a:off x="749808" y="3922776"/>
-            <a:ext cx="411480" cy="411480"/>
-          </a:xfrm>
-          <a:prstGeom prst="rect">
-            <a:avLst/>
-          </a:prstGeom>
-          <a:noFill/>
-          <a:ln/>
-        </p:spPr>
-        <p:txBody>
-          <a:bodyPr wrap="square" lIns="0" tIns="0" rIns="0" bIns="0" rtlCol="0" anchor="ctr"/>
-          <a:lstStyle/>
-          <a:p>
-            <a:pPr algn="ctr" indent="0" marL="0">
-              <a:buNone/>
-            </a:pPr>
-            <a:r>
-              <a:rPr lang="en-US" sz="1600" b="1" dirty="0">
-                <a:solidFill>
-                  <a:schemeClr val="bg1"/>
-                </a:solidFill>
-              </a:rPr>
-              <a:t>→</a:t>
-            </a:r>
-            <a:endParaRPr lang="en-US" sz="1600" dirty="0"/>
-          </a:p>
-        </p:txBody>
-      </p:sp>
-      <p:sp>
-        <p:nvSpPr>
-          <p:cNvPr id="16" name="Proof 3 label"/>
-          <p:cNvSpPr txBox="1"/>
-          <p:nvPr/>
-        </p:nvSpPr>
-        <p:spPr>
-          <a:xfrm>
-            <a:off x="1325880" y="3776472"/>
-            <a:ext cx="5120640" cy="347472"/>
-          </a:xfrm>
-          <a:prstGeom prst="rect">
-            <a:avLst/>
-          </a:prstGeom>
-          <a:noFill/>
-          <a:ln/>
-        </p:spPr>
-        <p:txBody>
-          <a:bodyPr wrap="square" lIns="0" tIns="0" rIns="0" bIns="0" rtlCol="0" anchor="t"/>
-          <a:lstStyle/>
-          <a:p>
-            <a:pPr indent="0" marL="0">
-              <a:buNone/>
-            </a:pPr>
-            <a:r>
-              <a:rPr lang="en-US" sz="1600" b="1" dirty="0">
-                <a:solidFill>
-                  <a:schemeClr val="tx2"/>
-                </a:solidFill>
-              </a:rPr>
-              <a:t>Live Salesforce extract</a:t>
-            </a:r>
-            <a:endParaRPr lang="en-US" sz="1600" dirty="0"/>
-          </a:p>
-        </p:txBody>
-      </p:sp>
-      <p:sp>
-        <p:nvSpPr>
-          <p:cNvPr id="17" name="Proof 3 link"/>
-          <p:cNvSpPr txBox="1"/>
-          <p:nvPr/>
-        </p:nvSpPr>
-        <p:spPr>
-          <a:xfrm>
-            <a:off x="1325880" y="4142232"/>
-            <a:ext cx="5120640" cy="347472"/>
-          </a:xfrm>
-          <a:prstGeom prst="rect">
-            <a:avLst/>
-          </a:prstGeom>
-          <a:noFill/>
-          <a:ln/>
-        </p:spPr>
-        <p:txBody>
-          <a:bodyPr wrap="square" lIns="0" tIns="0" rIns="0" bIns="0" rtlCol="0" anchor="t"/>
-          <a:lstStyle/>
-          <a:p>
-            <a:pPr indent="0" marL="0">
-              <a:buNone/>
-            </a:pPr>
-            <a:r>
-              <a:rPr lang="en-US" sz="1400" u="sng" dirty="0">
-                <a:solidFill>
-                  <a:schemeClr val="accent6"/>
-                </a:solidFill>
-                <a:hlinkClick r:id="rId3" invalidUrl="" action="" tgtFrame="" tooltip="" history="1" highlightClick="0" endSnd="0">
-                  <a:extLst>
-                    <a:ext uri="{A12FA001-AC4F-418D-AE19-62706E023703}">
-                      <ahyp:hlinkClr xmlns:ahyp="http://schemas.microsoft.com/office/drawing/2018/hyperlinkcolor" val="tx"/>
-                    </a:ext>
-                  </a:extLst>
-                </a:hlinkClick>
-              </a:rPr>
-              <a:t>salesforce-process-intelligence.vercel.app/live.html</a:t>
-            </a:r>
-            <a:endParaRPr lang="en-US" sz="1400" dirty="0"/>
-          </a:p>
-        </p:txBody>
-      </p:sp>
-      <p:sp>
-        <p:nvSpPr>
-          <p:cNvPr id="18" name="Proof 4"/>
-          <p:cNvSpPr/>
-          <p:nvPr/>
-        </p:nvSpPr>
-        <p:spPr>
-          <a:xfrm>
-            <a:off x="548640" y="4764024"/>
-            <a:ext cx="6035040" cy="960120"/>
-          </a:xfrm>
-          <a:prstGeom prst="roundRect">
-            <a:avLst>
-              <a:gd name="adj" fmla="val 11429"/>
-            </a:avLst>
-          </a:prstGeom>
-          <a:solidFill>
-            <a:schemeClr val="bg2"/>
-          </a:solidFill>
-          <a:ln/>
-        </p:spPr>
-      </p:sp>
-      <p:sp>
-        <p:nvSpPr>
-          <p:cNvPr id="19" name="Proof 4 marker"/>
-          <p:cNvSpPr/>
-          <p:nvPr/>
-        </p:nvSpPr>
-        <p:spPr>
-          <a:xfrm>
-            <a:off x="749808" y="5038344"/>
-            <a:ext cx="411480" cy="411480"/>
-          </a:xfrm>
-          <a:prstGeom prst="ellipse">
-            <a:avLst/>
-          </a:prstGeom>
-          <a:solidFill>
-            <a:schemeClr val="accent1"/>
-          </a:solidFill>
-          <a:ln/>
-        </p:spPr>
-      </p:sp>
-      <p:sp>
-        <p:nvSpPr>
-          <p:cNvPr id="20" name="Proof 4 glyph"/>
-          <p:cNvSpPr txBox="1"/>
-          <p:nvPr/>
-        </p:nvSpPr>
-        <p:spPr>
-          <a:xfrm>
-            <a:off x="749808" y="5038344"/>
-            <a:ext cx="411480" cy="411480"/>
-          </a:xfrm>
-          <a:prstGeom prst="rect">
-            <a:avLst/>
-          </a:prstGeom>
-          <a:noFill/>
-          <a:ln/>
-        </p:spPr>
-        <p:txBody>
-          <a:bodyPr wrap="square" lIns="0" tIns="0" rIns="0" bIns="0" rtlCol="0" anchor="ctr"/>
-          <a:lstStyle/>
-          <a:p>
-            <a:pPr algn="ctr" indent="0" marL="0">
-              <a:buNone/>
-            </a:pPr>
-            <a:r>
-              <a:rPr lang="en-US" sz="1600" b="1" dirty="0">
-                <a:solidFill>
-                  <a:schemeClr val="bg1"/>
-                </a:solidFill>
-              </a:rPr>
-              <a:t>→</a:t>
-            </a:r>
-            <a:endParaRPr lang="en-US" sz="1600" dirty="0"/>
-          </a:p>
-        </p:txBody>
-      </p:sp>
-      <p:sp>
-        <p:nvSpPr>
-          <p:cNvPr id="21" name="Proof 4 label"/>
-          <p:cNvSpPr txBox="1"/>
-          <p:nvPr/>
-        </p:nvSpPr>
-        <p:spPr>
-          <a:xfrm>
-            <a:off x="1325880" y="4892040"/>
-            <a:ext cx="5120640" cy="347472"/>
-          </a:xfrm>
-          <a:prstGeom prst="rect">
-            <a:avLst/>
-          </a:prstGeom>
-          <a:noFill/>
-          <a:ln/>
-        </p:spPr>
-        <p:txBody>
-          <a:bodyPr wrap="square" lIns="0" tIns="0" rIns="0" bIns="0" rtlCol="0" anchor="t"/>
-          <a:lstStyle/>
-          <a:p>
-            <a:pPr indent="0" marL="0">
-              <a:buNone/>
-            </a:pPr>
-            <a:r>
-              <a:rPr lang="en-US" sz="1600" b="1" dirty="0">
-                <a:solidFill>
-                  <a:schemeClr val="tx2"/>
-                </a:solidFill>
-              </a:rPr>
-              <a:t>Source code and event logs</a:t>
-            </a:r>
-            <a:endParaRPr lang="en-US" sz="1600" dirty="0"/>
-          </a:p>
-        </p:txBody>
-      </p:sp>
-      <p:sp>
-        <p:nvSpPr>
-          <p:cNvPr id="22" name="Proof 4 link"/>
-          <p:cNvSpPr txBox="1"/>
-          <p:nvPr/>
-        </p:nvSpPr>
-        <p:spPr>
-          <a:xfrm>
-            <a:off x="1325880" y="5257800"/>
-            <a:ext cx="5120640" cy="347472"/>
-          </a:xfrm>
-          <a:prstGeom prst="rect">
-            <a:avLst/>
-          </a:prstGeom>
-          <a:noFill/>
-          <a:ln/>
-        </p:spPr>
-        <p:txBody>
-          <a:bodyPr wrap="square" lIns="0" tIns="0" rIns="0" bIns="0" rtlCol="0" anchor="t"/>
-          <a:lstStyle/>
-          <a:p>
-            <a:pPr indent="0" marL="0">
-              <a:buNone/>
-            </a:pPr>
-            <a:r>
-              <a:rPr lang="en-US" sz="1400" u="sng" dirty="0">
-                <a:solidFill>
-                  <a:schemeClr val="accent6"/>
-                </a:solidFill>
-                <a:hlinkClick r:id="rId4" invalidUrl="" action="" tgtFrame="" tooltip="" history="1" highlightClick="0" endSnd="0">
-                  <a:extLst>
-                    <a:ext uri="{A12FA001-AC4F-418D-AE19-62706E023703}">
-                      <ahyp:hlinkClr xmlns:ahyp="http://schemas.microsoft.com/office/drawing/2018/hyperlinkcolor" val="tx"/>
-                    </a:ext>
-                  </a:extLst>
-                </a:hlinkClick>
-              </a:rPr>
-              <a:t>github.com/ch-lukas/salesforce-process-intelligence</a:t>
-            </a:r>
-            <a:endParaRPr lang="en-US" sz="1400" dirty="0"/>
-          </a:p>
-        </p:txBody>
-      </p:sp>
-      <p:sp>
-        <p:nvSpPr>
-          <p:cNvPr id="23" name="Screenshot frame"/>
-          <p:cNvSpPr/>
-          <p:nvPr/>
-        </p:nvSpPr>
-        <p:spPr>
-          <a:xfrm>
-            <a:off x="6903720" y="1371600"/>
-            <a:ext cx="4802925" cy="4434840"/>
-          </a:xfrm>
-          <a:prstGeom prst="rect">
-            <a:avLst/>
-          </a:prstGeom>
-          <a:solidFill>
-            <a:schemeClr val="bg1"/>
-          </a:solidFill>
-          <a:ln w="12700">
-            <a:solidFill>
-              <a:schemeClr val="accent3"/>
-            </a:solidFill>
-            <a:prstDash val="solid"/>
-          </a:ln>
-        </p:spPr>
-      </p:sp>
-      <p:pic>
-        <p:nvPicPr>
-          <p:cNvPr id="24" name="Value case screenshot" descr="Value case one-pager on the hosted site">    </p:cNvPr>
-          <p:cNvPicPr>
-            <a:picLocks noChangeAspect="1"/>
-          </p:cNvPicPr>
-          <p:nvPr/>
-        </p:nvPicPr>
-        <p:blipFill>
-          <a:blip r:embed="rId5"/>
-          <a:stretch>
-            <a:fillRect/>
-          </a:stretch>
-        </p:blipFill>
-        <p:spPr>
-          <a:xfrm>
-            <a:off x="6949440" y="1417320"/>
-            <a:ext cx="4711485" cy="4343400"/>
-          </a:xfrm>
-          <a:prstGeom prst="rect">
-            <a:avLst/>
-          </a:prstGeom>
-        </p:spPr>
-      </p:pic>
-      <p:sp>
-        <p:nvSpPr>
-          <p:cNvPr id="25" name="Slide Number Placeholder 0"/>
-          <p:cNvSpPr>
-            <a:spLocks noGrp="1"/>
-          </p:cNvSpPr>
-          <p:nvPr>
-            <p:ph type="sldNum" sz="quarter" idx="4294967295"/>
-          </p:nvPr>
-        </p:nvSpPr>
-        <p:spPr>
-          <a:xfrm>
-            <a:off x="11155680" y="6400800"/>
-            <a:ext cx="457200" cy="274320"/>
-          </a:xfrm>
-          <a:prstGeom prst="rect">
-            <a:avLst/>
-          </a:prstGeom>
-          <a:extLst>
-            <a:ext uri="{C572A759-6A51-4108-AA02-DFA0A04FC94B}">
-              <ma14:wrappingTextBoxFlag xmlns:ma14="http://schemas.microsoft.com/office/mac/drawingml/2011/main" val="0"/>
-            </a:ext>
-          </a:extLst>
-        </p:spPr>
-        <p:txBody>
-          <a:bodyPr/>
-          <a:lstStyle>
-            <a:lvl1pPr>
-              <a:defRPr sz="1000">
-                <a:solidFill>
-                  <a:schemeClr val="accent6"/>
-                </a:solidFill>
-              </a:defRPr>
-            </a:lvl1pPr>
-          </a:lstStyle>
-          <a:p>
-            <a:pPr algn="r"/>
-            <a:fld id="{F7021451-1387-4CA6-816F-3879F97B5CBC}" type="slidenum">
-              <a:rPr b="0" lang="en-US"/>
-              <a:t>7</a:t>
-            </a:fld>
-            <a:endParaRPr lang="en-US"/>
-          </a:p>
-        </p:txBody>
-      </p:sp>
-    </p:spTree>
-  </p:cSld>
-  <p:clrMapOvr>
-    <a:masterClrMapping/>
-  </p:clrMapOvr>
-</p:sld>
-</file>
-
-<file path=ppt/slides/slide8.xml><?xml version="1.0" encoding="utf-8"?>
-<p:sld xmlns:a="http://schemas.openxmlformats.org/drawingml/2006/main" xmlns:r="http://schemas.openxmlformats.org/officeDocument/2006/relationships" xmlns:p="http://schemas.openxmlformats.org/presentationml/2006/main">
-  <p:cSld name="Slide 8">
     <p:spTree>
       <p:nvGrpSpPr>
         <p:cNvPr id="1" name=""/>

</xml_diff>

<commit_message>
Deck: add clickable live dashboard link to the Discover slide
Co-Authored-By: Claude Opus 5.5 <noreply@anthropic.com>
</commit_message>
<xml_diff>
--- a/deck/salesforce-process-intelligence.pptx
+++ b/deck/salesforce-process-intelligence.pptx
@@ -114,26 +114,26 @@
   <p:extLst>
     <p:ext uri="{521415D9-36F7-43E2-AB2F-B90AF26B5E84}">
       <p14:sectionLst xmlns:p14="http://schemas.microsoft.com/office/powerpoint/2010/main">
-        <p14:section name="Opening" id="{d5783a8d-0375-479f-66a9-711c76928298}">
+        <p14:section name="Opening" id="{b050dd30-102d-29fc-b4ae-9b2030b869c0}">
           <p14:sldIdLst>
             <p14:sldId id="256"/>
             <p14:sldId id="257"/>
             <p14:sldId id="258"/>
           </p14:sldIdLst>
         </p14:section>
-        <p14:section name="Evidence" id="{745848bb-1833-4927-b61a-18bd3a33a0ee}">
+        <p14:section name="Evidence" id="{d2ec7e79-e8ef-e849-ad28-09df078927b7}">
           <p14:sldIdLst>
             <p14:sldId id="259"/>
             <p14:sldId id="260"/>
           </p14:sldIdLst>
         </p14:section>
-        <p14:section name="Value" id="{917a4510-0ac2-e60e-6387-7cd41e3296ba}">
+        <p14:section name="Value" id="{29e77a92-fce9-1b59-75ee-a1d313e0ef2f}">
           <p14:sldIdLst>
             <p14:sldId id="261"/>
             <p14:sldId id="262"/>
           </p14:sldIdLst>
         </p14:section>
-        <p14:section name="Close" id="{94860cf0-d90a-442e-6da5-05e8683e92f1}">
+        <p14:section name="Close" id="{5999a4a6-a7f4-b100-9ef8-d364f4755a58}">
           <p14:sldIdLst>
             <p14:sldId id="263"/>
           </p14:sldIdLst>
@@ -5173,7 +5173,7 @@
         </p:nvSpPr>
         <p:spPr>
           <a:xfrm>
-            <a:off x="548640" y="1508760"/>
+            <a:off x="548640" y="1371600"/>
             <a:ext cx="2651760" cy="822960"/>
           </a:xfrm>
           <a:prstGeom prst="rect">
@@ -5209,7 +5209,7 @@
         </p:nvSpPr>
         <p:spPr>
           <a:xfrm>
-            <a:off x="3291840" y="1508760"/>
+            <a:off x="3291840" y="1371600"/>
             <a:ext cx="3566160" cy="822960"/>
           </a:xfrm>
           <a:prstGeom prst="rect">
@@ -5245,7 +5245,7 @@
         </p:nvSpPr>
         <p:spPr>
           <a:xfrm>
-            <a:off x="548640" y="2926080"/>
+            <a:off x="548640" y="2560320"/>
             <a:ext cx="2651760" cy="822960"/>
           </a:xfrm>
           <a:prstGeom prst="rect">
@@ -5281,7 +5281,7 @@
         </p:nvSpPr>
         <p:spPr>
           <a:xfrm>
-            <a:off x="3291840" y="2926080"/>
+            <a:off x="3291840" y="2560320"/>
             <a:ext cx="3566160" cy="822960"/>
           </a:xfrm>
           <a:prstGeom prst="rect">
@@ -5317,7 +5317,7 @@
         </p:nvSpPr>
         <p:spPr>
           <a:xfrm>
-            <a:off x="548640" y="4343400"/>
+            <a:off x="548640" y="3749040"/>
             <a:ext cx="2651760" cy="822960"/>
           </a:xfrm>
           <a:prstGeom prst="rect">
@@ -5353,7 +5353,7 @@
         </p:nvSpPr>
         <p:spPr>
           <a:xfrm>
-            <a:off x="3291840" y="4343400"/>
+            <a:off x="3291840" y="3749040"/>
             <a:ext cx="3566160" cy="822960"/>
           </a:xfrm>
           <a:prstGeom prst="rect">
@@ -5389,8 +5389,8 @@
         </p:nvSpPr>
         <p:spPr>
           <a:xfrm>
-            <a:off x="548640" y="5715000"/>
-            <a:ext cx="6309360" cy="457200"/>
+            <a:off x="548640" y="4892040"/>
+            <a:ext cx="6309360" cy="411480"/>
           </a:xfrm>
           <a:prstGeom prst="rect">
             <a:avLst/>
@@ -5419,7 +5419,69 @@
       </p:sp>
       <p:sp>
         <p:nvSpPr>
-          <p:cNvPr id="10" name="Map frame"/>
+          <p:cNvPr id="10" name="Dashboard link"/>
+          <p:cNvSpPr/>
+          <p:nvPr/>
+        </p:nvSpPr>
+        <p:spPr>
+          <a:xfrm>
+            <a:off x="548640" y="5486400"/>
+            <a:ext cx="6309360" cy="548640"/>
+          </a:xfrm>
+          <a:prstGeom prst="roundRect">
+            <a:avLst>
+              <a:gd name="adj" fmla="val 25000"/>
+            </a:avLst>
+          </a:prstGeom>
+          <a:solidFill>
+            <a:schemeClr val="accent3"/>
+          </a:solidFill>
+          <a:ln w="19050">
+            <a:solidFill>
+              <a:schemeClr val="accent1"/>
+            </a:solidFill>
+          </a:ln>
+        </p:spPr>
+        <p:txBody>
+          <a:bodyPr wrap="square" lIns="1016" tIns="1016" rIns="1016" bIns="1016" rtlCol="0" anchor="ctr"/>
+          <a:lstStyle/>
+          <a:p>
+            <a:pPr algn="ctr" indent="0" marL="0">
+              <a:buNone/>
+            </a:pPr>
+            <a:r>
+              <a:rPr lang="en-US" sz="1400" b="1" dirty="0">
+                <a:solidFill>
+                  <a:schemeClr val="tx2"/>
+                </a:solidFill>
+              </a:rPr>
+              <a:t>Live process map:  </a:t>
+            </a:r>
+            <a:pPr algn="ctr" indent="0" marL="0">
+              <a:buNone/>
+            </a:pPr>
+            <a:r>
+              <a:rPr lang="en-US" sz="1400" b="1" u="sng" dirty="0">
+                <a:solidFill>
+                  <a:srgbClr val="000000"/>
+                </a:solidFill>
+                <a:hlinkClick r:id="rId1" invalidUrl="" action="" tgtFrame="" tooltip="Open the live dashboard" history="1" highlightClick="0" endSnd="0">
+                  <a:extLst>
+                    <a:ext uri="{A12FA001-AC4F-418D-AE19-62706E023703}">
+                      <ahyp:hlinkClr xmlns:ahyp="http://schemas.microsoft.com/office/drawing/2018/hyperlinkcolor" val="tx"/>
+                    </a:ext>
+                  </a:extLst>
+                </a:hlinkClick>
+              </a:rPr>
+              <a:t>salesforce-process-intelligence.vercel.app</a:t>
+            </a:r>
+            <a:endParaRPr lang="en-US" sz="1400" dirty="0"/>
+          </a:p>
+        </p:txBody>
+      </p:sp>
+      <p:sp>
+        <p:nvSpPr>
+          <p:cNvPr id="11" name="Map frame"/>
           <p:cNvSpPr/>
           <p:nvPr/>
         </p:nvSpPr>
@@ -5444,14 +5506,14 @@
       </p:sp>
       <p:pic>
         <p:nvPicPr>
-          <p:cNvPr id="11" name="Process map" descr="Process map from the hosted dashboard">    </p:cNvPr>
+          <p:cNvPr id="12" name="Process map" descr="Process map from the hosted dashboard">    </p:cNvPr>
           <p:cNvPicPr>
             <a:picLocks noChangeAspect="1"/>
           </p:cNvPicPr>
           <p:nvPr/>
         </p:nvPicPr>
         <p:blipFill>
-          <a:blip r:embed="rId1"/>
+          <a:blip r:embed="rId2"/>
           <a:stretch>
             <a:fillRect/>
           </a:stretch>

</xml_diff>

<commit_message>
Apply second review; rename site to Process Intelligence
- Bookings, not revenue: 'Accelerate bookings', 'modelled incremental
  bookings', Finance validates bookings with revenue recognition separate
- Overlap rule: count each deal win once across all three opportunities
- 50% capture made operational: cut re-quotes 19.2% -> 9.6%, as a
  readable scenario line; stage named Negotiation/Review
- Approval takeaway shows its win-rate association; 'skipped
  Qualification' replaces 'unqualified'; slide 8 ends on a decision
  with an illustrative schedule
- Same wording on the site; site name is now Process Intelligence

Co-Authored-By: Claude Opus 5.5 <noreply@anthropic.com>
</commit_message>
<xml_diff>
--- a/deck/salesforce-process-intelligence.pptx
+++ b/deck/salesforce-process-intelligence.pptx
@@ -114,26 +114,26 @@
   <p:extLst>
     <p:ext uri="{521415D9-36F7-43E2-AB2F-B90AF26B5E84}">
       <p14:sectionLst xmlns:p14="http://schemas.microsoft.com/office/powerpoint/2010/main">
-        <p14:section name="Opening" id="{94d81707-862b-126d-e9c7-f6783de64c0a}">
+        <p14:section name="Opening" id="{e22d0cf0-c5bb-235e-d3ce-c70c36e13009}">
           <p14:sldIdLst>
             <p14:sldId id="256"/>
             <p14:sldId id="257"/>
             <p14:sldId id="258"/>
           </p14:sldIdLst>
         </p14:section>
-        <p14:section name="Evidence" id="{cef6550d-f6b9-adcb-d1d5-0268788250c3}">
+        <p14:section name="Evidence" id="{745d9065-1b18-79d9-b8ce-1c158850e20d}">
           <p14:sldIdLst>
             <p14:sldId id="259"/>
             <p14:sldId id="260"/>
           </p14:sldIdLst>
         </p14:section>
-        <p14:section name="Value" id="{a4da9e89-2ef9-8cff-a232-505eb71b89e1}">
+        <p14:section name="Value" id="{464afebc-1619-f126-9fe5-cc8a539dd4d4}">
           <p14:sldIdLst>
             <p14:sldId id="261"/>
             <p14:sldId id="262"/>
           </p14:sldIdLst>
         </p14:section>
-        <p14:section name="Close" id="{3429c88f-02b5-10ec-d6d9-02a8443e999f}">
+        <p14:section name="Close" id="{1892500d-cf51-4285-0c47-ff2709800d16}">
           <p14:sldIdLst>
             <p14:sldId id="263"/>
           </p14:sldIdLst>
@@ -1915,7 +1915,7 @@
           <a:p>
             <a:r>
               <a:rPr lang="en-US" dirty="0"/>
-              <a:t>This follows my value framing format: challenge, root cause, solution, then a multiplicative value chain. The customer owns the improvement assumption; we own the evidence. Root cause is labelled 'to capture' because it needs reason codes the CRM doesn't hold yet. The chain multiplies to the displayed value using unrounded inputs.</a:t>
+              <a:t>This follows my value framing format: challenge, root cause, solution, then a multiplicative value chain. The customer owns the improvement assumption; we own the evidence. Root cause is labelled 'to capture' because it needs reason codes the CRM doesn't hold yet. The chain multiplies to the displayed value using unrounded inputs. Annualised over the 10.4-month event window as an illustrative run rate; the win-rate gap is an association among deals that reached Negotiation/Review.</a:t>
             </a:r>
             <a:endParaRPr lang="en-US" dirty="0"/>
           </a:p>
@@ -3285,7 +3285,7 @@
                   <a:schemeClr val="bg1"/>
                 </a:solidFill>
               </a:rPr>
-              <a:t>Accelerate revenue</a:t>
+              <a:t>Accelerate bookings</a:t>
             </a:r>
             <a:endParaRPr lang="en-US" sz="1200" dirty="0"/>
           </a:p>
@@ -5397,7 +5397,7 @@
                   <a:schemeClr val="tx2"/>
                 </a:solidFill>
               </a:rPr>
-              <a:t>median EMEA approval wait, the slowest hand-off</a:t>
+              <a:t>median EMEA discount approval, the slowest region</a:t>
             </a:r>
             <a:endParaRPr lang="en-US" sz="1800" dirty="0"/>
           </a:p>
@@ -5715,7 +5715,7 @@
                   <a:schemeClr val="tx2"/>
                 </a:solidFill>
               </a:rPr>
-              <a:t>EMEA approvals take 5.8 days longer than the fastest region (103 EMEA approvals).</a:t>
+              <a:t>5.8 days slower than the fastest region. EMEA deals waiting &gt;7 days won 47% vs 54% (n = 51 vs 52).</a:t>
             </a:r>
             <a:endParaRPr lang="en-US" sz="1400" dirty="0"/>
           </a:p>
@@ -6452,7 +6452,7 @@
                             <a:schemeClr val="tx1"/>
                           </a:solidFill>
                         </a:rPr>
-                        <a:t>Accelerate revenue</a:t>
+                        <a:t>Accelerate bookings</a:t>
                       </a:r>
                       <a:endParaRPr lang="en-US" sz="1400" dirty="0"/>
                     </a:p>
@@ -8235,7 +8235,7 @@
                   <a:schemeClr val="tx1"/>
                 </a:solidFill>
               </a:rPr>
-              <a:t>22 deals are both re-quoted and unqualified, 7 re-quoted with slow approvals, 5 unqualified with slow approvals.</a:t>
+              <a:t>22 deals were re-quoted and skipped Qualification, 7 were re-quoted with slow approvals, 5 skipped Qualification with slow approvals.</a:t>
             </a:r>
             <a:endParaRPr lang="en-US" sz="1400" dirty="0"/>
           </a:p>
@@ -8263,7 +8263,7 @@
                   <a:schemeClr val="accent6"/>
                 </a:solidFill>
               </a:rPr>
-              <a:t>So the total is gross: incremental wins must be counted once per opportunity before anything is committed.</a:t>
+              <a:t>So the total is gross: count each incremental deal win once across all three improvement opportunities before committing.</a:t>
             </a:r>
             <a:endParaRPr lang="en-US" sz="1400" dirty="0"/>
           </a:p>
@@ -8717,7 +8717,7 @@
                   <a:schemeClr val="tx2"/>
                 </a:solidFill>
               </a:rPr>
-              <a:t>Time frame: 2025-10 to 2026-09   ·   Deals that reached Negotiate   ·   Proposed owner: VP Revenue Operations   ·   Simulated data</a:t>
+              <a:t>2025-10 to 2026-09, annualised  ·  Reached Negotiation/Review  ·  Amount = bookings  ·  Proposed owner: VP Revenue Ops  ·  Simulated data</a:t>
             </a:r>
             <a:endParaRPr lang="en-US" sz="1200" dirty="0"/>
           </a:p>
@@ -9609,7 +9609,7 @@
                   <a:schemeClr val="tx2"/>
                 </a:solidFill>
               </a:rPr>
-              <a:t>Scenario capture</a:t>
+              <a:t>Re-quotes prevented</a:t>
             </a:r>
             <a:endParaRPr lang="en-US" sz="1200" dirty="0"/>
           </a:p>
@@ -9770,12 +9770,12 @@
               <a:buNone/>
             </a:pPr>
             <a:r>
-              <a:rPr lang="en-US" sz="1200" dirty="0">
+              <a:rPr lang="en-US" sz="1100" dirty="0">
                 <a:solidFill>
                   <a:schemeClr val="accent3"/>
                 </a:solidFill>
               </a:rPr>
-              <a:t>modelled upside p.a.</a:t>
+              <a:t>modelled incremental bookings p.a.</a:t>
             </a:r>
             <a:endParaRPr lang="en-US" sz="1400" dirty="0"/>
           </a:p>
@@ -9783,14 +9783,14 @@
       </p:sp>
       <p:sp>
         <p:nvSpPr>
-          <p:cNvPr id="33" name="Assumptions"/>
+          <p:cNvPr id="33" name="Scenario"/>
           <p:cNvSpPr txBox="1"/>
           <p:nvPr/>
         </p:nvSpPr>
         <p:spPr>
           <a:xfrm>
-            <a:off x="548640" y="5669280"/>
-            <a:ext cx="11064240" cy="457200"/>
+            <a:off x="548640" y="5596128"/>
+            <a:ext cx="11064240" cy="685800"/>
           </a:xfrm>
           <a:prstGeom prst="rect">
             <a:avLst/>
@@ -9806,14 +9806,25 @@
               <a:buNone/>
             </a:pPr>
             <a:r>
-              <a:rPr lang="en-US" sz="1100" i="1" dirty="0">
-                <a:solidFill>
-                  <a:schemeClr val="accent6"/>
-                </a:solidFill>
-              </a:rPr>
-              <a:t>Assumptions: simulated data, annualised over the 10.4-month event window (illustrative run rate); Amount = opportunity bookings; win-rate gap is an association among deals that reached Negotiate; 50% capture is a scenario. Tracking: share re-quoted vs a frozen baseline of 19.2%, win rate vs a comparison group; Finance validates realized revenue.</a:t>
-            </a:r>
-            <a:endParaRPr lang="en-US" sz="1100" dirty="0"/>
+              <a:rPr lang="en-US" sz="1400" b="1" dirty="0">
+                <a:solidFill>
+                  <a:schemeClr val="tx2"/>
+                </a:solidFill>
+              </a:rPr>
+              <a:t>Scenario to test: </a:t>
+            </a:r>
+            <a:pPr indent="0" marL="0">
+              <a:buNone/>
+            </a:pPr>
+            <a:r>
+              <a:rPr lang="en-US" sz="1400" dirty="0">
+                <a:solidFill>
+                  <a:schemeClr val="tx1"/>
+                </a:solidFill>
+              </a:rPr>
+              <a:t>cut re-quotes from 19.2% to 9.6% of negotiated deals, assuming each prevented re-quote recovers the 17.5-point win-rate gap. Measured against a comparison group; Finance validates incremental bookings, revenue recognition assessed separately.</a:t>
+            </a:r>
+            <a:endParaRPr lang="en-US" sz="1400" dirty="0"/>
           </a:p>
         </p:txBody>
       </p:sp>
@@ -10339,7 +10350,90 @@
       </p:sp>
       <p:sp>
         <p:nvSpPr>
-          <p:cNvPr id="16" name="Closing contact"/>
+          <p:cNvPr id="16" name="Schedule note"/>
+          <p:cNvSpPr txBox="1"/>
+          <p:nvPr/>
+        </p:nvSpPr>
+        <p:spPr>
+          <a:xfrm>
+            <a:off x="731520" y="4343400"/>
+            <a:ext cx="7315200" cy="274320"/>
+          </a:xfrm>
+          <a:prstGeom prst="rect">
+            <a:avLst/>
+          </a:prstGeom>
+          <a:noFill/>
+          <a:ln/>
+        </p:spPr>
+        <p:txBody>
+          <a:bodyPr wrap="square" lIns="0" tIns="0" rIns="0" bIns="0" rtlCol="0" anchor="t"/>
+          <a:lstStyle/>
+          <a:p>
+            <a:pPr indent="0" marL="0">
+              <a:buNone/>
+            </a:pPr>
+            <a:r>
+              <a:rPr lang="en-US" sz="1200" i="1" dirty="0">
+                <a:solidFill>
+                  <a:schemeClr val="accent3"/>
+                </a:solidFill>
+              </a:rPr>
+              <a:t>Illustrative schedule; owners are proposed.</a:t>
+            </a:r>
+            <a:endParaRPr lang="en-US" sz="1200" dirty="0"/>
+          </a:p>
+        </p:txBody>
+      </p:sp>
+      <p:sp>
+        <p:nvSpPr>
+          <p:cNvPr id="17" name="Decision"/>
+          <p:cNvSpPr txBox="1"/>
+          <p:nvPr/>
+        </p:nvSpPr>
+        <p:spPr>
+          <a:xfrm>
+            <a:off x="731520" y="4800600"/>
+            <a:ext cx="8412480" cy="548640"/>
+          </a:xfrm>
+          <a:prstGeom prst="rect">
+            <a:avLst/>
+          </a:prstGeom>
+          <a:noFill/>
+          <a:ln/>
+        </p:spPr>
+        <p:txBody>
+          <a:bodyPr wrap="square" lIns="0" tIns="0" rIns="0" bIns="0" rtlCol="0" anchor="t"/>
+          <a:lstStyle/>
+          <a:p>
+            <a:pPr indent="0" marL="0">
+              <a:buNone/>
+            </a:pPr>
+            <a:r>
+              <a:rPr lang="en-US" sz="1800" b="1" dirty="0">
+                <a:solidFill>
+                  <a:schemeClr val="bg1"/>
+                </a:solidFill>
+              </a:rPr>
+              <a:t>Decision today: </a:t>
+            </a:r>
+            <a:pPr indent="0" marL="0">
+              <a:buNone/>
+            </a:pPr>
+            <a:r>
+              <a:rPr lang="en-US" sz="1800" dirty="0">
+                <a:solidFill>
+                  <a:schemeClr val="accent3"/>
+                </a:solidFill>
+              </a:rPr>
+              <a:t>agree the validation scope, named owners and pilot success criteria.</a:t>
+            </a:r>
+            <a:endParaRPr lang="en-US" sz="1800" dirty="0"/>
+          </a:p>
+        </p:txBody>
+      </p:sp>
+      <p:sp>
+        <p:nvSpPr>
+          <p:cNvPr id="18" name="Closing contact"/>
           <p:cNvSpPr txBox="1"/>
           <p:nvPr/>
         </p:nvSpPr>

</xml_diff>